<commit_message>
Update presentation files for Weeks 1 to 6; remove obsolete templates
</commit_message>
<xml_diff>
--- a/Woche_1_Refresher_CleanCode/01_Clean_Code_v01.pptx
+++ b/Woche_1_Refresher_CleanCode/01_Clean_Code_v01.pptx
@@ -4,6 +4,9 @@
   <p:sldMasterIdLst>
     <p:sldMasterId id="2147483750" r:id="rId1"/>
   </p:sldMasterIdLst>
+  <p:handoutMasterIdLst>
+    <p:handoutMasterId r:id="rId36"/>
+  </p:handoutMasterIdLst>
   <p:sldIdLst>
     <p:sldId id="312" r:id="rId2"/>
     <p:sldId id="313" r:id="rId3"/>
@@ -156,2540 +159,166 @@
 </p:presentation>
 </file>
 
-<file path=ppt/revisionInfo.xml><?xml version="1.0" encoding="utf-8"?>
-<p1510:revInfo xmlns:a="http://schemas.openxmlformats.org/drawingml/2006/main" xmlns:r="http://schemas.openxmlformats.org/officeDocument/2006/relationships" xmlns:p1510="http://schemas.microsoft.com/office/powerpoint/2015/10/main">
-  <p1510:revLst>
-    <p1510:client id="{07985352-70BD-4C55-94CD-D8AB9AF4ECAE}" v="26" dt="2026-03-18T17:12:24.161"/>
-    <p1510:client id="{8FD8E9B9-19E4-45DE-B338-CC800BA76FB7}" v="1" dt="2026-03-18T17:27:52.992"/>
-    <p1510:client id="{B7FDA16B-6CD8-46DA-B9AA-DBE7077D826F}" v="2" dt="2026-03-18T17:27:25.091"/>
-  </p1510:revLst>
-</p1510:revInfo>
-</file>
-
 <file path=ppt/changesInfos/changesInfo1.xml><?xml version="1.0" encoding="utf-8"?>
 <pc:chgInfo xmlns:a="http://schemas.openxmlformats.org/drawingml/2006/main" xmlns:r="http://schemas.openxmlformats.org/officeDocument/2006/relationships" xmlns:ac="http://schemas.microsoft.com/office/drawing/2013/main/command" xmlns:pc="http://schemas.microsoft.com/office/powerpoint/2013/main/command">
   <pc:docChgLst>
-    <pc:chgData name="Peter Bernhardt" userId="f2333933-0b12-4d6e-972f-f87625423892" providerId="ADAL" clId="{54BAB7D7-C378-4C4A-B0F8-9DF09AB8FC9C}"/>
-    <pc:docChg chg="undo custSel addSld delSld modSld modMainMaster">
-      <pc:chgData name="Peter Bernhardt" userId="f2333933-0b12-4d6e-972f-f87625423892" providerId="ADAL" clId="{54BAB7D7-C378-4C4A-B0F8-9DF09AB8FC9C}" dt="2026-03-18T17:52:00.811" v="796" actId="14100"/>
+    <pc:chgData name="Peter Bernhardt" userId="f2333933-0b12-4d6e-972f-f87625423892" providerId="ADAL" clId="{2C628E33-589C-449E-BBA5-ED05E3E5CC01}"/>
+    <pc:docChg chg="custSel modHandout">
+      <pc:chgData name="Peter Bernhardt" userId="f2333933-0b12-4d6e-972f-f87625423892" providerId="ADAL" clId="{2C628E33-589C-449E-BBA5-ED05E3E5CC01}" dt="2026-04-21T11:31:32.408" v="0" actId="478"/>
       <pc:docMkLst>
         <pc:docMk/>
       </pc:docMkLst>
-      <pc:sldChg chg="addSp delSp modSp del mod chgLayout">
-        <pc:chgData name="Peter Bernhardt" userId="f2333933-0b12-4d6e-972f-f87625423892" providerId="ADAL" clId="{54BAB7D7-C378-4C4A-B0F8-9DF09AB8FC9C}" dt="2026-03-18T17:27:59.585" v="473" actId="47"/>
-        <pc:sldMkLst>
-          <pc:docMk/>
-          <pc:sldMk cId="0" sldId="256"/>
-        </pc:sldMkLst>
-        <pc:spChg chg="mod ord">
-          <ac:chgData name="Peter Bernhardt" userId="f2333933-0b12-4d6e-972f-f87625423892" providerId="ADAL" clId="{54BAB7D7-C378-4C4A-B0F8-9DF09AB8FC9C}" dt="2026-03-18T17:15:04.664" v="428" actId="27636"/>
-          <ac:spMkLst>
-            <pc:docMk/>
-            <pc:sldMk cId="0" sldId="256"/>
-            <ac:spMk id="2" creationId="{00000000-0000-0000-0000-000000000000}"/>
-          </ac:spMkLst>
-        </pc:spChg>
-        <pc:spChg chg="mod ord">
-          <ac:chgData name="Peter Bernhardt" userId="f2333933-0b12-4d6e-972f-f87625423892" providerId="ADAL" clId="{54BAB7D7-C378-4C4A-B0F8-9DF09AB8FC9C}" dt="2026-03-18T17:15:14.733" v="430" actId="20577"/>
-          <ac:spMkLst>
-            <pc:docMk/>
-            <pc:sldMk cId="0" sldId="256"/>
-            <ac:spMk id="3" creationId="{00000000-0000-0000-0000-000000000000}"/>
-          </ac:spMkLst>
-        </pc:spChg>
-        <pc:spChg chg="mod ord">
-          <ac:chgData name="Peter Bernhardt" userId="f2333933-0b12-4d6e-972f-f87625423892" providerId="ADAL" clId="{54BAB7D7-C378-4C4A-B0F8-9DF09AB8FC9C}" dt="2026-03-18T17:15:04.648" v="426" actId="6264"/>
-          <ac:spMkLst>
-            <pc:docMk/>
-            <pc:sldMk cId="0" sldId="256"/>
-            <ac:spMk id="4" creationId="{00000000-0000-0000-0000-000000000000}"/>
-          </ac:spMkLst>
-        </pc:spChg>
-        <pc:spChg chg="add del mod">
-          <ac:chgData name="Peter Bernhardt" userId="f2333933-0b12-4d6e-972f-f87625423892" providerId="ADAL" clId="{54BAB7D7-C378-4C4A-B0F8-9DF09AB8FC9C}" dt="2026-03-18T17:15:04.648" v="426" actId="6264"/>
-          <ac:spMkLst>
-            <pc:docMk/>
-            <pc:sldMk cId="0" sldId="256"/>
-            <ac:spMk id="5" creationId="{864F6E31-2BAA-17E0-3806-D6A2E0187B87}"/>
-          </ac:spMkLst>
-        </pc:spChg>
-        <pc:spChg chg="add del mod">
-          <ac:chgData name="Peter Bernhardt" userId="f2333933-0b12-4d6e-972f-f87625423892" providerId="ADAL" clId="{54BAB7D7-C378-4C4A-B0F8-9DF09AB8FC9C}" dt="2026-03-18T17:15:04.648" v="426" actId="6264"/>
-          <ac:spMkLst>
-            <pc:docMk/>
-            <pc:sldMk cId="0" sldId="256"/>
-            <ac:spMk id="6" creationId="{1373D5EF-DAC2-0EF9-BEB5-5E7CD8C1B191}"/>
-          </ac:spMkLst>
-        </pc:spChg>
-        <pc:spChg chg="add del mod">
-          <ac:chgData name="Peter Bernhardt" userId="f2333933-0b12-4d6e-972f-f87625423892" providerId="ADAL" clId="{54BAB7D7-C378-4C4A-B0F8-9DF09AB8FC9C}" dt="2026-03-18T17:15:04.648" v="426" actId="6264"/>
-          <ac:spMkLst>
-            <pc:docMk/>
-            <pc:sldMk cId="0" sldId="256"/>
-            <ac:spMk id="7" creationId="{D6BD83D8-C692-9D2F-2278-6266ACF55A74}"/>
-          </ac:spMkLst>
-        </pc:spChg>
-      </pc:sldChg>
-      <pc:sldChg chg="modSp del mod">
-        <pc:chgData name="Peter Bernhardt" userId="f2333933-0b12-4d6e-972f-f87625423892" providerId="ADAL" clId="{54BAB7D7-C378-4C4A-B0F8-9DF09AB8FC9C}" dt="2026-03-18T17:27:59.585" v="473" actId="47"/>
-        <pc:sldMkLst>
-          <pc:docMk/>
-          <pc:sldMk cId="0" sldId="257"/>
-        </pc:sldMkLst>
-        <pc:spChg chg="mod">
-          <ac:chgData name="Peter Bernhardt" userId="f2333933-0b12-4d6e-972f-f87625423892" providerId="ADAL" clId="{54BAB7D7-C378-4C4A-B0F8-9DF09AB8FC9C}" dt="2026-03-18T16:39:28.101" v="79" actId="790"/>
-          <ac:spMkLst>
-            <pc:docMk/>
-            <pc:sldMk cId="0" sldId="257"/>
-            <ac:spMk id="2" creationId="{00000000-0000-0000-0000-000000000000}"/>
-          </ac:spMkLst>
-        </pc:spChg>
-        <pc:spChg chg="mod">
-          <ac:chgData name="Peter Bernhardt" userId="f2333933-0b12-4d6e-972f-f87625423892" providerId="ADAL" clId="{54BAB7D7-C378-4C4A-B0F8-9DF09AB8FC9C}" dt="2026-03-18T16:39:28.229" v="81" actId="27636"/>
-          <ac:spMkLst>
-            <pc:docMk/>
-            <pc:sldMk cId="0" sldId="257"/>
-            <ac:spMk id="3" creationId="{00000000-0000-0000-0000-000000000000}"/>
-          </ac:spMkLst>
-        </pc:spChg>
-      </pc:sldChg>
-      <pc:sldChg chg="modSp del mod">
-        <pc:chgData name="Peter Bernhardt" userId="f2333933-0b12-4d6e-972f-f87625423892" providerId="ADAL" clId="{54BAB7D7-C378-4C4A-B0F8-9DF09AB8FC9C}" dt="2026-03-18T17:27:59.585" v="473" actId="47"/>
-        <pc:sldMkLst>
-          <pc:docMk/>
-          <pc:sldMk cId="0" sldId="258"/>
-        </pc:sldMkLst>
-        <pc:spChg chg="mod">
-          <ac:chgData name="Peter Bernhardt" userId="f2333933-0b12-4d6e-972f-f87625423892" providerId="ADAL" clId="{54BAB7D7-C378-4C4A-B0F8-9DF09AB8FC9C}" dt="2026-03-18T16:39:28.101" v="79" actId="790"/>
-          <ac:spMkLst>
-            <pc:docMk/>
-            <pc:sldMk cId="0" sldId="258"/>
-            <ac:spMk id="2" creationId="{00000000-0000-0000-0000-000000000000}"/>
-          </ac:spMkLst>
-        </pc:spChg>
-        <pc:spChg chg="mod">
-          <ac:chgData name="Peter Bernhardt" userId="f2333933-0b12-4d6e-972f-f87625423892" providerId="ADAL" clId="{54BAB7D7-C378-4C4A-B0F8-9DF09AB8FC9C}" dt="2026-03-18T16:39:28.261" v="82" actId="27636"/>
-          <ac:spMkLst>
-            <pc:docMk/>
-            <pc:sldMk cId="0" sldId="258"/>
-            <ac:spMk id="3" creationId="{00000000-0000-0000-0000-000000000000}"/>
-          </ac:spMkLst>
-        </pc:spChg>
-      </pc:sldChg>
-      <pc:sldChg chg="modSp del mod">
-        <pc:chgData name="Peter Bernhardt" userId="f2333933-0b12-4d6e-972f-f87625423892" providerId="ADAL" clId="{54BAB7D7-C378-4C4A-B0F8-9DF09AB8FC9C}" dt="2026-03-18T17:27:59.585" v="473" actId="47"/>
-        <pc:sldMkLst>
-          <pc:docMk/>
-          <pc:sldMk cId="0" sldId="259"/>
-        </pc:sldMkLst>
-        <pc:spChg chg="mod">
-          <ac:chgData name="Peter Bernhardt" userId="f2333933-0b12-4d6e-972f-f87625423892" providerId="ADAL" clId="{54BAB7D7-C378-4C4A-B0F8-9DF09AB8FC9C}" dt="2026-03-18T16:39:28.101" v="79" actId="790"/>
-          <ac:spMkLst>
-            <pc:docMk/>
-            <pc:sldMk cId="0" sldId="259"/>
-            <ac:spMk id="2" creationId="{00000000-0000-0000-0000-000000000000}"/>
-          </ac:spMkLst>
-        </pc:spChg>
-        <pc:spChg chg="mod">
-          <ac:chgData name="Peter Bernhardt" userId="f2333933-0b12-4d6e-972f-f87625423892" providerId="ADAL" clId="{54BAB7D7-C378-4C4A-B0F8-9DF09AB8FC9C}" dt="2026-03-18T16:39:28.267" v="83" actId="27636"/>
-          <ac:spMkLst>
-            <pc:docMk/>
-            <pc:sldMk cId="0" sldId="259"/>
-            <ac:spMk id="3" creationId="{00000000-0000-0000-0000-000000000000}"/>
-          </ac:spMkLst>
-        </pc:spChg>
-      </pc:sldChg>
-      <pc:sldChg chg="addSp delSp modSp del mod setBg delDesignElem chgLayout">
-        <pc:chgData name="Peter Bernhardt" userId="f2333933-0b12-4d6e-972f-f87625423892" providerId="ADAL" clId="{54BAB7D7-C378-4C4A-B0F8-9DF09AB8FC9C}" dt="2026-03-18T17:27:59.585" v="473" actId="47"/>
-        <pc:sldMkLst>
-          <pc:docMk/>
-          <pc:sldMk cId="0" sldId="260"/>
-        </pc:sldMkLst>
-        <pc:spChg chg="mod ord">
-          <ac:chgData name="Peter Bernhardt" userId="f2333933-0b12-4d6e-972f-f87625423892" providerId="ADAL" clId="{54BAB7D7-C378-4C4A-B0F8-9DF09AB8FC9C}" dt="2026-03-18T17:15:26.880" v="432" actId="14100"/>
-          <ac:spMkLst>
-            <pc:docMk/>
-            <pc:sldMk cId="0" sldId="260"/>
-            <ac:spMk id="2" creationId="{00000000-0000-0000-0000-000000000000}"/>
-          </ac:spMkLst>
-        </pc:spChg>
-        <pc:spChg chg="add del mod ord">
-          <ac:chgData name="Peter Bernhardt" userId="f2333933-0b12-4d6e-972f-f87625423892" providerId="ADAL" clId="{54BAB7D7-C378-4C4A-B0F8-9DF09AB8FC9C}" dt="2026-03-18T16:45:20.814" v="288" actId="700"/>
-          <ac:spMkLst>
-            <pc:docMk/>
-            <pc:sldMk cId="0" sldId="260"/>
-            <ac:spMk id="3" creationId="{15AAAF13-54EE-43B2-D37D-5013DA7AD876}"/>
-          </ac:spMkLst>
-        </pc:spChg>
-        <pc:spChg chg="add del mod ord">
-          <ac:chgData name="Peter Bernhardt" userId="f2333933-0b12-4d6e-972f-f87625423892" providerId="ADAL" clId="{54BAB7D7-C378-4C4A-B0F8-9DF09AB8FC9C}" dt="2026-03-18T16:46:50.036" v="297" actId="700"/>
-          <ac:spMkLst>
-            <pc:docMk/>
-            <pc:sldMk cId="0" sldId="260"/>
-            <ac:spMk id="4" creationId="{2BF60E54-56CF-69C5-C78E-EA7C230DD1A7}"/>
-          </ac:spMkLst>
-        </pc:spChg>
-        <pc:spChg chg="add del mod ord">
-          <ac:chgData name="Peter Bernhardt" userId="f2333933-0b12-4d6e-972f-f87625423892" providerId="ADAL" clId="{54BAB7D7-C378-4C4A-B0F8-9DF09AB8FC9C}" dt="2026-03-18T16:47:08.173" v="301" actId="6264"/>
-          <ac:spMkLst>
-            <pc:docMk/>
-            <pc:sldMk cId="0" sldId="260"/>
-            <ac:spMk id="5" creationId="{460AF33A-DD44-200F-314D-2C0E800840E6}"/>
-          </ac:spMkLst>
-        </pc:spChg>
-        <pc:spChg chg="add del mod">
-          <ac:chgData name="Peter Bernhardt" userId="f2333933-0b12-4d6e-972f-f87625423892" providerId="ADAL" clId="{54BAB7D7-C378-4C4A-B0F8-9DF09AB8FC9C}" dt="2026-03-18T16:47:08.173" v="301" actId="6264"/>
-          <ac:spMkLst>
-            <pc:docMk/>
-            <pc:sldMk cId="0" sldId="260"/>
-            <ac:spMk id="6" creationId="{395C5F83-BD03-5556-D8B2-EAF5435BCDB0}"/>
-          </ac:spMkLst>
-        </pc:spChg>
-        <pc:spChg chg="add del mod ord">
-          <ac:chgData name="Peter Bernhardt" userId="f2333933-0b12-4d6e-972f-f87625423892" providerId="ADAL" clId="{54BAB7D7-C378-4C4A-B0F8-9DF09AB8FC9C}" dt="2026-03-18T17:15:21.818" v="431" actId="6264"/>
-          <ac:spMkLst>
-            <pc:docMk/>
-            <pc:sldMk cId="0" sldId="260"/>
-            <ac:spMk id="7" creationId="{4EC73281-620F-F720-0EBD-2FE38FD221AB}"/>
-          </ac:spMkLst>
-        </pc:spChg>
-        <pc:spChg chg="add del">
-          <ac:chgData name="Peter Bernhardt" userId="f2333933-0b12-4d6e-972f-f87625423892" providerId="ADAL" clId="{54BAB7D7-C378-4C4A-B0F8-9DF09AB8FC9C}" dt="2026-03-18T16:45:20.814" v="288" actId="700"/>
-          <ac:spMkLst>
-            <pc:docMk/>
-            <pc:sldMk cId="0" sldId="260"/>
-            <ac:spMk id="8" creationId="{EB8A1B5F-0801-4AFF-A489-335B6A851FF4}"/>
-          </ac:spMkLst>
-        </pc:spChg>
-        <pc:spChg chg="add del mod">
-          <ac:chgData name="Peter Bernhardt" userId="f2333933-0b12-4d6e-972f-f87625423892" providerId="ADAL" clId="{54BAB7D7-C378-4C4A-B0F8-9DF09AB8FC9C}" dt="2026-03-18T17:15:21.818" v="431" actId="6264"/>
-          <ac:spMkLst>
-            <pc:docMk/>
-            <pc:sldMk cId="0" sldId="260"/>
-            <ac:spMk id="9" creationId="{7311CE1B-E5BD-CF3E-86C3-F754B64230EE}"/>
-          </ac:spMkLst>
-        </pc:spChg>
-        <pc:spChg chg="add del">
-          <ac:chgData name="Peter Bernhardt" userId="f2333933-0b12-4d6e-972f-f87625423892" providerId="ADAL" clId="{54BAB7D7-C378-4C4A-B0F8-9DF09AB8FC9C}" dt="2026-03-18T16:45:20.814" v="288" actId="700"/>
-          <ac:spMkLst>
-            <pc:docMk/>
-            <pc:sldMk cId="0" sldId="260"/>
-            <ac:spMk id="10" creationId="{06201B52-6441-4DBA-BACE-2359775817CE}"/>
-          </ac:spMkLst>
-        </pc:spChg>
-        <pc:spChg chg="add mod ord">
-          <ac:chgData name="Peter Bernhardt" userId="f2333933-0b12-4d6e-972f-f87625423892" providerId="ADAL" clId="{54BAB7D7-C378-4C4A-B0F8-9DF09AB8FC9C}" dt="2026-03-18T17:15:21.818" v="431" actId="6264"/>
-          <ac:spMkLst>
-            <pc:docMk/>
-            <pc:sldMk cId="0" sldId="260"/>
-            <ac:spMk id="11" creationId="{8F3127DF-8214-64CE-298A-497397B6CAB2}"/>
-          </ac:spMkLst>
-        </pc:spChg>
-        <pc:spChg chg="add del">
-          <ac:chgData name="Peter Bernhardt" userId="f2333933-0b12-4d6e-972f-f87625423892" providerId="ADAL" clId="{54BAB7D7-C378-4C4A-B0F8-9DF09AB8FC9C}" dt="2026-03-18T16:45:20.814" v="288" actId="700"/>
-          <ac:spMkLst>
-            <pc:docMk/>
-            <pc:sldMk cId="0" sldId="260"/>
-            <ac:spMk id="14" creationId="{FBDCECDC-EEE3-4128-AA5E-82A8C08796E8}"/>
-          </ac:spMkLst>
-        </pc:spChg>
-        <pc:spChg chg="add del">
-          <ac:chgData name="Peter Bernhardt" userId="f2333933-0b12-4d6e-972f-f87625423892" providerId="ADAL" clId="{54BAB7D7-C378-4C4A-B0F8-9DF09AB8FC9C}" dt="2026-03-18T16:45:20.814" v="288" actId="700"/>
-          <ac:spMkLst>
-            <pc:docMk/>
-            <pc:sldMk cId="0" sldId="260"/>
-            <ac:spMk id="16" creationId="{1F3985C0-E548-44D2-B30E-F3E42DADE133}"/>
-          </ac:spMkLst>
-        </pc:spChg>
-        <pc:spChg chg="add del">
-          <ac:chgData name="Peter Bernhardt" userId="f2333933-0b12-4d6e-972f-f87625423892" providerId="ADAL" clId="{54BAB7D7-C378-4C4A-B0F8-9DF09AB8FC9C}" dt="2026-03-18T16:45:20.814" v="288" actId="700"/>
-          <ac:spMkLst>
-            <pc:docMk/>
-            <pc:sldMk cId="0" sldId="260"/>
-            <ac:spMk id="18" creationId="{4260EDE0-989C-4E16-AF94-F652294D828E}"/>
-          </ac:spMkLst>
-        </pc:spChg>
-        <pc:cxnChg chg="add del">
-          <ac:chgData name="Peter Bernhardt" userId="f2333933-0b12-4d6e-972f-f87625423892" providerId="ADAL" clId="{54BAB7D7-C378-4C4A-B0F8-9DF09AB8FC9C}" dt="2026-03-18T16:45:20.814" v="288" actId="700"/>
-          <ac:cxnSpMkLst>
-            <pc:docMk/>
-            <pc:sldMk cId="0" sldId="260"/>
-            <ac:cxnSpMk id="12" creationId="{89DF3DBB-17DD-4058-A944-5578E18A031E}"/>
-          </ac:cxnSpMkLst>
-        </pc:cxnChg>
-      </pc:sldChg>
-      <pc:sldChg chg="modSp del mod">
-        <pc:chgData name="Peter Bernhardt" userId="f2333933-0b12-4d6e-972f-f87625423892" providerId="ADAL" clId="{54BAB7D7-C378-4C4A-B0F8-9DF09AB8FC9C}" dt="2026-03-18T17:27:59.585" v="473" actId="47"/>
-        <pc:sldMkLst>
-          <pc:docMk/>
-          <pc:sldMk cId="0" sldId="261"/>
-        </pc:sldMkLst>
-        <pc:spChg chg="mod">
-          <ac:chgData name="Peter Bernhardt" userId="f2333933-0b12-4d6e-972f-f87625423892" providerId="ADAL" clId="{54BAB7D7-C378-4C4A-B0F8-9DF09AB8FC9C}" dt="2026-03-18T16:39:28.101" v="79" actId="790"/>
-          <ac:spMkLst>
-            <pc:docMk/>
-            <pc:sldMk cId="0" sldId="261"/>
-            <ac:spMk id="2" creationId="{00000000-0000-0000-0000-000000000000}"/>
-          </ac:spMkLst>
-        </pc:spChg>
-        <pc:spChg chg="mod">
-          <ac:chgData name="Peter Bernhardt" userId="f2333933-0b12-4d6e-972f-f87625423892" providerId="ADAL" clId="{54BAB7D7-C378-4C4A-B0F8-9DF09AB8FC9C}" dt="2026-03-18T16:39:28.277" v="85" actId="27636"/>
-          <ac:spMkLst>
-            <pc:docMk/>
-            <pc:sldMk cId="0" sldId="261"/>
-            <ac:spMk id="3" creationId="{00000000-0000-0000-0000-000000000000}"/>
-          </ac:spMkLst>
-        </pc:spChg>
-      </pc:sldChg>
-      <pc:sldChg chg="modSp del mod">
-        <pc:chgData name="Peter Bernhardt" userId="f2333933-0b12-4d6e-972f-f87625423892" providerId="ADAL" clId="{54BAB7D7-C378-4C4A-B0F8-9DF09AB8FC9C}" dt="2026-03-18T17:27:59.585" v="473" actId="47"/>
-        <pc:sldMkLst>
-          <pc:docMk/>
-          <pc:sldMk cId="0" sldId="262"/>
-        </pc:sldMkLst>
-        <pc:spChg chg="mod">
-          <ac:chgData name="Peter Bernhardt" userId="f2333933-0b12-4d6e-972f-f87625423892" providerId="ADAL" clId="{54BAB7D7-C378-4C4A-B0F8-9DF09AB8FC9C}" dt="2026-03-18T16:39:28.101" v="79" actId="790"/>
-          <ac:spMkLst>
-            <pc:docMk/>
-            <pc:sldMk cId="0" sldId="262"/>
-            <ac:spMk id="2" creationId="{00000000-0000-0000-0000-000000000000}"/>
-          </ac:spMkLst>
-        </pc:spChg>
-        <pc:spChg chg="mod">
-          <ac:chgData name="Peter Bernhardt" userId="f2333933-0b12-4d6e-972f-f87625423892" providerId="ADAL" clId="{54BAB7D7-C378-4C4A-B0F8-9DF09AB8FC9C}" dt="2026-03-18T16:39:28.277" v="86" actId="27636"/>
-          <ac:spMkLst>
-            <pc:docMk/>
-            <pc:sldMk cId="0" sldId="262"/>
-            <ac:spMk id="3" creationId="{00000000-0000-0000-0000-000000000000}"/>
-          </ac:spMkLst>
-        </pc:spChg>
-      </pc:sldChg>
-      <pc:sldChg chg="modSp del mod">
-        <pc:chgData name="Peter Bernhardt" userId="f2333933-0b12-4d6e-972f-f87625423892" providerId="ADAL" clId="{54BAB7D7-C378-4C4A-B0F8-9DF09AB8FC9C}" dt="2026-03-18T17:27:59.585" v="473" actId="47"/>
-        <pc:sldMkLst>
-          <pc:docMk/>
-          <pc:sldMk cId="0" sldId="263"/>
-        </pc:sldMkLst>
-        <pc:spChg chg="mod">
-          <ac:chgData name="Peter Bernhardt" userId="f2333933-0b12-4d6e-972f-f87625423892" providerId="ADAL" clId="{54BAB7D7-C378-4C4A-B0F8-9DF09AB8FC9C}" dt="2026-03-18T16:39:28.101" v="79" actId="790"/>
-          <ac:spMkLst>
-            <pc:docMk/>
-            <pc:sldMk cId="0" sldId="263"/>
-            <ac:spMk id="2" creationId="{00000000-0000-0000-0000-000000000000}"/>
-          </ac:spMkLst>
-        </pc:spChg>
-        <pc:spChg chg="mod">
-          <ac:chgData name="Peter Bernhardt" userId="f2333933-0b12-4d6e-972f-f87625423892" providerId="ADAL" clId="{54BAB7D7-C378-4C4A-B0F8-9DF09AB8FC9C}" dt="2026-03-18T16:39:28.292" v="87" actId="27636"/>
-          <ac:spMkLst>
-            <pc:docMk/>
-            <pc:sldMk cId="0" sldId="263"/>
-            <ac:spMk id="3" creationId="{00000000-0000-0000-0000-000000000000}"/>
-          </ac:spMkLst>
-        </pc:spChg>
-      </pc:sldChg>
-      <pc:sldChg chg="modSp del mod">
-        <pc:chgData name="Peter Bernhardt" userId="f2333933-0b12-4d6e-972f-f87625423892" providerId="ADAL" clId="{54BAB7D7-C378-4C4A-B0F8-9DF09AB8FC9C}" dt="2026-03-18T17:27:59.585" v="473" actId="47"/>
-        <pc:sldMkLst>
-          <pc:docMk/>
-          <pc:sldMk cId="0" sldId="264"/>
-        </pc:sldMkLst>
-        <pc:spChg chg="mod">
-          <ac:chgData name="Peter Bernhardt" userId="f2333933-0b12-4d6e-972f-f87625423892" providerId="ADAL" clId="{54BAB7D7-C378-4C4A-B0F8-9DF09AB8FC9C}" dt="2026-03-18T16:41:22.087" v="209" actId="14100"/>
-          <ac:spMkLst>
-            <pc:docMk/>
-            <pc:sldMk cId="0" sldId="264"/>
-            <ac:spMk id="2" creationId="{00000000-0000-0000-0000-000000000000}"/>
-          </ac:spMkLst>
-        </pc:spChg>
-        <pc:spChg chg="mod">
-          <ac:chgData name="Peter Bernhardt" userId="f2333933-0b12-4d6e-972f-f87625423892" providerId="ADAL" clId="{54BAB7D7-C378-4C4A-B0F8-9DF09AB8FC9C}" dt="2026-03-18T17:22:43.779" v="463" actId="207"/>
-          <ac:spMkLst>
-            <pc:docMk/>
-            <pc:sldMk cId="0" sldId="264"/>
-            <ac:spMk id="3" creationId="{00000000-0000-0000-0000-000000000000}"/>
-          </ac:spMkLst>
-        </pc:spChg>
-      </pc:sldChg>
-      <pc:sldChg chg="modSp del mod">
-        <pc:chgData name="Peter Bernhardt" userId="f2333933-0b12-4d6e-972f-f87625423892" providerId="ADAL" clId="{54BAB7D7-C378-4C4A-B0F8-9DF09AB8FC9C}" dt="2026-03-18T17:27:59.585" v="473" actId="47"/>
-        <pc:sldMkLst>
-          <pc:docMk/>
-          <pc:sldMk cId="0" sldId="265"/>
-        </pc:sldMkLst>
-        <pc:spChg chg="mod">
-          <ac:chgData name="Peter Bernhardt" userId="f2333933-0b12-4d6e-972f-f87625423892" providerId="ADAL" clId="{54BAB7D7-C378-4C4A-B0F8-9DF09AB8FC9C}" dt="2026-03-18T16:39:28.101" v="79" actId="790"/>
-          <ac:spMkLst>
-            <pc:docMk/>
-            <pc:sldMk cId="0" sldId="265"/>
-            <ac:spMk id="2" creationId="{00000000-0000-0000-0000-000000000000}"/>
-          </ac:spMkLst>
-        </pc:spChg>
-        <pc:spChg chg="mod">
-          <ac:chgData name="Peter Bernhardt" userId="f2333933-0b12-4d6e-972f-f87625423892" providerId="ADAL" clId="{54BAB7D7-C378-4C4A-B0F8-9DF09AB8FC9C}" dt="2026-03-18T16:39:28.308" v="90" actId="27636"/>
-          <ac:spMkLst>
-            <pc:docMk/>
-            <pc:sldMk cId="0" sldId="265"/>
-            <ac:spMk id="3" creationId="{00000000-0000-0000-0000-000000000000}"/>
-          </ac:spMkLst>
-        </pc:spChg>
-      </pc:sldChg>
-      <pc:sldChg chg="modSp del mod">
-        <pc:chgData name="Peter Bernhardt" userId="f2333933-0b12-4d6e-972f-f87625423892" providerId="ADAL" clId="{54BAB7D7-C378-4C4A-B0F8-9DF09AB8FC9C}" dt="2026-03-18T17:27:59.585" v="473" actId="47"/>
-        <pc:sldMkLst>
-          <pc:docMk/>
-          <pc:sldMk cId="0" sldId="266"/>
-        </pc:sldMkLst>
-        <pc:spChg chg="mod">
-          <ac:chgData name="Peter Bernhardt" userId="f2333933-0b12-4d6e-972f-f87625423892" providerId="ADAL" clId="{54BAB7D7-C378-4C4A-B0F8-9DF09AB8FC9C}" dt="2026-03-18T16:39:28.308" v="91" actId="27636"/>
-          <ac:spMkLst>
-            <pc:docMk/>
-            <pc:sldMk cId="0" sldId="266"/>
-            <ac:spMk id="2" creationId="{00000000-0000-0000-0000-000000000000}"/>
-          </ac:spMkLst>
-        </pc:spChg>
-        <pc:spChg chg="mod">
-          <ac:chgData name="Peter Bernhardt" userId="f2333933-0b12-4d6e-972f-f87625423892" providerId="ADAL" clId="{54BAB7D7-C378-4C4A-B0F8-9DF09AB8FC9C}" dt="2026-03-18T16:39:28.308" v="92" actId="27636"/>
-          <ac:spMkLst>
-            <pc:docMk/>
-            <pc:sldMk cId="0" sldId="266"/>
-            <ac:spMk id="3" creationId="{00000000-0000-0000-0000-000000000000}"/>
-          </ac:spMkLst>
-        </pc:spChg>
-      </pc:sldChg>
-      <pc:sldChg chg="modSp del mod">
-        <pc:chgData name="Peter Bernhardt" userId="f2333933-0b12-4d6e-972f-f87625423892" providerId="ADAL" clId="{54BAB7D7-C378-4C4A-B0F8-9DF09AB8FC9C}" dt="2026-03-18T17:27:59.585" v="473" actId="47"/>
-        <pc:sldMkLst>
-          <pc:docMk/>
-          <pc:sldMk cId="0" sldId="267"/>
-        </pc:sldMkLst>
-        <pc:spChg chg="mod">
-          <ac:chgData name="Peter Bernhardt" userId="f2333933-0b12-4d6e-972f-f87625423892" providerId="ADAL" clId="{54BAB7D7-C378-4C4A-B0F8-9DF09AB8FC9C}" dt="2026-03-18T16:39:28.101" v="79" actId="790"/>
-          <ac:spMkLst>
-            <pc:docMk/>
-            <pc:sldMk cId="0" sldId="267"/>
-            <ac:spMk id="2" creationId="{00000000-0000-0000-0000-000000000000}"/>
-          </ac:spMkLst>
-        </pc:spChg>
-        <pc:spChg chg="mod">
-          <ac:chgData name="Peter Bernhardt" userId="f2333933-0b12-4d6e-972f-f87625423892" providerId="ADAL" clId="{54BAB7D7-C378-4C4A-B0F8-9DF09AB8FC9C}" dt="2026-03-18T16:39:28.325" v="93" actId="27636"/>
-          <ac:spMkLst>
-            <pc:docMk/>
-            <pc:sldMk cId="0" sldId="267"/>
-            <ac:spMk id="3" creationId="{00000000-0000-0000-0000-000000000000}"/>
-          </ac:spMkLst>
-        </pc:spChg>
-      </pc:sldChg>
-      <pc:sldChg chg="modSp del mod">
-        <pc:chgData name="Peter Bernhardt" userId="f2333933-0b12-4d6e-972f-f87625423892" providerId="ADAL" clId="{54BAB7D7-C378-4C4A-B0F8-9DF09AB8FC9C}" dt="2026-03-18T17:27:59.585" v="473" actId="47"/>
-        <pc:sldMkLst>
-          <pc:docMk/>
-          <pc:sldMk cId="0" sldId="268"/>
-        </pc:sldMkLst>
-        <pc:spChg chg="mod">
-          <ac:chgData name="Peter Bernhardt" userId="f2333933-0b12-4d6e-972f-f87625423892" providerId="ADAL" clId="{54BAB7D7-C378-4C4A-B0F8-9DF09AB8FC9C}" dt="2026-03-18T16:39:28.333" v="95" actId="27636"/>
-          <ac:spMkLst>
-            <pc:docMk/>
-            <pc:sldMk cId="0" sldId="268"/>
-            <ac:spMk id="2" creationId="{00000000-0000-0000-0000-000000000000}"/>
-          </ac:spMkLst>
-        </pc:spChg>
-        <pc:spChg chg="mod">
-          <ac:chgData name="Peter Bernhardt" userId="f2333933-0b12-4d6e-972f-f87625423892" providerId="ADAL" clId="{54BAB7D7-C378-4C4A-B0F8-9DF09AB8FC9C}" dt="2026-03-18T16:39:28.332" v="94" actId="27636"/>
-          <ac:spMkLst>
-            <pc:docMk/>
-            <pc:sldMk cId="0" sldId="268"/>
-            <ac:spMk id="3" creationId="{00000000-0000-0000-0000-000000000000}"/>
-          </ac:spMkLst>
-        </pc:spChg>
-      </pc:sldChg>
-      <pc:sldChg chg="addSp delSp modSp del mod setBg delDesignElem chgLayout">
-        <pc:chgData name="Peter Bernhardt" userId="f2333933-0b12-4d6e-972f-f87625423892" providerId="ADAL" clId="{54BAB7D7-C378-4C4A-B0F8-9DF09AB8FC9C}" dt="2026-03-18T17:27:59.585" v="473" actId="47"/>
-        <pc:sldMkLst>
-          <pc:docMk/>
-          <pc:sldMk cId="0" sldId="269"/>
-        </pc:sldMkLst>
-        <pc:spChg chg="mod ord">
-          <ac:chgData name="Peter Bernhardt" userId="f2333933-0b12-4d6e-972f-f87625423892" providerId="ADAL" clId="{54BAB7D7-C378-4C4A-B0F8-9DF09AB8FC9C}" dt="2026-03-18T17:15:30.999" v="433" actId="6264"/>
-          <ac:spMkLst>
-            <pc:docMk/>
-            <pc:sldMk cId="0" sldId="269"/>
-            <ac:spMk id="2" creationId="{00000000-0000-0000-0000-000000000000}"/>
-          </ac:spMkLst>
-        </pc:spChg>
-        <pc:spChg chg="add del mod ord">
-          <ac:chgData name="Peter Bernhardt" userId="f2333933-0b12-4d6e-972f-f87625423892" providerId="ADAL" clId="{54BAB7D7-C378-4C4A-B0F8-9DF09AB8FC9C}" dt="2026-03-18T16:46:34.265" v="294" actId="700"/>
-          <ac:spMkLst>
-            <pc:docMk/>
-            <pc:sldMk cId="0" sldId="269"/>
-            <ac:spMk id="3" creationId="{19AD92D7-A542-E8D7-97BC-158B9474374B}"/>
-          </ac:spMkLst>
-        </pc:spChg>
-        <pc:spChg chg="add del mod ord">
-          <ac:chgData name="Peter Bernhardt" userId="f2333933-0b12-4d6e-972f-f87625423892" providerId="ADAL" clId="{54BAB7D7-C378-4C4A-B0F8-9DF09AB8FC9C}" dt="2026-03-18T16:46:58.112" v="298" actId="6264"/>
-          <ac:spMkLst>
-            <pc:docMk/>
-            <pc:sldMk cId="0" sldId="269"/>
-            <ac:spMk id="4" creationId="{F402EB27-1766-EC25-F2E9-E25A9A74C9A6}"/>
-          </ac:spMkLst>
-        </pc:spChg>
-        <pc:spChg chg="add del mod">
-          <ac:chgData name="Peter Bernhardt" userId="f2333933-0b12-4d6e-972f-f87625423892" providerId="ADAL" clId="{54BAB7D7-C378-4C4A-B0F8-9DF09AB8FC9C}" dt="2026-03-18T16:46:58.112" v="298" actId="6264"/>
-          <ac:spMkLst>
-            <pc:docMk/>
-            <pc:sldMk cId="0" sldId="269"/>
-            <ac:spMk id="6" creationId="{1F150884-F75D-44F1-4705-C6EBE6FDA276}"/>
-          </ac:spMkLst>
-        </pc:spChg>
-        <pc:spChg chg="add del mod ord">
-          <ac:chgData name="Peter Bernhardt" userId="f2333933-0b12-4d6e-972f-f87625423892" providerId="ADAL" clId="{54BAB7D7-C378-4C4A-B0F8-9DF09AB8FC9C}" dt="2026-03-18T16:47:01.269" v="300" actId="700"/>
-          <ac:spMkLst>
-            <pc:docMk/>
-            <pc:sldMk cId="0" sldId="269"/>
-            <ac:spMk id="7" creationId="{D7F42379-8D7C-6359-8666-CF903DA8421C}"/>
-          </ac:spMkLst>
-        </pc:spChg>
-        <pc:spChg chg="add del mod ord">
-          <ac:chgData name="Peter Bernhardt" userId="f2333933-0b12-4d6e-972f-f87625423892" providerId="ADAL" clId="{54BAB7D7-C378-4C4A-B0F8-9DF09AB8FC9C}" dt="2026-03-18T17:15:30.999" v="433" actId="6264"/>
-          <ac:spMkLst>
-            <pc:docMk/>
-            <pc:sldMk cId="0" sldId="269"/>
-            <ac:spMk id="8" creationId="{6B4C4B3D-D383-F075-7F5D-E818D1FE8C31}"/>
-          </ac:spMkLst>
-        </pc:spChg>
-        <pc:spChg chg="add del">
-          <ac:chgData name="Peter Bernhardt" userId="f2333933-0b12-4d6e-972f-f87625423892" providerId="ADAL" clId="{54BAB7D7-C378-4C4A-B0F8-9DF09AB8FC9C}" dt="2026-03-18T16:46:34.265" v="294" actId="700"/>
-          <ac:spMkLst>
-            <pc:docMk/>
-            <pc:sldMk cId="0" sldId="269"/>
-            <ac:spMk id="9" creationId="{D829E218-74FB-4455-98BE-F2C5BA8978BE}"/>
-          </ac:spMkLst>
-        </pc:spChg>
-        <pc:spChg chg="add del mod">
-          <ac:chgData name="Peter Bernhardt" userId="f2333933-0b12-4d6e-972f-f87625423892" providerId="ADAL" clId="{54BAB7D7-C378-4C4A-B0F8-9DF09AB8FC9C}" dt="2026-03-18T17:15:30.999" v="433" actId="6264"/>
-          <ac:spMkLst>
-            <pc:docMk/>
-            <pc:sldMk cId="0" sldId="269"/>
-            <ac:spMk id="10" creationId="{3E0CF35C-F0EB-1270-E47D-6AB23AF89F07}"/>
-          </ac:spMkLst>
-        </pc:spChg>
-        <pc:spChg chg="add del">
-          <ac:chgData name="Peter Bernhardt" userId="f2333933-0b12-4d6e-972f-f87625423892" providerId="ADAL" clId="{54BAB7D7-C378-4C4A-B0F8-9DF09AB8FC9C}" dt="2026-03-18T16:46:34.265" v="294" actId="700"/>
-          <ac:spMkLst>
-            <pc:docMk/>
-            <pc:sldMk cId="0" sldId="269"/>
-            <ac:spMk id="11" creationId="{7E8D75FD-D4F9-4D11-B70D-82EFCB4CFA5B}"/>
-          </ac:spMkLst>
-        </pc:spChg>
-        <pc:spChg chg="add mod ord">
-          <ac:chgData name="Peter Bernhardt" userId="f2333933-0b12-4d6e-972f-f87625423892" providerId="ADAL" clId="{54BAB7D7-C378-4C4A-B0F8-9DF09AB8FC9C}" dt="2026-03-18T17:15:30.999" v="433" actId="6264"/>
-          <ac:spMkLst>
-            <pc:docMk/>
-            <pc:sldMk cId="0" sldId="269"/>
-            <ac:spMk id="12" creationId="{CF703DD4-0F5C-5E36-561C-DE7602282BCB}"/>
-          </ac:spMkLst>
-        </pc:spChg>
-        <pc:spChg chg="add del">
-          <ac:chgData name="Peter Bernhardt" userId="f2333933-0b12-4d6e-972f-f87625423892" providerId="ADAL" clId="{54BAB7D7-C378-4C4A-B0F8-9DF09AB8FC9C}" dt="2026-03-18T16:46:34.265" v="294" actId="700"/>
-          <ac:spMkLst>
-            <pc:docMk/>
-            <pc:sldMk cId="0" sldId="269"/>
-            <ac:spMk id="15" creationId="{A9286AD2-18A9-4868-A4E3-7A2097A20810}"/>
-          </ac:spMkLst>
-        </pc:spChg>
-        <pc:picChg chg="add del">
-          <ac:chgData name="Peter Bernhardt" userId="f2333933-0b12-4d6e-972f-f87625423892" providerId="ADAL" clId="{54BAB7D7-C378-4C4A-B0F8-9DF09AB8FC9C}" dt="2026-03-18T16:46:37.226" v="296" actId="478"/>
-          <ac:picMkLst>
-            <pc:docMk/>
-            <pc:sldMk cId="0" sldId="269"/>
-            <ac:picMk id="5" creationId="{77BD201C-1A67-DEAB-6901-F52FB64DCE15}"/>
-          </ac:picMkLst>
-        </pc:picChg>
-        <pc:cxnChg chg="add del">
-          <ac:chgData name="Peter Bernhardt" userId="f2333933-0b12-4d6e-972f-f87625423892" providerId="ADAL" clId="{54BAB7D7-C378-4C4A-B0F8-9DF09AB8FC9C}" dt="2026-03-18T16:46:34.265" v="294" actId="700"/>
-          <ac:cxnSpMkLst>
-            <pc:docMk/>
-            <pc:sldMk cId="0" sldId="269"/>
-            <ac:cxnSpMk id="13" creationId="{1F5DC8C3-BA5F-4EED-BB9A-A14272BD82A1}"/>
-          </ac:cxnSpMkLst>
-        </pc:cxnChg>
-        <pc:cxnChg chg="add del">
-          <ac:chgData name="Peter Bernhardt" userId="f2333933-0b12-4d6e-972f-f87625423892" providerId="ADAL" clId="{54BAB7D7-C378-4C4A-B0F8-9DF09AB8FC9C}" dt="2026-03-18T16:46:34.265" v="294" actId="700"/>
-          <ac:cxnSpMkLst>
-            <pc:docMk/>
-            <pc:sldMk cId="0" sldId="269"/>
-            <ac:cxnSpMk id="17" creationId="{E7A7CD63-7EC3-44F3-95D0-595C4019FF24}"/>
-          </ac:cxnSpMkLst>
-        </pc:cxnChg>
-      </pc:sldChg>
-      <pc:sldChg chg="modSp del mod">
-        <pc:chgData name="Peter Bernhardt" userId="f2333933-0b12-4d6e-972f-f87625423892" providerId="ADAL" clId="{54BAB7D7-C378-4C4A-B0F8-9DF09AB8FC9C}" dt="2026-03-18T17:27:59.585" v="473" actId="47"/>
-        <pc:sldMkLst>
-          <pc:docMk/>
-          <pc:sldMk cId="0" sldId="270"/>
-        </pc:sldMkLst>
-        <pc:spChg chg="mod">
-          <ac:chgData name="Peter Bernhardt" userId="f2333933-0b12-4d6e-972f-f87625423892" providerId="ADAL" clId="{54BAB7D7-C378-4C4A-B0F8-9DF09AB8FC9C}" dt="2026-03-18T16:41:22.087" v="209" actId="14100"/>
-          <ac:spMkLst>
-            <pc:docMk/>
-            <pc:sldMk cId="0" sldId="270"/>
-            <ac:spMk id="2" creationId="{00000000-0000-0000-0000-000000000000}"/>
-          </ac:spMkLst>
-        </pc:spChg>
-        <pc:spChg chg="mod">
-          <ac:chgData name="Peter Bernhardt" userId="f2333933-0b12-4d6e-972f-f87625423892" providerId="ADAL" clId="{54BAB7D7-C378-4C4A-B0F8-9DF09AB8FC9C}" dt="2026-03-18T16:39:28.340" v="97" actId="27636"/>
-          <ac:spMkLst>
-            <pc:docMk/>
-            <pc:sldMk cId="0" sldId="270"/>
-            <ac:spMk id="3" creationId="{00000000-0000-0000-0000-000000000000}"/>
-          </ac:spMkLst>
-        </pc:spChg>
-      </pc:sldChg>
-      <pc:sldChg chg="modSp del mod">
-        <pc:chgData name="Peter Bernhardt" userId="f2333933-0b12-4d6e-972f-f87625423892" providerId="ADAL" clId="{54BAB7D7-C378-4C4A-B0F8-9DF09AB8FC9C}" dt="2026-03-18T17:27:59.585" v="473" actId="47"/>
-        <pc:sldMkLst>
-          <pc:docMk/>
-          <pc:sldMk cId="0" sldId="271"/>
-        </pc:sldMkLst>
-        <pc:spChg chg="mod">
-          <ac:chgData name="Peter Bernhardt" userId="f2333933-0b12-4d6e-972f-f87625423892" providerId="ADAL" clId="{54BAB7D7-C378-4C4A-B0F8-9DF09AB8FC9C}" dt="2026-03-18T16:39:28.342" v="100" actId="27636"/>
-          <ac:spMkLst>
-            <pc:docMk/>
-            <pc:sldMk cId="0" sldId="271"/>
-            <ac:spMk id="2" creationId="{00000000-0000-0000-0000-000000000000}"/>
-          </ac:spMkLst>
-        </pc:spChg>
-        <pc:spChg chg="mod">
-          <ac:chgData name="Peter Bernhardt" userId="f2333933-0b12-4d6e-972f-f87625423892" providerId="ADAL" clId="{54BAB7D7-C378-4C4A-B0F8-9DF09AB8FC9C}" dt="2026-03-18T16:39:28.342" v="99" actId="27636"/>
-          <ac:spMkLst>
-            <pc:docMk/>
-            <pc:sldMk cId="0" sldId="271"/>
-            <ac:spMk id="3" creationId="{00000000-0000-0000-0000-000000000000}"/>
-          </ac:spMkLst>
-        </pc:spChg>
-      </pc:sldChg>
-      <pc:sldChg chg="modSp del mod">
-        <pc:chgData name="Peter Bernhardt" userId="f2333933-0b12-4d6e-972f-f87625423892" providerId="ADAL" clId="{54BAB7D7-C378-4C4A-B0F8-9DF09AB8FC9C}" dt="2026-03-18T17:27:59.585" v="473" actId="47"/>
-        <pc:sldMkLst>
-          <pc:docMk/>
-          <pc:sldMk cId="0" sldId="272"/>
-        </pc:sldMkLst>
-        <pc:spChg chg="mod">
-          <ac:chgData name="Peter Bernhardt" userId="f2333933-0b12-4d6e-972f-f87625423892" providerId="ADAL" clId="{54BAB7D7-C378-4C4A-B0F8-9DF09AB8FC9C}" dt="2026-03-18T16:41:22.087" v="209" actId="14100"/>
-          <ac:spMkLst>
-            <pc:docMk/>
-            <pc:sldMk cId="0" sldId="272"/>
-            <ac:spMk id="2" creationId="{00000000-0000-0000-0000-000000000000}"/>
-          </ac:spMkLst>
-        </pc:spChg>
-        <pc:spChg chg="mod">
-          <ac:chgData name="Peter Bernhardt" userId="f2333933-0b12-4d6e-972f-f87625423892" providerId="ADAL" clId="{54BAB7D7-C378-4C4A-B0F8-9DF09AB8FC9C}" dt="2026-03-18T16:39:28.358" v="101" actId="27636"/>
-          <ac:spMkLst>
-            <pc:docMk/>
-            <pc:sldMk cId="0" sldId="272"/>
-            <ac:spMk id="3" creationId="{00000000-0000-0000-0000-000000000000}"/>
-          </ac:spMkLst>
-        </pc:spChg>
-      </pc:sldChg>
-      <pc:sldChg chg="modSp del mod">
-        <pc:chgData name="Peter Bernhardt" userId="f2333933-0b12-4d6e-972f-f87625423892" providerId="ADAL" clId="{54BAB7D7-C378-4C4A-B0F8-9DF09AB8FC9C}" dt="2026-03-18T17:27:59.585" v="473" actId="47"/>
-        <pc:sldMkLst>
-          <pc:docMk/>
-          <pc:sldMk cId="0" sldId="273"/>
-        </pc:sldMkLst>
-        <pc:spChg chg="mod">
-          <ac:chgData name="Peter Bernhardt" userId="f2333933-0b12-4d6e-972f-f87625423892" providerId="ADAL" clId="{54BAB7D7-C378-4C4A-B0F8-9DF09AB8FC9C}" dt="2026-03-18T16:39:28.101" v="79" actId="790"/>
-          <ac:spMkLst>
-            <pc:docMk/>
-            <pc:sldMk cId="0" sldId="273"/>
-            <ac:spMk id="2" creationId="{00000000-0000-0000-0000-000000000000}"/>
-          </ac:spMkLst>
-        </pc:spChg>
-        <pc:spChg chg="mod">
-          <ac:chgData name="Peter Bernhardt" userId="f2333933-0b12-4d6e-972f-f87625423892" providerId="ADAL" clId="{54BAB7D7-C378-4C4A-B0F8-9DF09AB8FC9C}" dt="2026-03-18T16:39:28.783" v="103" actId="27636"/>
-          <ac:spMkLst>
-            <pc:docMk/>
-            <pc:sldMk cId="0" sldId="273"/>
-            <ac:spMk id="3" creationId="{00000000-0000-0000-0000-000000000000}"/>
-          </ac:spMkLst>
-        </pc:spChg>
-      </pc:sldChg>
-      <pc:sldChg chg="modSp del mod">
-        <pc:chgData name="Peter Bernhardt" userId="f2333933-0b12-4d6e-972f-f87625423892" providerId="ADAL" clId="{54BAB7D7-C378-4C4A-B0F8-9DF09AB8FC9C}" dt="2026-03-18T17:27:59.585" v="473" actId="47"/>
-        <pc:sldMkLst>
-          <pc:docMk/>
-          <pc:sldMk cId="0" sldId="274"/>
-        </pc:sldMkLst>
-        <pc:spChg chg="mod">
-          <ac:chgData name="Peter Bernhardt" userId="f2333933-0b12-4d6e-972f-f87625423892" providerId="ADAL" clId="{54BAB7D7-C378-4C4A-B0F8-9DF09AB8FC9C}" dt="2026-03-18T16:39:28.101" v="79" actId="790"/>
-          <ac:spMkLst>
-            <pc:docMk/>
-            <pc:sldMk cId="0" sldId="274"/>
-            <ac:spMk id="2" creationId="{00000000-0000-0000-0000-000000000000}"/>
-          </ac:spMkLst>
-        </pc:spChg>
-        <pc:spChg chg="mod">
-          <ac:chgData name="Peter Bernhardt" userId="f2333933-0b12-4d6e-972f-f87625423892" providerId="ADAL" clId="{54BAB7D7-C378-4C4A-B0F8-9DF09AB8FC9C}" dt="2026-03-18T16:39:28.791" v="104" actId="27636"/>
-          <ac:spMkLst>
-            <pc:docMk/>
-            <pc:sldMk cId="0" sldId="274"/>
-            <ac:spMk id="3" creationId="{00000000-0000-0000-0000-000000000000}"/>
-          </ac:spMkLst>
-        </pc:spChg>
-      </pc:sldChg>
-      <pc:sldChg chg="modSp del mod">
-        <pc:chgData name="Peter Bernhardt" userId="f2333933-0b12-4d6e-972f-f87625423892" providerId="ADAL" clId="{54BAB7D7-C378-4C4A-B0F8-9DF09AB8FC9C}" dt="2026-03-18T17:27:59.585" v="473" actId="47"/>
-        <pc:sldMkLst>
-          <pc:docMk/>
-          <pc:sldMk cId="0" sldId="275"/>
-        </pc:sldMkLst>
-        <pc:spChg chg="mod">
-          <ac:chgData name="Peter Bernhardt" userId="f2333933-0b12-4d6e-972f-f87625423892" providerId="ADAL" clId="{54BAB7D7-C378-4C4A-B0F8-9DF09AB8FC9C}" dt="2026-03-18T16:39:28.804" v="106" actId="27636"/>
-          <ac:spMkLst>
-            <pc:docMk/>
-            <pc:sldMk cId="0" sldId="275"/>
-            <ac:spMk id="2" creationId="{00000000-0000-0000-0000-000000000000}"/>
-          </ac:spMkLst>
-        </pc:spChg>
-        <pc:spChg chg="mod">
-          <ac:chgData name="Peter Bernhardt" userId="f2333933-0b12-4d6e-972f-f87625423892" providerId="ADAL" clId="{54BAB7D7-C378-4C4A-B0F8-9DF09AB8FC9C}" dt="2026-03-18T16:39:28.802" v="105" actId="27636"/>
-          <ac:spMkLst>
-            <pc:docMk/>
-            <pc:sldMk cId="0" sldId="275"/>
-            <ac:spMk id="3" creationId="{00000000-0000-0000-0000-000000000000}"/>
-          </ac:spMkLst>
-        </pc:spChg>
-      </pc:sldChg>
-      <pc:sldChg chg="modSp del mod">
-        <pc:chgData name="Peter Bernhardt" userId="f2333933-0b12-4d6e-972f-f87625423892" providerId="ADAL" clId="{54BAB7D7-C378-4C4A-B0F8-9DF09AB8FC9C}" dt="2026-03-18T17:27:59.585" v="473" actId="47"/>
-        <pc:sldMkLst>
-          <pc:docMk/>
-          <pc:sldMk cId="0" sldId="276"/>
-        </pc:sldMkLst>
-        <pc:spChg chg="mod">
-          <ac:chgData name="Peter Bernhardt" userId="f2333933-0b12-4d6e-972f-f87625423892" providerId="ADAL" clId="{54BAB7D7-C378-4C4A-B0F8-9DF09AB8FC9C}" dt="2026-03-18T16:39:28.807" v="107" actId="27636"/>
-          <ac:spMkLst>
-            <pc:docMk/>
-            <pc:sldMk cId="0" sldId="276"/>
-            <ac:spMk id="2" creationId="{00000000-0000-0000-0000-000000000000}"/>
-          </ac:spMkLst>
-        </pc:spChg>
-        <pc:spChg chg="mod">
-          <ac:chgData name="Peter Bernhardt" userId="f2333933-0b12-4d6e-972f-f87625423892" providerId="ADAL" clId="{54BAB7D7-C378-4C4A-B0F8-9DF09AB8FC9C}" dt="2026-03-18T16:39:28.807" v="108" actId="27636"/>
-          <ac:spMkLst>
-            <pc:docMk/>
-            <pc:sldMk cId="0" sldId="276"/>
-            <ac:spMk id="3" creationId="{00000000-0000-0000-0000-000000000000}"/>
-          </ac:spMkLst>
-        </pc:spChg>
-      </pc:sldChg>
-      <pc:sldChg chg="modSp del mod">
-        <pc:chgData name="Peter Bernhardt" userId="f2333933-0b12-4d6e-972f-f87625423892" providerId="ADAL" clId="{54BAB7D7-C378-4C4A-B0F8-9DF09AB8FC9C}" dt="2026-03-18T17:27:59.585" v="473" actId="47"/>
-        <pc:sldMkLst>
-          <pc:docMk/>
-          <pc:sldMk cId="0" sldId="277"/>
-        </pc:sldMkLst>
-        <pc:spChg chg="mod">
-          <ac:chgData name="Peter Bernhardt" userId="f2333933-0b12-4d6e-972f-f87625423892" providerId="ADAL" clId="{54BAB7D7-C378-4C4A-B0F8-9DF09AB8FC9C}" dt="2026-03-18T16:39:28.101" v="79" actId="790"/>
-          <ac:spMkLst>
-            <pc:docMk/>
-            <pc:sldMk cId="0" sldId="277"/>
-            <ac:spMk id="2" creationId="{00000000-0000-0000-0000-000000000000}"/>
-          </ac:spMkLst>
-        </pc:spChg>
-        <pc:spChg chg="mod">
-          <ac:chgData name="Peter Bernhardt" userId="f2333933-0b12-4d6e-972f-f87625423892" providerId="ADAL" clId="{54BAB7D7-C378-4C4A-B0F8-9DF09AB8FC9C}" dt="2026-03-18T16:39:28.807" v="109" actId="27636"/>
-          <ac:spMkLst>
-            <pc:docMk/>
-            <pc:sldMk cId="0" sldId="277"/>
-            <ac:spMk id="3" creationId="{00000000-0000-0000-0000-000000000000}"/>
-          </ac:spMkLst>
-        </pc:spChg>
-      </pc:sldChg>
-      <pc:sldChg chg="modSp del mod">
-        <pc:chgData name="Peter Bernhardt" userId="f2333933-0b12-4d6e-972f-f87625423892" providerId="ADAL" clId="{54BAB7D7-C378-4C4A-B0F8-9DF09AB8FC9C}" dt="2026-03-18T17:27:59.585" v="473" actId="47"/>
-        <pc:sldMkLst>
-          <pc:docMk/>
-          <pc:sldMk cId="0" sldId="278"/>
-        </pc:sldMkLst>
-        <pc:spChg chg="mod">
-          <ac:chgData name="Peter Bernhardt" userId="f2333933-0b12-4d6e-972f-f87625423892" providerId="ADAL" clId="{54BAB7D7-C378-4C4A-B0F8-9DF09AB8FC9C}" dt="2026-03-18T16:39:28.101" v="79" actId="790"/>
-          <ac:spMkLst>
-            <pc:docMk/>
-            <pc:sldMk cId="0" sldId="278"/>
-            <ac:spMk id="2" creationId="{00000000-0000-0000-0000-000000000000}"/>
-          </ac:spMkLst>
-        </pc:spChg>
-        <pc:spChg chg="mod">
-          <ac:chgData name="Peter Bernhardt" userId="f2333933-0b12-4d6e-972f-f87625423892" providerId="ADAL" clId="{54BAB7D7-C378-4C4A-B0F8-9DF09AB8FC9C}" dt="2026-03-18T16:39:28.830" v="110" actId="27636"/>
-          <ac:spMkLst>
-            <pc:docMk/>
-            <pc:sldMk cId="0" sldId="278"/>
-            <ac:spMk id="3" creationId="{00000000-0000-0000-0000-000000000000}"/>
-          </ac:spMkLst>
-        </pc:spChg>
-      </pc:sldChg>
-      <pc:sldChg chg="modSp del mod">
-        <pc:chgData name="Peter Bernhardt" userId="f2333933-0b12-4d6e-972f-f87625423892" providerId="ADAL" clId="{54BAB7D7-C378-4C4A-B0F8-9DF09AB8FC9C}" dt="2026-03-18T17:27:59.585" v="473" actId="47"/>
-        <pc:sldMkLst>
-          <pc:docMk/>
-          <pc:sldMk cId="0" sldId="279"/>
-        </pc:sldMkLst>
-        <pc:spChg chg="mod">
-          <ac:chgData name="Peter Bernhardt" userId="f2333933-0b12-4d6e-972f-f87625423892" providerId="ADAL" clId="{54BAB7D7-C378-4C4A-B0F8-9DF09AB8FC9C}" dt="2026-03-18T16:39:28.832" v="111" actId="27636"/>
-          <ac:spMkLst>
-            <pc:docMk/>
-            <pc:sldMk cId="0" sldId="279"/>
-            <ac:spMk id="2" creationId="{00000000-0000-0000-0000-000000000000}"/>
-          </ac:spMkLst>
-        </pc:spChg>
-        <pc:spChg chg="mod">
-          <ac:chgData name="Peter Bernhardt" userId="f2333933-0b12-4d6e-972f-f87625423892" providerId="ADAL" clId="{54BAB7D7-C378-4C4A-B0F8-9DF09AB8FC9C}" dt="2026-03-18T16:39:28.839" v="112" actId="27636"/>
-          <ac:spMkLst>
-            <pc:docMk/>
-            <pc:sldMk cId="0" sldId="279"/>
-            <ac:spMk id="3" creationId="{00000000-0000-0000-0000-000000000000}"/>
-          </ac:spMkLst>
-        </pc:spChg>
-      </pc:sldChg>
-      <pc:sldChg chg="addSp modSp del mod chgLayout">
-        <pc:chgData name="Peter Bernhardt" userId="f2333933-0b12-4d6e-972f-f87625423892" providerId="ADAL" clId="{54BAB7D7-C378-4C4A-B0F8-9DF09AB8FC9C}" dt="2026-03-18T17:27:59.585" v="473" actId="47"/>
-        <pc:sldMkLst>
-          <pc:docMk/>
-          <pc:sldMk cId="0" sldId="280"/>
-        </pc:sldMkLst>
-        <pc:spChg chg="mod ord">
-          <ac:chgData name="Peter Bernhardt" userId="f2333933-0b12-4d6e-972f-f87625423892" providerId="ADAL" clId="{54BAB7D7-C378-4C4A-B0F8-9DF09AB8FC9C}" dt="2026-03-18T16:47:36.106" v="303" actId="700"/>
-          <ac:spMkLst>
-            <pc:docMk/>
-            <pc:sldMk cId="0" sldId="280"/>
-            <ac:spMk id="2" creationId="{00000000-0000-0000-0000-000000000000}"/>
-          </ac:spMkLst>
-        </pc:spChg>
-        <pc:spChg chg="add mod ord">
-          <ac:chgData name="Peter Bernhardt" userId="f2333933-0b12-4d6e-972f-f87625423892" providerId="ADAL" clId="{54BAB7D7-C378-4C4A-B0F8-9DF09AB8FC9C}" dt="2026-03-18T16:47:36.106" v="303" actId="700"/>
-          <ac:spMkLst>
-            <pc:docMk/>
-            <pc:sldMk cId="0" sldId="280"/>
-            <ac:spMk id="3" creationId="{3FAF18B2-91AD-12FF-8DD6-25B1AA052EAF}"/>
-          </ac:spMkLst>
-        </pc:spChg>
-      </pc:sldChg>
-      <pc:sldChg chg="modSp del mod">
-        <pc:chgData name="Peter Bernhardt" userId="f2333933-0b12-4d6e-972f-f87625423892" providerId="ADAL" clId="{54BAB7D7-C378-4C4A-B0F8-9DF09AB8FC9C}" dt="2026-03-18T17:27:59.585" v="473" actId="47"/>
-        <pc:sldMkLst>
-          <pc:docMk/>
-          <pc:sldMk cId="0" sldId="281"/>
-        </pc:sldMkLst>
-        <pc:spChg chg="mod">
-          <ac:chgData name="Peter Bernhardt" userId="f2333933-0b12-4d6e-972f-f87625423892" providerId="ADAL" clId="{54BAB7D7-C378-4C4A-B0F8-9DF09AB8FC9C}" dt="2026-03-18T16:39:28.101" v="79" actId="790"/>
-          <ac:spMkLst>
-            <pc:docMk/>
-            <pc:sldMk cId="0" sldId="281"/>
-            <ac:spMk id="2" creationId="{00000000-0000-0000-0000-000000000000}"/>
-          </ac:spMkLst>
-        </pc:spChg>
-        <pc:spChg chg="mod">
-          <ac:chgData name="Peter Bernhardt" userId="f2333933-0b12-4d6e-972f-f87625423892" providerId="ADAL" clId="{54BAB7D7-C378-4C4A-B0F8-9DF09AB8FC9C}" dt="2026-03-18T16:39:28.849" v="114" actId="27636"/>
-          <ac:spMkLst>
-            <pc:docMk/>
-            <pc:sldMk cId="0" sldId="281"/>
-            <ac:spMk id="3" creationId="{00000000-0000-0000-0000-000000000000}"/>
-          </ac:spMkLst>
-        </pc:spChg>
-      </pc:sldChg>
-      <pc:sldChg chg="modSp del mod">
-        <pc:chgData name="Peter Bernhardt" userId="f2333933-0b12-4d6e-972f-f87625423892" providerId="ADAL" clId="{54BAB7D7-C378-4C4A-B0F8-9DF09AB8FC9C}" dt="2026-03-18T17:27:59.585" v="473" actId="47"/>
-        <pc:sldMkLst>
-          <pc:docMk/>
-          <pc:sldMk cId="0" sldId="282"/>
-        </pc:sldMkLst>
-        <pc:spChg chg="mod">
-          <ac:chgData name="Peter Bernhardt" userId="f2333933-0b12-4d6e-972f-f87625423892" providerId="ADAL" clId="{54BAB7D7-C378-4C4A-B0F8-9DF09AB8FC9C}" dt="2026-03-18T16:39:28.101" v="79" actId="790"/>
-          <ac:spMkLst>
-            <pc:docMk/>
-            <pc:sldMk cId="0" sldId="282"/>
-            <ac:spMk id="2" creationId="{00000000-0000-0000-0000-000000000000}"/>
-          </ac:spMkLst>
-        </pc:spChg>
-        <pc:spChg chg="mod">
-          <ac:chgData name="Peter Bernhardt" userId="f2333933-0b12-4d6e-972f-f87625423892" providerId="ADAL" clId="{54BAB7D7-C378-4C4A-B0F8-9DF09AB8FC9C}" dt="2026-03-18T16:39:28.858" v="115" actId="27636"/>
-          <ac:spMkLst>
-            <pc:docMk/>
-            <pc:sldMk cId="0" sldId="282"/>
-            <ac:spMk id="3" creationId="{00000000-0000-0000-0000-000000000000}"/>
-          </ac:spMkLst>
-        </pc:spChg>
-      </pc:sldChg>
-      <pc:sldChg chg="modSp del mod">
-        <pc:chgData name="Peter Bernhardt" userId="f2333933-0b12-4d6e-972f-f87625423892" providerId="ADAL" clId="{54BAB7D7-C378-4C4A-B0F8-9DF09AB8FC9C}" dt="2026-03-18T17:27:59.585" v="473" actId="47"/>
-        <pc:sldMkLst>
-          <pc:docMk/>
-          <pc:sldMk cId="0" sldId="283"/>
-        </pc:sldMkLst>
-        <pc:spChg chg="mod">
-          <ac:chgData name="Peter Bernhardt" userId="f2333933-0b12-4d6e-972f-f87625423892" providerId="ADAL" clId="{54BAB7D7-C378-4C4A-B0F8-9DF09AB8FC9C}" dt="2026-03-18T16:39:28.101" v="79" actId="790"/>
-          <ac:spMkLst>
-            <pc:docMk/>
-            <pc:sldMk cId="0" sldId="283"/>
-            <ac:spMk id="2" creationId="{00000000-0000-0000-0000-000000000000}"/>
-          </ac:spMkLst>
-        </pc:spChg>
-        <pc:spChg chg="mod">
-          <ac:chgData name="Peter Bernhardt" userId="f2333933-0b12-4d6e-972f-f87625423892" providerId="ADAL" clId="{54BAB7D7-C378-4C4A-B0F8-9DF09AB8FC9C}" dt="2026-03-18T16:39:28.866" v="116" actId="27636"/>
-          <ac:spMkLst>
-            <pc:docMk/>
-            <pc:sldMk cId="0" sldId="283"/>
-            <ac:spMk id="3" creationId="{00000000-0000-0000-0000-000000000000}"/>
-          </ac:spMkLst>
-        </pc:spChg>
-      </pc:sldChg>
-      <pc:sldChg chg="addSp modSp del mod">
-        <pc:chgData name="Peter Bernhardt" userId="f2333933-0b12-4d6e-972f-f87625423892" providerId="ADAL" clId="{54BAB7D7-C378-4C4A-B0F8-9DF09AB8FC9C}" dt="2026-03-18T17:27:59.585" v="473" actId="47"/>
-        <pc:sldMkLst>
-          <pc:docMk/>
-          <pc:sldMk cId="0" sldId="284"/>
-        </pc:sldMkLst>
-        <pc:spChg chg="mod">
-          <ac:chgData name="Peter Bernhardt" userId="f2333933-0b12-4d6e-972f-f87625423892" providerId="ADAL" clId="{54BAB7D7-C378-4C4A-B0F8-9DF09AB8FC9C}" dt="2026-03-18T16:39:28.869" v="117" actId="27636"/>
-          <ac:spMkLst>
-            <pc:docMk/>
-            <pc:sldMk cId="0" sldId="284"/>
-            <ac:spMk id="2" creationId="{00000000-0000-0000-0000-000000000000}"/>
-          </ac:spMkLst>
-        </pc:spChg>
-        <pc:spChg chg="mod">
-          <ac:chgData name="Peter Bernhardt" userId="f2333933-0b12-4d6e-972f-f87625423892" providerId="ADAL" clId="{54BAB7D7-C378-4C4A-B0F8-9DF09AB8FC9C}" dt="2026-03-18T17:16:09.844" v="437" actId="27636"/>
-          <ac:spMkLst>
-            <pc:docMk/>
-            <pc:sldMk cId="0" sldId="284"/>
-            <ac:spMk id="3" creationId="{00000000-0000-0000-0000-000000000000}"/>
-          </ac:spMkLst>
-        </pc:spChg>
-        <pc:picChg chg="add mod modCrop">
-          <ac:chgData name="Peter Bernhardt" userId="f2333933-0b12-4d6e-972f-f87625423892" providerId="ADAL" clId="{54BAB7D7-C378-4C4A-B0F8-9DF09AB8FC9C}" dt="2026-03-18T17:09:03.973" v="348" actId="1076"/>
-          <ac:picMkLst>
-            <pc:docMk/>
-            <pc:sldMk cId="0" sldId="284"/>
-            <ac:picMk id="5" creationId="{31A5285D-914E-FA7D-F134-3B80DA4843CE}"/>
-          </ac:picMkLst>
-        </pc:picChg>
-      </pc:sldChg>
-      <pc:sldChg chg="modSp del mod">
-        <pc:chgData name="Peter Bernhardt" userId="f2333933-0b12-4d6e-972f-f87625423892" providerId="ADAL" clId="{54BAB7D7-C378-4C4A-B0F8-9DF09AB8FC9C}" dt="2026-03-18T17:27:59.585" v="473" actId="47"/>
-        <pc:sldMkLst>
-          <pc:docMk/>
-          <pc:sldMk cId="0" sldId="285"/>
-        </pc:sldMkLst>
-        <pc:spChg chg="mod">
-          <ac:chgData name="Peter Bernhardt" userId="f2333933-0b12-4d6e-972f-f87625423892" providerId="ADAL" clId="{54BAB7D7-C378-4C4A-B0F8-9DF09AB8FC9C}" dt="2026-03-18T16:39:28.101" v="79" actId="790"/>
-          <ac:spMkLst>
-            <pc:docMk/>
-            <pc:sldMk cId="0" sldId="285"/>
-            <ac:spMk id="2" creationId="{00000000-0000-0000-0000-000000000000}"/>
-          </ac:spMkLst>
-        </pc:spChg>
-        <pc:spChg chg="mod">
-          <ac:chgData name="Peter Bernhardt" userId="f2333933-0b12-4d6e-972f-f87625423892" providerId="ADAL" clId="{54BAB7D7-C378-4C4A-B0F8-9DF09AB8FC9C}" dt="2026-03-18T16:39:28.869" v="119" actId="27636"/>
-          <ac:spMkLst>
-            <pc:docMk/>
-            <pc:sldMk cId="0" sldId="285"/>
-            <ac:spMk id="3" creationId="{00000000-0000-0000-0000-000000000000}"/>
-          </ac:spMkLst>
-        </pc:spChg>
-      </pc:sldChg>
-      <pc:sldChg chg="modSp del mod">
-        <pc:chgData name="Peter Bernhardt" userId="f2333933-0b12-4d6e-972f-f87625423892" providerId="ADAL" clId="{54BAB7D7-C378-4C4A-B0F8-9DF09AB8FC9C}" dt="2026-03-18T17:27:59.585" v="473" actId="47"/>
-        <pc:sldMkLst>
-          <pc:docMk/>
-          <pc:sldMk cId="0" sldId="286"/>
-        </pc:sldMkLst>
-        <pc:spChg chg="mod">
-          <ac:chgData name="Peter Bernhardt" userId="f2333933-0b12-4d6e-972f-f87625423892" providerId="ADAL" clId="{54BAB7D7-C378-4C4A-B0F8-9DF09AB8FC9C}" dt="2026-03-18T16:39:28.101" v="79" actId="790"/>
-          <ac:spMkLst>
-            <pc:docMk/>
-            <pc:sldMk cId="0" sldId="286"/>
-            <ac:spMk id="2" creationId="{00000000-0000-0000-0000-000000000000}"/>
-          </ac:spMkLst>
-        </pc:spChg>
-        <pc:spChg chg="mod">
-          <ac:chgData name="Peter Bernhardt" userId="f2333933-0b12-4d6e-972f-f87625423892" providerId="ADAL" clId="{54BAB7D7-C378-4C4A-B0F8-9DF09AB8FC9C}" dt="2026-03-18T16:39:28.887" v="120" actId="27636"/>
-          <ac:spMkLst>
-            <pc:docMk/>
-            <pc:sldMk cId="0" sldId="286"/>
-            <ac:spMk id="3" creationId="{00000000-0000-0000-0000-000000000000}"/>
-          </ac:spMkLst>
-        </pc:spChg>
-      </pc:sldChg>
-      <pc:sldChg chg="modSp del mod">
-        <pc:chgData name="Peter Bernhardt" userId="f2333933-0b12-4d6e-972f-f87625423892" providerId="ADAL" clId="{54BAB7D7-C378-4C4A-B0F8-9DF09AB8FC9C}" dt="2026-03-18T17:27:59.585" v="473" actId="47"/>
-        <pc:sldMkLst>
-          <pc:docMk/>
-          <pc:sldMk cId="0" sldId="287"/>
-        </pc:sldMkLst>
-        <pc:spChg chg="mod">
-          <ac:chgData name="Peter Bernhardt" userId="f2333933-0b12-4d6e-972f-f87625423892" providerId="ADAL" clId="{54BAB7D7-C378-4C4A-B0F8-9DF09AB8FC9C}" dt="2026-03-18T16:39:28.101" v="79" actId="790"/>
-          <ac:spMkLst>
-            <pc:docMk/>
-            <pc:sldMk cId="0" sldId="287"/>
-            <ac:spMk id="2" creationId="{00000000-0000-0000-0000-000000000000}"/>
-          </ac:spMkLst>
-        </pc:spChg>
-        <pc:spChg chg="mod">
-          <ac:chgData name="Peter Bernhardt" userId="f2333933-0b12-4d6e-972f-f87625423892" providerId="ADAL" clId="{54BAB7D7-C378-4C4A-B0F8-9DF09AB8FC9C}" dt="2026-03-18T16:39:28.899" v="121" actId="27636"/>
-          <ac:spMkLst>
-            <pc:docMk/>
-            <pc:sldMk cId="0" sldId="287"/>
-            <ac:spMk id="3" creationId="{00000000-0000-0000-0000-000000000000}"/>
-          </ac:spMkLst>
-        </pc:spChg>
-      </pc:sldChg>
-      <pc:sldChg chg="modSp del mod">
-        <pc:chgData name="Peter Bernhardt" userId="f2333933-0b12-4d6e-972f-f87625423892" providerId="ADAL" clId="{54BAB7D7-C378-4C4A-B0F8-9DF09AB8FC9C}" dt="2026-03-18T17:27:59.585" v="473" actId="47"/>
-        <pc:sldMkLst>
-          <pc:docMk/>
-          <pc:sldMk cId="0" sldId="288"/>
-        </pc:sldMkLst>
-        <pc:spChg chg="mod">
-          <ac:chgData name="Peter Bernhardt" userId="f2333933-0b12-4d6e-972f-f87625423892" providerId="ADAL" clId="{54BAB7D7-C378-4C4A-B0F8-9DF09AB8FC9C}" dt="2026-03-18T16:39:28.904" v="122" actId="27636"/>
-          <ac:spMkLst>
-            <pc:docMk/>
-            <pc:sldMk cId="0" sldId="288"/>
-            <ac:spMk id="2" creationId="{00000000-0000-0000-0000-000000000000}"/>
-          </ac:spMkLst>
-        </pc:spChg>
-        <pc:spChg chg="mod">
-          <ac:chgData name="Peter Bernhardt" userId="f2333933-0b12-4d6e-972f-f87625423892" providerId="ADAL" clId="{54BAB7D7-C378-4C4A-B0F8-9DF09AB8FC9C}" dt="2026-03-18T16:39:28.910" v="123" actId="27636"/>
-          <ac:spMkLst>
-            <pc:docMk/>
-            <pc:sldMk cId="0" sldId="288"/>
-            <ac:spMk id="3" creationId="{00000000-0000-0000-0000-000000000000}"/>
-          </ac:spMkLst>
-        </pc:spChg>
-      </pc:sldChg>
-      <pc:sldChg chg="addSp modSp del mod chgLayout">
-        <pc:chgData name="Peter Bernhardt" userId="f2333933-0b12-4d6e-972f-f87625423892" providerId="ADAL" clId="{54BAB7D7-C378-4C4A-B0F8-9DF09AB8FC9C}" dt="2026-03-18T17:27:59.585" v="473" actId="47"/>
-        <pc:sldMkLst>
-          <pc:docMk/>
-          <pc:sldMk cId="0" sldId="289"/>
-        </pc:sldMkLst>
-        <pc:spChg chg="mod ord">
-          <ac:chgData name="Peter Bernhardt" userId="f2333933-0b12-4d6e-972f-f87625423892" providerId="ADAL" clId="{54BAB7D7-C378-4C4A-B0F8-9DF09AB8FC9C}" dt="2026-03-18T16:47:51.791" v="304" actId="700"/>
-          <ac:spMkLst>
-            <pc:docMk/>
-            <pc:sldMk cId="0" sldId="289"/>
-            <ac:spMk id="2" creationId="{00000000-0000-0000-0000-000000000000}"/>
-          </ac:spMkLst>
-        </pc:spChg>
-        <pc:spChg chg="add mod ord">
-          <ac:chgData name="Peter Bernhardt" userId="f2333933-0b12-4d6e-972f-f87625423892" providerId="ADAL" clId="{54BAB7D7-C378-4C4A-B0F8-9DF09AB8FC9C}" dt="2026-03-18T16:47:51.791" v="304" actId="700"/>
-          <ac:spMkLst>
-            <pc:docMk/>
-            <pc:sldMk cId="0" sldId="289"/>
-            <ac:spMk id="3" creationId="{2C79806A-06EA-A213-011E-BFD782E8231D}"/>
-          </ac:spMkLst>
-        </pc:spChg>
-      </pc:sldChg>
-      <pc:sldChg chg="modSp del mod">
-        <pc:chgData name="Peter Bernhardt" userId="f2333933-0b12-4d6e-972f-f87625423892" providerId="ADAL" clId="{54BAB7D7-C378-4C4A-B0F8-9DF09AB8FC9C}" dt="2026-03-18T17:27:59.585" v="473" actId="47"/>
-        <pc:sldMkLst>
-          <pc:docMk/>
-          <pc:sldMk cId="0" sldId="290"/>
-        </pc:sldMkLst>
-        <pc:spChg chg="mod">
-          <ac:chgData name="Peter Bernhardt" userId="f2333933-0b12-4d6e-972f-f87625423892" providerId="ADAL" clId="{54BAB7D7-C378-4C4A-B0F8-9DF09AB8FC9C}" dt="2026-03-18T16:41:22.087" v="209" actId="14100"/>
-          <ac:spMkLst>
-            <pc:docMk/>
-            <pc:sldMk cId="0" sldId="290"/>
-            <ac:spMk id="2" creationId="{00000000-0000-0000-0000-000000000000}"/>
-          </ac:spMkLst>
-        </pc:spChg>
-        <pc:spChg chg="mod">
-          <ac:chgData name="Peter Bernhardt" userId="f2333933-0b12-4d6e-972f-f87625423892" providerId="ADAL" clId="{54BAB7D7-C378-4C4A-B0F8-9DF09AB8FC9C}" dt="2026-03-18T16:39:28.921" v="126" actId="27636"/>
-          <ac:spMkLst>
-            <pc:docMk/>
-            <pc:sldMk cId="0" sldId="290"/>
-            <ac:spMk id="3" creationId="{00000000-0000-0000-0000-000000000000}"/>
-          </ac:spMkLst>
-        </pc:spChg>
-      </pc:sldChg>
-      <pc:sldChg chg="modSp del mod">
-        <pc:chgData name="Peter Bernhardt" userId="f2333933-0b12-4d6e-972f-f87625423892" providerId="ADAL" clId="{54BAB7D7-C378-4C4A-B0F8-9DF09AB8FC9C}" dt="2026-03-18T17:27:59.585" v="473" actId="47"/>
-        <pc:sldMkLst>
-          <pc:docMk/>
-          <pc:sldMk cId="0" sldId="291"/>
-        </pc:sldMkLst>
-        <pc:spChg chg="mod">
-          <ac:chgData name="Peter Bernhardt" userId="f2333933-0b12-4d6e-972f-f87625423892" providerId="ADAL" clId="{54BAB7D7-C378-4C4A-B0F8-9DF09AB8FC9C}" dt="2026-03-18T16:39:28.927" v="127" actId="27636"/>
-          <ac:spMkLst>
-            <pc:docMk/>
-            <pc:sldMk cId="0" sldId="291"/>
-            <ac:spMk id="2" creationId="{00000000-0000-0000-0000-000000000000}"/>
-          </ac:spMkLst>
-        </pc:spChg>
-        <pc:spChg chg="mod">
-          <ac:chgData name="Peter Bernhardt" userId="f2333933-0b12-4d6e-972f-f87625423892" providerId="ADAL" clId="{54BAB7D7-C378-4C4A-B0F8-9DF09AB8FC9C}" dt="2026-03-18T16:39:28.931" v="128" actId="27636"/>
-          <ac:spMkLst>
-            <pc:docMk/>
-            <pc:sldMk cId="0" sldId="291"/>
-            <ac:spMk id="3" creationId="{00000000-0000-0000-0000-000000000000}"/>
-          </ac:spMkLst>
-        </pc:spChg>
-      </pc:sldChg>
-      <pc:sldChg chg="modSp del mod">
-        <pc:chgData name="Peter Bernhardt" userId="f2333933-0b12-4d6e-972f-f87625423892" providerId="ADAL" clId="{54BAB7D7-C378-4C4A-B0F8-9DF09AB8FC9C}" dt="2026-03-18T17:27:59.585" v="473" actId="47"/>
-        <pc:sldMkLst>
-          <pc:docMk/>
-          <pc:sldMk cId="0" sldId="292"/>
-        </pc:sldMkLst>
-        <pc:spChg chg="mod">
-          <ac:chgData name="Peter Bernhardt" userId="f2333933-0b12-4d6e-972f-f87625423892" providerId="ADAL" clId="{54BAB7D7-C378-4C4A-B0F8-9DF09AB8FC9C}" dt="2026-03-18T16:39:28.933" v="130" actId="27636"/>
-          <ac:spMkLst>
-            <pc:docMk/>
-            <pc:sldMk cId="0" sldId="292"/>
-            <ac:spMk id="2" creationId="{00000000-0000-0000-0000-000000000000}"/>
-          </ac:spMkLst>
-        </pc:spChg>
-        <pc:spChg chg="mod">
-          <ac:chgData name="Peter Bernhardt" userId="f2333933-0b12-4d6e-972f-f87625423892" providerId="ADAL" clId="{54BAB7D7-C378-4C4A-B0F8-9DF09AB8FC9C}" dt="2026-03-18T16:39:28.933" v="129" actId="27636"/>
-          <ac:spMkLst>
-            <pc:docMk/>
-            <pc:sldMk cId="0" sldId="292"/>
-            <ac:spMk id="3" creationId="{00000000-0000-0000-0000-000000000000}"/>
-          </ac:spMkLst>
-        </pc:spChg>
-      </pc:sldChg>
-      <pc:sldChg chg="modSp del mod">
-        <pc:chgData name="Peter Bernhardt" userId="f2333933-0b12-4d6e-972f-f87625423892" providerId="ADAL" clId="{54BAB7D7-C378-4C4A-B0F8-9DF09AB8FC9C}" dt="2026-03-18T17:27:59.585" v="473" actId="47"/>
-        <pc:sldMkLst>
-          <pc:docMk/>
-          <pc:sldMk cId="0" sldId="293"/>
-        </pc:sldMkLst>
-        <pc:spChg chg="mod">
-          <ac:chgData name="Peter Bernhardt" userId="f2333933-0b12-4d6e-972f-f87625423892" providerId="ADAL" clId="{54BAB7D7-C378-4C4A-B0F8-9DF09AB8FC9C}" dt="2026-03-18T16:39:28.933" v="131" actId="27636"/>
-          <ac:spMkLst>
-            <pc:docMk/>
-            <pc:sldMk cId="0" sldId="293"/>
-            <ac:spMk id="2" creationId="{00000000-0000-0000-0000-000000000000}"/>
-          </ac:spMkLst>
-        </pc:spChg>
-        <pc:spChg chg="mod">
-          <ac:chgData name="Peter Bernhardt" userId="f2333933-0b12-4d6e-972f-f87625423892" providerId="ADAL" clId="{54BAB7D7-C378-4C4A-B0F8-9DF09AB8FC9C}" dt="2026-03-18T16:39:28.949" v="132" actId="27636"/>
-          <ac:spMkLst>
-            <pc:docMk/>
-            <pc:sldMk cId="0" sldId="293"/>
-            <ac:spMk id="3" creationId="{00000000-0000-0000-0000-000000000000}"/>
-          </ac:spMkLst>
-        </pc:spChg>
-      </pc:sldChg>
-      <pc:sldChg chg="modSp del mod">
-        <pc:chgData name="Peter Bernhardt" userId="f2333933-0b12-4d6e-972f-f87625423892" providerId="ADAL" clId="{54BAB7D7-C378-4C4A-B0F8-9DF09AB8FC9C}" dt="2026-03-18T17:27:59.585" v="473" actId="47"/>
-        <pc:sldMkLst>
-          <pc:docMk/>
-          <pc:sldMk cId="0" sldId="294"/>
-        </pc:sldMkLst>
-        <pc:spChg chg="mod">
-          <ac:chgData name="Peter Bernhardt" userId="f2333933-0b12-4d6e-972f-f87625423892" providerId="ADAL" clId="{54BAB7D7-C378-4C4A-B0F8-9DF09AB8FC9C}" dt="2026-03-18T16:39:28.101" v="79" actId="790"/>
-          <ac:spMkLst>
-            <pc:docMk/>
-            <pc:sldMk cId="0" sldId="294"/>
-            <ac:spMk id="2" creationId="{00000000-0000-0000-0000-000000000000}"/>
-          </ac:spMkLst>
-        </pc:spChg>
-        <pc:spChg chg="mod">
-          <ac:chgData name="Peter Bernhardt" userId="f2333933-0b12-4d6e-972f-f87625423892" providerId="ADAL" clId="{54BAB7D7-C378-4C4A-B0F8-9DF09AB8FC9C}" dt="2026-03-18T16:39:28.966" v="133" actId="27636"/>
-          <ac:spMkLst>
-            <pc:docMk/>
-            <pc:sldMk cId="0" sldId="294"/>
-            <ac:spMk id="3" creationId="{00000000-0000-0000-0000-000000000000}"/>
-          </ac:spMkLst>
-        </pc:spChg>
-      </pc:sldChg>
-      <pc:sldChg chg="modSp del mod">
-        <pc:chgData name="Peter Bernhardt" userId="f2333933-0b12-4d6e-972f-f87625423892" providerId="ADAL" clId="{54BAB7D7-C378-4C4A-B0F8-9DF09AB8FC9C}" dt="2026-03-18T17:27:59.585" v="473" actId="47"/>
-        <pc:sldMkLst>
-          <pc:docMk/>
-          <pc:sldMk cId="0" sldId="295"/>
-        </pc:sldMkLst>
-        <pc:spChg chg="mod">
-          <ac:chgData name="Peter Bernhardt" userId="f2333933-0b12-4d6e-972f-f87625423892" providerId="ADAL" clId="{54BAB7D7-C378-4C4A-B0F8-9DF09AB8FC9C}" dt="2026-03-18T16:41:22.087" v="209" actId="14100"/>
-          <ac:spMkLst>
-            <pc:docMk/>
-            <pc:sldMk cId="0" sldId="295"/>
-            <ac:spMk id="2" creationId="{00000000-0000-0000-0000-000000000000}"/>
-          </ac:spMkLst>
-        </pc:spChg>
-        <pc:spChg chg="mod">
-          <ac:chgData name="Peter Bernhardt" userId="f2333933-0b12-4d6e-972f-f87625423892" providerId="ADAL" clId="{54BAB7D7-C378-4C4A-B0F8-9DF09AB8FC9C}" dt="2026-03-18T16:39:28.976" v="135" actId="27636"/>
-          <ac:spMkLst>
-            <pc:docMk/>
-            <pc:sldMk cId="0" sldId="295"/>
-            <ac:spMk id="3" creationId="{00000000-0000-0000-0000-000000000000}"/>
-          </ac:spMkLst>
-        </pc:spChg>
-      </pc:sldChg>
-      <pc:sldChg chg="modSp del mod">
-        <pc:chgData name="Peter Bernhardt" userId="f2333933-0b12-4d6e-972f-f87625423892" providerId="ADAL" clId="{54BAB7D7-C378-4C4A-B0F8-9DF09AB8FC9C}" dt="2026-03-18T17:27:59.585" v="473" actId="47"/>
-        <pc:sldMkLst>
-          <pc:docMk/>
-          <pc:sldMk cId="0" sldId="296"/>
-        </pc:sldMkLst>
-        <pc:spChg chg="mod">
-          <ac:chgData name="Peter Bernhardt" userId="f2333933-0b12-4d6e-972f-f87625423892" providerId="ADAL" clId="{54BAB7D7-C378-4C4A-B0F8-9DF09AB8FC9C}" dt="2026-03-18T17:16:52.359" v="442" actId="20577"/>
-          <ac:spMkLst>
-            <pc:docMk/>
-            <pc:sldMk cId="0" sldId="296"/>
-            <ac:spMk id="2" creationId="{00000000-0000-0000-0000-000000000000}"/>
-          </ac:spMkLst>
-        </pc:spChg>
-        <pc:spChg chg="mod">
-          <ac:chgData name="Peter Bernhardt" userId="f2333933-0b12-4d6e-972f-f87625423892" providerId="ADAL" clId="{54BAB7D7-C378-4C4A-B0F8-9DF09AB8FC9C}" dt="2026-03-18T16:39:28.101" v="79" actId="790"/>
-          <ac:spMkLst>
-            <pc:docMk/>
-            <pc:sldMk cId="0" sldId="296"/>
-            <ac:spMk id="3" creationId="{00000000-0000-0000-0000-000000000000}"/>
-          </ac:spMkLst>
-        </pc:spChg>
-      </pc:sldChg>
-      <pc:sldChg chg="modSp del mod">
-        <pc:chgData name="Peter Bernhardt" userId="f2333933-0b12-4d6e-972f-f87625423892" providerId="ADAL" clId="{54BAB7D7-C378-4C4A-B0F8-9DF09AB8FC9C}" dt="2026-03-18T17:27:59.585" v="473" actId="47"/>
-        <pc:sldMkLst>
-          <pc:docMk/>
-          <pc:sldMk cId="0" sldId="297"/>
-        </pc:sldMkLst>
-        <pc:spChg chg="mod">
-          <ac:chgData name="Peter Bernhardt" userId="f2333933-0b12-4d6e-972f-f87625423892" providerId="ADAL" clId="{54BAB7D7-C378-4C4A-B0F8-9DF09AB8FC9C}" dt="2026-03-18T16:39:28.101" v="79" actId="790"/>
-          <ac:spMkLst>
-            <pc:docMk/>
-            <pc:sldMk cId="0" sldId="297"/>
-            <ac:spMk id="2" creationId="{00000000-0000-0000-0000-000000000000}"/>
-          </ac:spMkLst>
-        </pc:spChg>
-        <pc:spChg chg="mod">
-          <ac:chgData name="Peter Bernhardt" userId="f2333933-0b12-4d6e-972f-f87625423892" providerId="ADAL" clId="{54BAB7D7-C378-4C4A-B0F8-9DF09AB8FC9C}" dt="2026-03-18T16:39:28.979" v="136" actId="27636"/>
-          <ac:spMkLst>
-            <pc:docMk/>
-            <pc:sldMk cId="0" sldId="297"/>
-            <ac:spMk id="3" creationId="{00000000-0000-0000-0000-000000000000}"/>
-          </ac:spMkLst>
-        </pc:spChg>
-      </pc:sldChg>
-      <pc:sldChg chg="modSp del mod modClrScheme chgLayout">
-        <pc:chgData name="Peter Bernhardt" userId="f2333933-0b12-4d6e-972f-f87625423892" providerId="ADAL" clId="{54BAB7D7-C378-4C4A-B0F8-9DF09AB8FC9C}" dt="2026-03-18T17:27:59.585" v="473" actId="47"/>
-        <pc:sldMkLst>
-          <pc:docMk/>
-          <pc:sldMk cId="0" sldId="298"/>
-        </pc:sldMkLst>
-        <pc:spChg chg="mod ord">
-          <ac:chgData name="Peter Bernhardt" userId="f2333933-0b12-4d6e-972f-f87625423892" providerId="ADAL" clId="{54BAB7D7-C378-4C4A-B0F8-9DF09AB8FC9C}" dt="2026-03-18T17:02:45.579" v="309" actId="27636"/>
-          <ac:spMkLst>
-            <pc:docMk/>
-            <pc:sldMk cId="0" sldId="298"/>
-            <ac:spMk id="2" creationId="{00000000-0000-0000-0000-000000000000}"/>
-          </ac:spMkLst>
-        </pc:spChg>
-        <pc:spChg chg="mod ord">
-          <ac:chgData name="Peter Bernhardt" userId="f2333933-0b12-4d6e-972f-f87625423892" providerId="ADAL" clId="{54BAB7D7-C378-4C4A-B0F8-9DF09AB8FC9C}" dt="2026-03-18T17:04:06.022" v="330" actId="20577"/>
-          <ac:spMkLst>
-            <pc:docMk/>
-            <pc:sldMk cId="0" sldId="298"/>
-            <ac:spMk id="4" creationId="{00000000-0000-0000-0000-000000000000}"/>
-          </ac:spMkLst>
-        </pc:spChg>
-        <pc:graphicFrameChg chg="mod ord modGraphic">
-          <ac:chgData name="Peter Bernhardt" userId="f2333933-0b12-4d6e-972f-f87625423892" providerId="ADAL" clId="{54BAB7D7-C378-4C4A-B0F8-9DF09AB8FC9C}" dt="2026-03-18T17:03:47.041" v="317" actId="1076"/>
-          <ac:graphicFrameMkLst>
-            <pc:docMk/>
-            <pc:sldMk cId="0" sldId="298"/>
-            <ac:graphicFrameMk id="6" creationId="{00000000-0000-0000-0000-000000000000}"/>
-          </ac:graphicFrameMkLst>
-        </pc:graphicFrameChg>
-      </pc:sldChg>
-      <pc:sldChg chg="modSp del mod">
-        <pc:chgData name="Peter Bernhardt" userId="f2333933-0b12-4d6e-972f-f87625423892" providerId="ADAL" clId="{54BAB7D7-C378-4C4A-B0F8-9DF09AB8FC9C}" dt="2026-03-18T17:04:17.363" v="331" actId="47"/>
-        <pc:sldMkLst>
-          <pc:docMk/>
-          <pc:sldMk cId="0" sldId="299"/>
-        </pc:sldMkLst>
-        <pc:spChg chg="mod">
-          <ac:chgData name="Peter Bernhardt" userId="f2333933-0b12-4d6e-972f-f87625423892" providerId="ADAL" clId="{54BAB7D7-C378-4C4A-B0F8-9DF09AB8FC9C}" dt="2026-03-18T16:39:28.101" v="79" actId="790"/>
-          <ac:spMkLst>
-            <pc:docMk/>
-            <pc:sldMk cId="0" sldId="299"/>
-            <ac:spMk id="3" creationId="{00000000-0000-0000-0000-000000000000}"/>
-          </ac:spMkLst>
-        </pc:spChg>
-      </pc:sldChg>
-      <pc:sldChg chg="modSp del mod">
-        <pc:chgData name="Peter Bernhardt" userId="f2333933-0b12-4d6e-972f-f87625423892" providerId="ADAL" clId="{54BAB7D7-C378-4C4A-B0F8-9DF09AB8FC9C}" dt="2026-03-18T17:27:59.585" v="473" actId="47"/>
-        <pc:sldMkLst>
-          <pc:docMk/>
-          <pc:sldMk cId="0" sldId="300"/>
-        </pc:sldMkLst>
-        <pc:spChg chg="mod">
-          <ac:chgData name="Peter Bernhardt" userId="f2333933-0b12-4d6e-972f-f87625423892" providerId="ADAL" clId="{54BAB7D7-C378-4C4A-B0F8-9DF09AB8FC9C}" dt="2026-03-18T16:39:28.101" v="79" actId="790"/>
-          <ac:spMkLst>
-            <pc:docMk/>
-            <pc:sldMk cId="0" sldId="300"/>
-            <ac:spMk id="2" creationId="{00000000-0000-0000-0000-000000000000}"/>
-          </ac:spMkLst>
-        </pc:spChg>
-        <pc:spChg chg="mod">
-          <ac:chgData name="Peter Bernhardt" userId="f2333933-0b12-4d6e-972f-f87625423892" providerId="ADAL" clId="{54BAB7D7-C378-4C4A-B0F8-9DF09AB8FC9C}" dt="2026-03-18T16:39:28.994" v="138" actId="27636"/>
-          <ac:spMkLst>
-            <pc:docMk/>
-            <pc:sldMk cId="0" sldId="300"/>
-            <ac:spMk id="3" creationId="{00000000-0000-0000-0000-000000000000}"/>
-          </ac:spMkLst>
-        </pc:spChg>
-      </pc:sldChg>
-      <pc:sldChg chg="modSp del mod">
-        <pc:chgData name="Peter Bernhardt" userId="f2333933-0b12-4d6e-972f-f87625423892" providerId="ADAL" clId="{54BAB7D7-C378-4C4A-B0F8-9DF09AB8FC9C}" dt="2026-03-18T17:27:59.585" v="473" actId="47"/>
-        <pc:sldMkLst>
-          <pc:docMk/>
-          <pc:sldMk cId="0" sldId="301"/>
-        </pc:sldMkLst>
-        <pc:spChg chg="mod">
-          <ac:chgData name="Peter Bernhardt" userId="f2333933-0b12-4d6e-972f-f87625423892" providerId="ADAL" clId="{54BAB7D7-C378-4C4A-B0F8-9DF09AB8FC9C}" dt="2026-03-18T16:41:22.087" v="209" actId="14100"/>
-          <ac:spMkLst>
-            <pc:docMk/>
-            <pc:sldMk cId="0" sldId="301"/>
-            <ac:spMk id="2" creationId="{00000000-0000-0000-0000-000000000000}"/>
-          </ac:spMkLst>
-        </pc:spChg>
-        <pc:spChg chg="mod">
-          <ac:chgData name="Peter Bernhardt" userId="f2333933-0b12-4d6e-972f-f87625423892" providerId="ADAL" clId="{54BAB7D7-C378-4C4A-B0F8-9DF09AB8FC9C}" dt="2026-03-18T16:39:29.008" v="140" actId="27636"/>
-          <ac:spMkLst>
-            <pc:docMk/>
-            <pc:sldMk cId="0" sldId="301"/>
-            <ac:spMk id="3" creationId="{00000000-0000-0000-0000-000000000000}"/>
-          </ac:spMkLst>
-        </pc:spChg>
-      </pc:sldChg>
-      <pc:sldChg chg="modSp del mod">
-        <pc:chgData name="Peter Bernhardt" userId="f2333933-0b12-4d6e-972f-f87625423892" providerId="ADAL" clId="{54BAB7D7-C378-4C4A-B0F8-9DF09AB8FC9C}" dt="2026-03-18T17:27:59.585" v="473" actId="47"/>
-        <pc:sldMkLst>
-          <pc:docMk/>
-          <pc:sldMk cId="0" sldId="302"/>
-        </pc:sldMkLst>
-        <pc:spChg chg="mod">
-          <ac:chgData name="Peter Bernhardt" userId="f2333933-0b12-4d6e-972f-f87625423892" providerId="ADAL" clId="{54BAB7D7-C378-4C4A-B0F8-9DF09AB8FC9C}" dt="2026-03-18T16:39:29.012" v="141" actId="27636"/>
-          <ac:spMkLst>
-            <pc:docMk/>
-            <pc:sldMk cId="0" sldId="302"/>
-            <ac:spMk id="2" creationId="{00000000-0000-0000-0000-000000000000}"/>
-          </ac:spMkLst>
-        </pc:spChg>
-        <pc:spChg chg="mod">
-          <ac:chgData name="Peter Bernhardt" userId="f2333933-0b12-4d6e-972f-f87625423892" providerId="ADAL" clId="{54BAB7D7-C378-4C4A-B0F8-9DF09AB8FC9C}" dt="2026-03-18T16:39:29.014" v="142" actId="27636"/>
-          <ac:spMkLst>
-            <pc:docMk/>
-            <pc:sldMk cId="0" sldId="302"/>
-            <ac:spMk id="3" creationId="{00000000-0000-0000-0000-000000000000}"/>
-          </ac:spMkLst>
-        </pc:spChg>
-      </pc:sldChg>
-      <pc:sldChg chg="addSp delSp modSp del mod">
-        <pc:chgData name="Peter Bernhardt" userId="f2333933-0b12-4d6e-972f-f87625423892" providerId="ADAL" clId="{54BAB7D7-C378-4C4A-B0F8-9DF09AB8FC9C}" dt="2026-03-18T17:27:59.585" v="473" actId="47"/>
-        <pc:sldMkLst>
-          <pc:docMk/>
-          <pc:sldMk cId="0" sldId="303"/>
-        </pc:sldMkLst>
-        <pc:spChg chg="mod">
-          <ac:chgData name="Peter Bernhardt" userId="f2333933-0b12-4d6e-972f-f87625423892" providerId="ADAL" clId="{54BAB7D7-C378-4C4A-B0F8-9DF09AB8FC9C}" dt="2026-03-18T17:11:20.837" v="369" actId="20577"/>
-          <ac:spMkLst>
-            <pc:docMk/>
-            <pc:sldMk cId="0" sldId="303"/>
-            <ac:spMk id="2" creationId="{00000000-0000-0000-0000-000000000000}"/>
-          </ac:spMkLst>
-        </pc:spChg>
-        <pc:spChg chg="mod">
-          <ac:chgData name="Peter Bernhardt" userId="f2333933-0b12-4d6e-972f-f87625423892" providerId="ADAL" clId="{54BAB7D7-C378-4C4A-B0F8-9DF09AB8FC9C}" dt="2026-03-18T17:16:09.887" v="438" actId="27636"/>
-          <ac:spMkLst>
-            <pc:docMk/>
-            <pc:sldMk cId="0" sldId="303"/>
-            <ac:spMk id="3" creationId="{00000000-0000-0000-0000-000000000000}"/>
-          </ac:spMkLst>
-        </pc:spChg>
-        <pc:grpChg chg="add mod">
-          <ac:chgData name="Peter Bernhardt" userId="f2333933-0b12-4d6e-972f-f87625423892" providerId="ADAL" clId="{54BAB7D7-C378-4C4A-B0F8-9DF09AB8FC9C}" dt="2026-03-18T17:13:08.640" v="392" actId="14100"/>
-          <ac:grpSpMkLst>
-            <pc:docMk/>
-            <pc:sldMk cId="0" sldId="303"/>
-            <ac:grpSpMk id="10" creationId="{C8B658D4-67D0-EA1C-5507-2CCA466560CB}"/>
-          </ac:grpSpMkLst>
-        </pc:grpChg>
-        <pc:picChg chg="add del mod">
-          <ac:chgData name="Peter Bernhardt" userId="f2333933-0b12-4d6e-972f-f87625423892" providerId="ADAL" clId="{54BAB7D7-C378-4C4A-B0F8-9DF09AB8FC9C}" dt="2026-03-18T17:11:34.679" v="372" actId="478"/>
-          <ac:picMkLst>
-            <pc:docMk/>
-            <pc:sldMk cId="0" sldId="303"/>
-            <ac:picMk id="5" creationId="{4F912428-C8C8-1ADF-ED4F-3486638CF6B1}"/>
-          </ac:picMkLst>
-        </pc:picChg>
-        <pc:picChg chg="add mod">
-          <ac:chgData name="Peter Bernhardt" userId="f2333933-0b12-4d6e-972f-f87625423892" providerId="ADAL" clId="{54BAB7D7-C378-4C4A-B0F8-9DF09AB8FC9C}" dt="2026-03-18T17:12:24.161" v="381" actId="164"/>
-          <ac:picMkLst>
-            <pc:docMk/>
-            <pc:sldMk cId="0" sldId="303"/>
-            <ac:picMk id="7" creationId="{947B2390-B0EC-259F-930A-6900CD497B7D}"/>
-          </ac:picMkLst>
-        </pc:picChg>
-        <pc:picChg chg="add mod">
-          <ac:chgData name="Peter Bernhardt" userId="f2333933-0b12-4d6e-972f-f87625423892" providerId="ADAL" clId="{54BAB7D7-C378-4C4A-B0F8-9DF09AB8FC9C}" dt="2026-03-18T17:12:24.161" v="381" actId="164"/>
-          <ac:picMkLst>
-            <pc:docMk/>
-            <pc:sldMk cId="0" sldId="303"/>
-            <ac:picMk id="9" creationId="{C9D17E6C-6CEC-E98A-6B0B-52194B236241}"/>
-          </ac:picMkLst>
-        </pc:picChg>
-      </pc:sldChg>
-      <pc:sldChg chg="addSp modSp del mod chgLayout">
-        <pc:chgData name="Peter Bernhardt" userId="f2333933-0b12-4d6e-972f-f87625423892" providerId="ADAL" clId="{54BAB7D7-C378-4C4A-B0F8-9DF09AB8FC9C}" dt="2026-03-18T17:27:59.585" v="473" actId="47"/>
-        <pc:sldMkLst>
-          <pc:docMk/>
-          <pc:sldMk cId="0" sldId="304"/>
-        </pc:sldMkLst>
-        <pc:spChg chg="mod ord">
-          <ac:chgData name="Peter Bernhardt" userId="f2333933-0b12-4d6e-972f-f87625423892" providerId="ADAL" clId="{54BAB7D7-C378-4C4A-B0F8-9DF09AB8FC9C}" dt="2026-03-18T16:48:06.705" v="306" actId="700"/>
-          <ac:spMkLst>
-            <pc:docMk/>
-            <pc:sldMk cId="0" sldId="304"/>
-            <ac:spMk id="2" creationId="{00000000-0000-0000-0000-000000000000}"/>
-          </ac:spMkLst>
-        </pc:spChg>
-        <pc:spChg chg="add mod ord">
-          <ac:chgData name="Peter Bernhardt" userId="f2333933-0b12-4d6e-972f-f87625423892" providerId="ADAL" clId="{54BAB7D7-C378-4C4A-B0F8-9DF09AB8FC9C}" dt="2026-03-18T16:48:06.705" v="306" actId="700"/>
-          <ac:spMkLst>
-            <pc:docMk/>
-            <pc:sldMk cId="0" sldId="304"/>
-            <ac:spMk id="3" creationId="{25E75BA3-E6A0-72F3-7B54-1EBCF166B9C6}"/>
-          </ac:spMkLst>
-        </pc:spChg>
-      </pc:sldChg>
-      <pc:sldChg chg="modSp del mod">
-        <pc:chgData name="Peter Bernhardt" userId="f2333933-0b12-4d6e-972f-f87625423892" providerId="ADAL" clId="{54BAB7D7-C378-4C4A-B0F8-9DF09AB8FC9C}" dt="2026-03-18T17:27:59.585" v="473" actId="47"/>
-        <pc:sldMkLst>
-          <pc:docMk/>
-          <pc:sldMk cId="0" sldId="305"/>
-        </pc:sldMkLst>
-        <pc:spChg chg="mod">
-          <ac:chgData name="Peter Bernhardt" userId="f2333933-0b12-4d6e-972f-f87625423892" providerId="ADAL" clId="{54BAB7D7-C378-4C4A-B0F8-9DF09AB8FC9C}" dt="2026-03-18T16:39:28.101" v="79" actId="790"/>
-          <ac:spMkLst>
-            <pc:docMk/>
-            <pc:sldMk cId="0" sldId="305"/>
-            <ac:spMk id="2" creationId="{00000000-0000-0000-0000-000000000000}"/>
-          </ac:spMkLst>
-        </pc:spChg>
-        <pc:spChg chg="mod">
-          <ac:chgData name="Peter Bernhardt" userId="f2333933-0b12-4d6e-972f-f87625423892" providerId="ADAL" clId="{54BAB7D7-C378-4C4A-B0F8-9DF09AB8FC9C}" dt="2026-03-18T16:39:29.041" v="146" actId="27636"/>
-          <ac:spMkLst>
-            <pc:docMk/>
-            <pc:sldMk cId="0" sldId="305"/>
-            <ac:spMk id="3" creationId="{00000000-0000-0000-0000-000000000000}"/>
-          </ac:spMkLst>
-        </pc:spChg>
-      </pc:sldChg>
-      <pc:sldChg chg="modSp del mod">
-        <pc:chgData name="Peter Bernhardt" userId="f2333933-0b12-4d6e-972f-f87625423892" providerId="ADAL" clId="{54BAB7D7-C378-4C4A-B0F8-9DF09AB8FC9C}" dt="2026-03-18T17:27:59.585" v="473" actId="47"/>
-        <pc:sldMkLst>
-          <pc:docMk/>
-          <pc:sldMk cId="0" sldId="306"/>
-        </pc:sldMkLst>
-        <pc:spChg chg="mod">
-          <ac:chgData name="Peter Bernhardt" userId="f2333933-0b12-4d6e-972f-f87625423892" providerId="ADAL" clId="{54BAB7D7-C378-4C4A-B0F8-9DF09AB8FC9C}" dt="2026-03-18T16:39:29.043" v="147" actId="27636"/>
-          <ac:spMkLst>
-            <pc:docMk/>
-            <pc:sldMk cId="0" sldId="306"/>
-            <ac:spMk id="2" creationId="{00000000-0000-0000-0000-000000000000}"/>
-          </ac:spMkLst>
-        </pc:spChg>
-        <pc:spChg chg="mod">
-          <ac:chgData name="Peter Bernhardt" userId="f2333933-0b12-4d6e-972f-f87625423892" providerId="ADAL" clId="{54BAB7D7-C378-4C4A-B0F8-9DF09AB8FC9C}" dt="2026-03-18T16:39:29.055" v="148" actId="27636"/>
-          <ac:spMkLst>
-            <pc:docMk/>
-            <pc:sldMk cId="0" sldId="306"/>
-            <ac:spMk id="3" creationId="{00000000-0000-0000-0000-000000000000}"/>
-          </ac:spMkLst>
-        </pc:spChg>
-      </pc:sldChg>
-      <pc:sldChg chg="modSp del mod">
-        <pc:chgData name="Peter Bernhardt" userId="f2333933-0b12-4d6e-972f-f87625423892" providerId="ADAL" clId="{54BAB7D7-C378-4C4A-B0F8-9DF09AB8FC9C}" dt="2026-03-18T17:27:59.585" v="473" actId="47"/>
-        <pc:sldMkLst>
-          <pc:docMk/>
-          <pc:sldMk cId="0" sldId="307"/>
-        </pc:sldMkLst>
-        <pc:spChg chg="mod">
-          <ac:chgData name="Peter Bernhardt" userId="f2333933-0b12-4d6e-972f-f87625423892" providerId="ADAL" clId="{54BAB7D7-C378-4C4A-B0F8-9DF09AB8FC9C}" dt="2026-03-18T16:39:28.101" v="79" actId="790"/>
-          <ac:spMkLst>
-            <pc:docMk/>
-            <pc:sldMk cId="0" sldId="307"/>
-            <ac:spMk id="2" creationId="{00000000-0000-0000-0000-000000000000}"/>
-          </ac:spMkLst>
-        </pc:spChg>
-        <pc:spChg chg="mod">
-          <ac:chgData name="Peter Bernhardt" userId="f2333933-0b12-4d6e-972f-f87625423892" providerId="ADAL" clId="{54BAB7D7-C378-4C4A-B0F8-9DF09AB8FC9C}" dt="2026-03-18T17:14:02.058" v="402" actId="20577"/>
-          <ac:spMkLst>
-            <pc:docMk/>
-            <pc:sldMk cId="0" sldId="307"/>
-            <ac:spMk id="3" creationId="{00000000-0000-0000-0000-000000000000}"/>
-          </ac:spMkLst>
-        </pc:spChg>
-      </pc:sldChg>
-      <pc:sldChg chg="modSp del mod">
-        <pc:chgData name="Peter Bernhardt" userId="f2333933-0b12-4d6e-972f-f87625423892" providerId="ADAL" clId="{54BAB7D7-C378-4C4A-B0F8-9DF09AB8FC9C}" dt="2026-03-18T17:27:59.585" v="473" actId="47"/>
-        <pc:sldMkLst>
-          <pc:docMk/>
-          <pc:sldMk cId="0" sldId="308"/>
-        </pc:sldMkLst>
-        <pc:spChg chg="mod">
-          <ac:chgData name="Peter Bernhardt" userId="f2333933-0b12-4d6e-972f-f87625423892" providerId="ADAL" clId="{54BAB7D7-C378-4C4A-B0F8-9DF09AB8FC9C}" dt="2026-03-18T16:39:28.101" v="79" actId="790"/>
-          <ac:spMkLst>
-            <pc:docMk/>
-            <pc:sldMk cId="0" sldId="308"/>
-            <ac:spMk id="2" creationId="{00000000-0000-0000-0000-000000000000}"/>
-          </ac:spMkLst>
-        </pc:spChg>
-        <pc:spChg chg="mod">
-          <ac:chgData name="Peter Bernhardt" userId="f2333933-0b12-4d6e-972f-f87625423892" providerId="ADAL" clId="{54BAB7D7-C378-4C4A-B0F8-9DF09AB8FC9C}" dt="2026-03-18T16:39:29.174" v="150" actId="27636"/>
-          <ac:spMkLst>
-            <pc:docMk/>
-            <pc:sldMk cId="0" sldId="308"/>
-            <ac:spMk id="3" creationId="{00000000-0000-0000-0000-000000000000}"/>
-          </ac:spMkLst>
-        </pc:spChg>
-      </pc:sldChg>
-      <pc:sldChg chg="addSp modSp del mod chgLayout">
-        <pc:chgData name="Peter Bernhardt" userId="f2333933-0b12-4d6e-972f-f87625423892" providerId="ADAL" clId="{54BAB7D7-C378-4C4A-B0F8-9DF09AB8FC9C}" dt="2026-03-18T17:27:59.585" v="473" actId="47"/>
-        <pc:sldMkLst>
-          <pc:docMk/>
-          <pc:sldMk cId="0" sldId="309"/>
-        </pc:sldMkLst>
-        <pc:spChg chg="mod ord">
-          <ac:chgData name="Peter Bernhardt" userId="f2333933-0b12-4d6e-972f-f87625423892" providerId="ADAL" clId="{54BAB7D7-C378-4C4A-B0F8-9DF09AB8FC9C}" dt="2026-03-18T16:48:01.054" v="305" actId="700"/>
-          <ac:spMkLst>
-            <pc:docMk/>
-            <pc:sldMk cId="0" sldId="309"/>
-            <ac:spMk id="2" creationId="{00000000-0000-0000-0000-000000000000}"/>
-          </ac:spMkLst>
-        </pc:spChg>
-        <pc:spChg chg="add mod ord">
-          <ac:chgData name="Peter Bernhardt" userId="f2333933-0b12-4d6e-972f-f87625423892" providerId="ADAL" clId="{54BAB7D7-C378-4C4A-B0F8-9DF09AB8FC9C}" dt="2026-03-18T16:48:01.054" v="305" actId="700"/>
-          <ac:spMkLst>
-            <pc:docMk/>
-            <pc:sldMk cId="0" sldId="309"/>
-            <ac:spMk id="3" creationId="{9949AC46-4BA5-444E-F92D-A58BAB78CCE1}"/>
-          </ac:spMkLst>
-        </pc:spChg>
-      </pc:sldChg>
-      <pc:sldChg chg="modSp del mod">
-        <pc:chgData name="Peter Bernhardt" userId="f2333933-0b12-4d6e-972f-f87625423892" providerId="ADAL" clId="{54BAB7D7-C378-4C4A-B0F8-9DF09AB8FC9C}" dt="2026-03-18T17:27:59.585" v="473" actId="47"/>
-        <pc:sldMkLst>
-          <pc:docMk/>
-          <pc:sldMk cId="0" sldId="310"/>
-        </pc:sldMkLst>
-        <pc:spChg chg="mod">
-          <ac:chgData name="Peter Bernhardt" userId="f2333933-0b12-4d6e-972f-f87625423892" providerId="ADAL" clId="{54BAB7D7-C378-4C4A-B0F8-9DF09AB8FC9C}" dt="2026-03-18T16:39:28.101" v="79" actId="790"/>
-          <ac:spMkLst>
-            <pc:docMk/>
-            <pc:sldMk cId="0" sldId="310"/>
-            <ac:spMk id="2" creationId="{00000000-0000-0000-0000-000000000000}"/>
-          </ac:spMkLst>
-        </pc:spChg>
-        <pc:spChg chg="mod">
-          <ac:chgData name="Peter Bernhardt" userId="f2333933-0b12-4d6e-972f-f87625423892" providerId="ADAL" clId="{54BAB7D7-C378-4C4A-B0F8-9DF09AB8FC9C}" dt="2026-03-18T16:39:29.187" v="151" actId="27636"/>
-          <ac:spMkLst>
-            <pc:docMk/>
-            <pc:sldMk cId="0" sldId="310"/>
-            <ac:spMk id="3" creationId="{00000000-0000-0000-0000-000000000000}"/>
-          </ac:spMkLst>
-        </pc:spChg>
-      </pc:sldChg>
-      <pc:sldChg chg="modSp del mod">
-        <pc:chgData name="Peter Bernhardt" userId="f2333933-0b12-4d6e-972f-f87625423892" providerId="ADAL" clId="{54BAB7D7-C378-4C4A-B0F8-9DF09AB8FC9C}" dt="2026-03-18T17:27:59.585" v="473" actId="47"/>
-        <pc:sldMkLst>
-          <pc:docMk/>
-          <pc:sldMk cId="0" sldId="311"/>
-        </pc:sldMkLst>
-        <pc:spChg chg="mod">
-          <ac:chgData name="Peter Bernhardt" userId="f2333933-0b12-4d6e-972f-f87625423892" providerId="ADAL" clId="{54BAB7D7-C378-4C4A-B0F8-9DF09AB8FC9C}" dt="2026-03-18T16:39:28.101" v="79" actId="790"/>
-          <ac:spMkLst>
-            <pc:docMk/>
-            <pc:sldMk cId="0" sldId="311"/>
-            <ac:spMk id="2" creationId="{00000000-0000-0000-0000-000000000000}"/>
-          </ac:spMkLst>
-        </pc:spChg>
-        <pc:spChg chg="mod">
-          <ac:chgData name="Peter Bernhardt" userId="f2333933-0b12-4d6e-972f-f87625423892" providerId="ADAL" clId="{54BAB7D7-C378-4C4A-B0F8-9DF09AB8FC9C}" dt="2026-03-18T16:39:29.197" v="152" actId="27636"/>
-          <ac:spMkLst>
-            <pc:docMk/>
-            <pc:sldMk cId="0" sldId="311"/>
-            <ac:spMk id="3" creationId="{00000000-0000-0000-0000-000000000000}"/>
-          </ac:spMkLst>
-        </pc:spChg>
-      </pc:sldChg>
-      <pc:sldChg chg="modSp add del mod chgLayout">
-        <pc:chgData name="Peter Bernhardt" userId="f2333933-0b12-4d6e-972f-f87625423892" providerId="ADAL" clId="{54BAB7D7-C378-4C4A-B0F8-9DF09AB8FC9C}" dt="2026-03-18T17:29:26.037" v="493" actId="6549"/>
-        <pc:sldMkLst>
-          <pc:docMk/>
-          <pc:sldMk cId="0" sldId="312"/>
-        </pc:sldMkLst>
-        <pc:spChg chg="mod ord">
-          <ac:chgData name="Peter Bernhardt" userId="f2333933-0b12-4d6e-972f-f87625423892" providerId="ADAL" clId="{54BAB7D7-C378-4C4A-B0F8-9DF09AB8FC9C}" dt="2026-03-18T17:29:26.037" v="493" actId="6549"/>
-          <ac:spMkLst>
-            <pc:docMk/>
-            <pc:sldMk cId="0" sldId="312"/>
-            <ac:spMk id="2" creationId="{00000000-0000-0000-0000-000000000000}"/>
-          </ac:spMkLst>
-        </pc:spChg>
-        <pc:spChg chg="mod ord">
-          <ac:chgData name="Peter Bernhardt" userId="f2333933-0b12-4d6e-972f-f87625423892" providerId="ADAL" clId="{54BAB7D7-C378-4C4A-B0F8-9DF09AB8FC9C}" dt="2026-03-18T17:28:08.391" v="474" actId="700"/>
-          <ac:spMkLst>
-            <pc:docMk/>
-            <pc:sldMk cId="0" sldId="312"/>
-            <ac:spMk id="3" creationId="{00000000-0000-0000-0000-000000000000}"/>
-          </ac:spMkLst>
-        </pc:spChg>
-        <pc:spChg chg="mod ord">
-          <ac:chgData name="Peter Bernhardt" userId="f2333933-0b12-4d6e-972f-f87625423892" providerId="ADAL" clId="{54BAB7D7-C378-4C4A-B0F8-9DF09AB8FC9C}" dt="2026-03-18T17:28:08.391" v="474" actId="700"/>
-          <ac:spMkLst>
-            <pc:docMk/>
-            <pc:sldMk cId="0" sldId="312"/>
-            <ac:spMk id="4" creationId="{00000000-0000-0000-0000-000000000000}"/>
-          </ac:spMkLst>
-        </pc:spChg>
-      </pc:sldChg>
-      <pc:sldChg chg="addSp delSp modSp add del mod chgLayout">
-        <pc:chgData name="Peter Bernhardt" userId="f2333933-0b12-4d6e-972f-f87625423892" providerId="ADAL" clId="{54BAB7D7-C378-4C4A-B0F8-9DF09AB8FC9C}" dt="2026-03-18T17:28:15.020" v="479" actId="700"/>
-        <pc:sldMkLst>
-          <pc:docMk/>
-          <pc:sldMk cId="0" sldId="313"/>
-        </pc:sldMkLst>
-        <pc:spChg chg="mod ord">
-          <ac:chgData name="Peter Bernhardt" userId="f2333933-0b12-4d6e-972f-f87625423892" providerId="ADAL" clId="{54BAB7D7-C378-4C4A-B0F8-9DF09AB8FC9C}" dt="2026-03-18T17:28:15.020" v="479" actId="700"/>
-          <ac:spMkLst>
-            <pc:docMk/>
-            <pc:sldMk cId="0" sldId="313"/>
-            <ac:spMk id="2" creationId="{00000000-0000-0000-0000-000000000000}"/>
-          </ac:spMkLst>
-        </pc:spChg>
-        <pc:spChg chg="del">
-          <ac:chgData name="Peter Bernhardt" userId="f2333933-0b12-4d6e-972f-f87625423892" providerId="ADAL" clId="{54BAB7D7-C378-4C4A-B0F8-9DF09AB8FC9C}" dt="2026-03-18T17:28:15.020" v="479" actId="700"/>
-          <ac:spMkLst>
-            <pc:docMk/>
-            <pc:sldMk cId="0" sldId="313"/>
-            <ac:spMk id="3" creationId="{8A36CD9A-91E0-2471-4620-382EBD68A123}"/>
-          </ac:spMkLst>
-        </pc:spChg>
-        <pc:spChg chg="mod">
-          <ac:chgData name="Peter Bernhardt" userId="f2333933-0b12-4d6e-972f-f87625423892" providerId="ADAL" clId="{54BAB7D7-C378-4C4A-B0F8-9DF09AB8FC9C}" dt="2026-03-18T16:39:29.215" v="154" actId="27636"/>
-          <ac:spMkLst>
-            <pc:docMk/>
-            <pc:sldMk cId="0" sldId="313"/>
-            <ac:spMk id="4" creationId="{00000000-0000-0000-0000-000000000000}"/>
-          </ac:spMkLst>
-        </pc:spChg>
-        <pc:spChg chg="add mod ord">
-          <ac:chgData name="Peter Bernhardt" userId="f2333933-0b12-4d6e-972f-f87625423892" providerId="ADAL" clId="{54BAB7D7-C378-4C4A-B0F8-9DF09AB8FC9C}" dt="2026-03-18T17:28:15.020" v="479" actId="700"/>
-          <ac:spMkLst>
-            <pc:docMk/>
-            <pc:sldMk cId="0" sldId="313"/>
-            <ac:spMk id="4" creationId="{7D63386B-EBA3-9B81-3CD0-6DCA7352DF28}"/>
-          </ac:spMkLst>
-        </pc:spChg>
-        <pc:graphicFrameChg chg="mod modGraphic">
-          <ac:chgData name="Peter Bernhardt" userId="f2333933-0b12-4d6e-972f-f87625423892" providerId="ADAL" clId="{54BAB7D7-C378-4C4A-B0F8-9DF09AB8FC9C}" dt="2026-03-18T16:39:28.101" v="79" actId="790"/>
-          <ac:graphicFrameMkLst>
-            <pc:docMk/>
-            <pc:sldMk cId="0" sldId="313"/>
-            <ac:graphicFrameMk id="6" creationId="{00000000-0000-0000-0000-000000000000}"/>
-          </ac:graphicFrameMkLst>
-        </pc:graphicFrameChg>
-      </pc:sldChg>
-      <pc:sldChg chg="addSp delSp modSp add del mod chgLayout">
-        <pc:chgData name="Peter Bernhardt" userId="f2333933-0b12-4d6e-972f-f87625423892" providerId="ADAL" clId="{54BAB7D7-C378-4C4A-B0F8-9DF09AB8FC9C}" dt="2026-03-18T17:33:00.254" v="530" actId="27636"/>
-        <pc:sldMkLst>
-          <pc:docMk/>
-          <pc:sldMk cId="0" sldId="314"/>
-        </pc:sldMkLst>
-        <pc:spChg chg="mod ord">
-          <ac:chgData name="Peter Bernhardt" userId="f2333933-0b12-4d6e-972f-f87625423892" providerId="ADAL" clId="{54BAB7D7-C378-4C4A-B0F8-9DF09AB8FC9C}" dt="2026-03-18T17:30:24.431" v="508" actId="6264"/>
-          <ac:spMkLst>
-            <pc:docMk/>
-            <pc:sldMk cId="0" sldId="314"/>
-            <ac:spMk id="2" creationId="{00000000-0000-0000-0000-000000000000}"/>
-          </ac:spMkLst>
-        </pc:spChg>
-        <pc:spChg chg="mod ord">
-          <ac:chgData name="Peter Bernhardt" userId="f2333933-0b12-4d6e-972f-f87625423892" providerId="ADAL" clId="{54BAB7D7-C378-4C4A-B0F8-9DF09AB8FC9C}" dt="2026-03-18T17:33:00.254" v="530" actId="27636"/>
-          <ac:spMkLst>
-            <pc:docMk/>
-            <pc:sldMk cId="0" sldId="314"/>
-            <ac:spMk id="3" creationId="{00000000-0000-0000-0000-000000000000}"/>
-          </ac:spMkLst>
-        </pc:spChg>
-        <pc:spChg chg="add del mod">
-          <ac:chgData name="Peter Bernhardt" userId="f2333933-0b12-4d6e-972f-f87625423892" providerId="ADAL" clId="{54BAB7D7-C378-4C4A-B0F8-9DF09AB8FC9C}" dt="2026-03-18T17:30:24.431" v="508" actId="6264"/>
-          <ac:spMkLst>
-            <pc:docMk/>
-            <pc:sldMk cId="0" sldId="314"/>
-            <ac:spMk id="4" creationId="{FCB7CCD1-B197-0C19-7698-48F6F382322F}"/>
-          </ac:spMkLst>
-        </pc:spChg>
-        <pc:spChg chg="add del mod">
-          <ac:chgData name="Peter Bernhardt" userId="f2333933-0b12-4d6e-972f-f87625423892" providerId="ADAL" clId="{54BAB7D7-C378-4C4A-B0F8-9DF09AB8FC9C}" dt="2026-03-18T17:30:24.431" v="508" actId="6264"/>
-          <ac:spMkLst>
-            <pc:docMk/>
-            <pc:sldMk cId="0" sldId="314"/>
-            <ac:spMk id="5" creationId="{62280B05-2D67-6B98-9740-C43979C41D08}"/>
-          </ac:spMkLst>
-        </pc:spChg>
-      </pc:sldChg>
-      <pc:sldChg chg="modSp add del mod chgLayout">
-        <pc:chgData name="Peter Bernhardt" userId="f2333933-0b12-4d6e-972f-f87625423892" providerId="ADAL" clId="{54BAB7D7-C378-4C4A-B0F8-9DF09AB8FC9C}" dt="2026-03-18T17:34:27.896" v="546" actId="948"/>
-        <pc:sldMkLst>
-          <pc:docMk/>
-          <pc:sldMk cId="0" sldId="315"/>
-        </pc:sldMkLst>
-        <pc:spChg chg="mod ord">
-          <ac:chgData name="Peter Bernhardt" userId="f2333933-0b12-4d6e-972f-f87625423892" providerId="ADAL" clId="{54BAB7D7-C378-4C4A-B0F8-9DF09AB8FC9C}" dt="2026-03-18T17:28:28.396" v="482" actId="700"/>
-          <ac:spMkLst>
-            <pc:docMk/>
-            <pc:sldMk cId="0" sldId="315"/>
-            <ac:spMk id="2" creationId="{00000000-0000-0000-0000-000000000000}"/>
-          </ac:spMkLst>
-        </pc:spChg>
-        <pc:spChg chg="mod ord">
-          <ac:chgData name="Peter Bernhardt" userId="f2333933-0b12-4d6e-972f-f87625423892" providerId="ADAL" clId="{54BAB7D7-C378-4C4A-B0F8-9DF09AB8FC9C}" dt="2026-03-18T17:34:27.896" v="546" actId="948"/>
-          <ac:spMkLst>
-            <pc:docMk/>
-            <pc:sldMk cId="0" sldId="315"/>
-            <ac:spMk id="3" creationId="{00000000-0000-0000-0000-000000000000}"/>
-          </ac:spMkLst>
-        </pc:spChg>
-      </pc:sldChg>
-      <pc:sldChg chg="modSp add del mod">
-        <pc:chgData name="Peter Bernhardt" userId="f2333933-0b12-4d6e-972f-f87625423892" providerId="ADAL" clId="{54BAB7D7-C378-4C4A-B0F8-9DF09AB8FC9C}" dt="2026-03-18T17:36:00.691" v="561" actId="948"/>
-        <pc:sldMkLst>
-          <pc:docMk/>
-          <pc:sldMk cId="0" sldId="316"/>
-        </pc:sldMkLst>
-        <pc:spChg chg="mod">
-          <ac:chgData name="Peter Bernhardt" userId="f2333933-0b12-4d6e-972f-f87625423892" providerId="ADAL" clId="{54BAB7D7-C378-4C4A-B0F8-9DF09AB8FC9C}" dt="2026-03-18T17:36:00.691" v="561" actId="948"/>
-          <ac:spMkLst>
-            <pc:docMk/>
-            <pc:sldMk cId="0" sldId="316"/>
-            <ac:spMk id="3" creationId="{00000000-0000-0000-0000-000000000000}"/>
-          </ac:spMkLst>
-        </pc:spChg>
-        <pc:spChg chg="mod">
-          <ac:chgData name="Peter Bernhardt" userId="f2333933-0b12-4d6e-972f-f87625423892" providerId="ADAL" clId="{54BAB7D7-C378-4C4A-B0F8-9DF09AB8FC9C}" dt="2026-03-18T16:39:28.101" v="79" actId="790"/>
-          <ac:spMkLst>
-            <pc:docMk/>
-            <pc:sldMk cId="0" sldId="316"/>
-            <ac:spMk id="4" creationId="{00000000-0000-0000-0000-000000000000}"/>
-          </ac:spMkLst>
-        </pc:spChg>
-        <pc:graphicFrameChg chg="mod modGraphic">
-          <ac:chgData name="Peter Bernhardt" userId="f2333933-0b12-4d6e-972f-f87625423892" providerId="ADAL" clId="{54BAB7D7-C378-4C4A-B0F8-9DF09AB8FC9C}" dt="2026-03-18T16:39:28.101" v="79" actId="790"/>
-          <ac:graphicFrameMkLst>
-            <pc:docMk/>
-            <pc:sldMk cId="0" sldId="316"/>
-            <ac:graphicFrameMk id="6" creationId="{00000000-0000-0000-0000-000000000000}"/>
-          </ac:graphicFrameMkLst>
-        </pc:graphicFrameChg>
-      </pc:sldChg>
-      <pc:sldChg chg="addSp modSp add del mod chgLayout">
-        <pc:chgData name="Peter Bernhardt" userId="f2333933-0b12-4d6e-972f-f87625423892" providerId="ADAL" clId="{54BAB7D7-C378-4C4A-B0F8-9DF09AB8FC9C}" dt="2026-03-18T17:28:20.768" v="480" actId="700"/>
-        <pc:sldMkLst>
-          <pc:docMk/>
-          <pc:sldMk cId="0" sldId="317"/>
-        </pc:sldMkLst>
-        <pc:spChg chg="mod ord">
-          <ac:chgData name="Peter Bernhardt" userId="f2333933-0b12-4d6e-972f-f87625423892" providerId="ADAL" clId="{54BAB7D7-C378-4C4A-B0F8-9DF09AB8FC9C}" dt="2026-03-18T17:28:20.768" v="480" actId="700"/>
-          <ac:spMkLst>
-            <pc:docMk/>
-            <pc:sldMk cId="0" sldId="317"/>
-            <ac:spMk id="2" creationId="{00000000-0000-0000-0000-000000000000}"/>
-          </ac:spMkLst>
-        </pc:spChg>
-        <pc:spChg chg="mod">
-          <ac:chgData name="Peter Bernhardt" userId="f2333933-0b12-4d6e-972f-f87625423892" providerId="ADAL" clId="{54BAB7D7-C378-4C4A-B0F8-9DF09AB8FC9C}" dt="2026-03-18T16:39:29.282" v="157" actId="27636"/>
-          <ac:spMkLst>
-            <pc:docMk/>
-            <pc:sldMk cId="0" sldId="317"/>
-            <ac:spMk id="3" creationId="{00000000-0000-0000-0000-000000000000}"/>
-          </ac:spMkLst>
-        </pc:spChg>
-        <pc:spChg chg="add mod ord">
-          <ac:chgData name="Peter Bernhardt" userId="f2333933-0b12-4d6e-972f-f87625423892" providerId="ADAL" clId="{54BAB7D7-C378-4C4A-B0F8-9DF09AB8FC9C}" dt="2026-03-18T17:28:20.768" v="480" actId="700"/>
-          <ac:spMkLst>
-            <pc:docMk/>
-            <pc:sldMk cId="0" sldId="317"/>
-            <ac:spMk id="3" creationId="{95C0326A-A5D8-0BA5-24D2-B7E30EF624F3}"/>
-          </ac:spMkLst>
-        </pc:spChg>
-      </pc:sldChg>
-      <pc:sldChg chg="modSp add del mod">
-        <pc:chgData name="Peter Bernhardt" userId="f2333933-0b12-4d6e-972f-f87625423892" providerId="ADAL" clId="{54BAB7D7-C378-4C4A-B0F8-9DF09AB8FC9C}" dt="2026-03-18T17:52:00.811" v="796" actId="14100"/>
-        <pc:sldMkLst>
-          <pc:docMk/>
-          <pc:sldMk cId="0" sldId="318"/>
-        </pc:sldMkLst>
-        <pc:spChg chg="mod">
-          <ac:chgData name="Peter Bernhardt" userId="f2333933-0b12-4d6e-972f-f87625423892" providerId="ADAL" clId="{54BAB7D7-C378-4C4A-B0F8-9DF09AB8FC9C}" dt="2026-03-18T17:52:00.811" v="796" actId="14100"/>
-          <ac:spMkLst>
-            <pc:docMk/>
-            <pc:sldMk cId="0" sldId="318"/>
-            <ac:spMk id="3" creationId="{00000000-0000-0000-0000-000000000000}"/>
-          </ac:spMkLst>
-        </pc:spChg>
-      </pc:sldChg>
-      <pc:sldChg chg="modSp add del mod">
-        <pc:chgData name="Peter Bernhardt" userId="f2333933-0b12-4d6e-972f-f87625423892" providerId="ADAL" clId="{54BAB7D7-C378-4C4A-B0F8-9DF09AB8FC9C}" dt="2026-03-18T17:40:02.293" v="722" actId="948"/>
-        <pc:sldMkLst>
-          <pc:docMk/>
-          <pc:sldMk cId="0" sldId="319"/>
-        </pc:sldMkLst>
-        <pc:spChg chg="mod">
-          <ac:chgData name="Peter Bernhardt" userId="f2333933-0b12-4d6e-972f-f87625423892" providerId="ADAL" clId="{54BAB7D7-C378-4C4A-B0F8-9DF09AB8FC9C}" dt="2026-03-18T17:40:02.293" v="722" actId="948"/>
-          <ac:spMkLst>
-            <pc:docMk/>
-            <pc:sldMk cId="0" sldId="319"/>
-            <ac:spMk id="3" creationId="{00000000-0000-0000-0000-000000000000}"/>
-          </ac:spMkLst>
-        </pc:spChg>
-      </pc:sldChg>
-      <pc:sldChg chg="modSp add del mod">
-        <pc:chgData name="Peter Bernhardt" userId="f2333933-0b12-4d6e-972f-f87625423892" providerId="ADAL" clId="{54BAB7D7-C378-4C4A-B0F8-9DF09AB8FC9C}" dt="2026-03-18T17:39:40.803" v="721" actId="6549"/>
-        <pc:sldMkLst>
-          <pc:docMk/>
-          <pc:sldMk cId="0" sldId="320"/>
-        </pc:sldMkLst>
-        <pc:spChg chg="mod">
-          <ac:chgData name="Peter Bernhardt" userId="f2333933-0b12-4d6e-972f-f87625423892" providerId="ADAL" clId="{54BAB7D7-C378-4C4A-B0F8-9DF09AB8FC9C}" dt="2026-03-18T17:39:40.803" v="721" actId="6549"/>
-          <ac:spMkLst>
-            <pc:docMk/>
-            <pc:sldMk cId="0" sldId="320"/>
-            <ac:spMk id="3" creationId="{00000000-0000-0000-0000-000000000000}"/>
-          </ac:spMkLst>
-        </pc:spChg>
-      </pc:sldChg>
-      <pc:sldChg chg="addSp modSp add del mod chgLayout">
-        <pc:chgData name="Peter Bernhardt" userId="f2333933-0b12-4d6e-972f-f87625423892" providerId="ADAL" clId="{54BAB7D7-C378-4C4A-B0F8-9DF09AB8FC9C}" dt="2026-03-18T17:28:33.009" v="483" actId="700"/>
-        <pc:sldMkLst>
-          <pc:docMk/>
-          <pc:sldMk cId="0" sldId="321"/>
-        </pc:sldMkLst>
-        <pc:spChg chg="mod ord">
-          <ac:chgData name="Peter Bernhardt" userId="f2333933-0b12-4d6e-972f-f87625423892" providerId="ADAL" clId="{54BAB7D7-C378-4C4A-B0F8-9DF09AB8FC9C}" dt="2026-03-18T17:28:33.009" v="483" actId="700"/>
-          <ac:spMkLst>
-            <pc:docMk/>
-            <pc:sldMk cId="0" sldId="321"/>
-            <ac:spMk id="2" creationId="{00000000-0000-0000-0000-000000000000}"/>
-          </ac:spMkLst>
-        </pc:spChg>
-        <pc:spChg chg="add mod ord">
-          <ac:chgData name="Peter Bernhardt" userId="f2333933-0b12-4d6e-972f-f87625423892" providerId="ADAL" clId="{54BAB7D7-C378-4C4A-B0F8-9DF09AB8FC9C}" dt="2026-03-18T17:28:33.009" v="483" actId="700"/>
-          <ac:spMkLst>
-            <pc:docMk/>
-            <pc:sldMk cId="0" sldId="321"/>
-            <ac:spMk id="3" creationId="{7CE2FEFE-C30A-8772-F382-C1DD0DC3135B}"/>
-          </ac:spMkLst>
-        </pc:spChg>
-      </pc:sldChg>
-      <pc:sldChg chg="modSp add del mod">
-        <pc:chgData name="Peter Bernhardt" userId="f2333933-0b12-4d6e-972f-f87625423892" providerId="ADAL" clId="{54BAB7D7-C378-4C4A-B0F8-9DF09AB8FC9C}" dt="2026-03-18T17:38:40.665" v="708" actId="20577"/>
-        <pc:sldMkLst>
-          <pc:docMk/>
-          <pc:sldMk cId="0" sldId="322"/>
-        </pc:sldMkLst>
-        <pc:spChg chg="mod">
-          <ac:chgData name="Peter Bernhardt" userId="f2333933-0b12-4d6e-972f-f87625423892" providerId="ADAL" clId="{54BAB7D7-C378-4C4A-B0F8-9DF09AB8FC9C}" dt="2026-03-18T17:38:40.665" v="708" actId="20577"/>
-          <ac:spMkLst>
-            <pc:docMk/>
-            <pc:sldMk cId="0" sldId="322"/>
-            <ac:spMk id="3" creationId="{00000000-0000-0000-0000-000000000000}"/>
-          </ac:spMkLst>
-        </pc:spChg>
-      </pc:sldChg>
-      <pc:sldChg chg="add del">
-        <pc:chgData name="Peter Bernhardt" userId="f2333933-0b12-4d6e-972f-f87625423892" providerId="ADAL" clId="{54BAB7D7-C378-4C4A-B0F8-9DF09AB8FC9C}" dt="2026-03-18T17:27:52.949" v="472"/>
-        <pc:sldMkLst>
-          <pc:docMk/>
-          <pc:sldMk cId="0" sldId="323"/>
-        </pc:sldMkLst>
-      </pc:sldChg>
-      <pc:sldChg chg="modSp add del mod">
-        <pc:chgData name="Peter Bernhardt" userId="f2333933-0b12-4d6e-972f-f87625423892" providerId="ADAL" clId="{54BAB7D7-C378-4C4A-B0F8-9DF09AB8FC9C}" dt="2026-03-18T17:28:08.746" v="478" actId="27636"/>
-        <pc:sldMkLst>
-          <pc:docMk/>
-          <pc:sldMk cId="0" sldId="324"/>
-        </pc:sldMkLst>
-        <pc:spChg chg="mod">
-          <ac:chgData name="Peter Bernhardt" userId="f2333933-0b12-4d6e-972f-f87625423892" providerId="ADAL" clId="{54BAB7D7-C378-4C4A-B0F8-9DF09AB8FC9C}" dt="2026-03-18T17:28:08.746" v="478" actId="27636"/>
-          <ac:spMkLst>
-            <pc:docMk/>
-            <pc:sldMk cId="0" sldId="324"/>
-            <ac:spMk id="3" creationId="{00000000-0000-0000-0000-000000000000}"/>
-          </ac:spMkLst>
-        </pc:spChg>
-      </pc:sldChg>
-      <pc:sldChg chg="addSp modSp add del mod chgLayout">
-        <pc:chgData name="Peter Bernhardt" userId="f2333933-0b12-4d6e-972f-f87625423892" providerId="ADAL" clId="{54BAB7D7-C378-4C4A-B0F8-9DF09AB8FC9C}" dt="2026-03-18T17:28:36.650" v="484" actId="700"/>
-        <pc:sldMkLst>
-          <pc:docMk/>
-          <pc:sldMk cId="0" sldId="325"/>
-        </pc:sldMkLst>
-        <pc:spChg chg="mod ord">
-          <ac:chgData name="Peter Bernhardt" userId="f2333933-0b12-4d6e-972f-f87625423892" providerId="ADAL" clId="{54BAB7D7-C378-4C4A-B0F8-9DF09AB8FC9C}" dt="2026-03-18T17:28:36.650" v="484" actId="700"/>
-          <ac:spMkLst>
-            <pc:docMk/>
-            <pc:sldMk cId="0" sldId="325"/>
-            <ac:spMk id="2" creationId="{00000000-0000-0000-0000-000000000000}"/>
-          </ac:spMkLst>
-        </pc:spChg>
-        <pc:spChg chg="add mod ord">
-          <ac:chgData name="Peter Bernhardt" userId="f2333933-0b12-4d6e-972f-f87625423892" providerId="ADAL" clId="{54BAB7D7-C378-4C4A-B0F8-9DF09AB8FC9C}" dt="2026-03-18T17:28:36.650" v="484" actId="700"/>
-          <ac:spMkLst>
-            <pc:docMk/>
-            <pc:sldMk cId="0" sldId="325"/>
-            <ac:spMk id="3" creationId="{26733553-45E4-B6ED-4538-A37C8B7ED3A5}"/>
-          </ac:spMkLst>
-        </pc:spChg>
-      </pc:sldChg>
-      <pc:sldChg chg="add del">
-        <pc:chgData name="Peter Bernhardt" userId="f2333933-0b12-4d6e-972f-f87625423892" providerId="ADAL" clId="{54BAB7D7-C378-4C4A-B0F8-9DF09AB8FC9C}" dt="2026-03-18T17:27:52.949" v="472"/>
-        <pc:sldMkLst>
-          <pc:docMk/>
-          <pc:sldMk cId="0" sldId="326"/>
-        </pc:sldMkLst>
-      </pc:sldChg>
-      <pc:sldChg chg="add del">
-        <pc:chgData name="Peter Bernhardt" userId="f2333933-0b12-4d6e-972f-f87625423892" providerId="ADAL" clId="{54BAB7D7-C378-4C4A-B0F8-9DF09AB8FC9C}" dt="2026-03-18T17:27:52.949" v="472"/>
-        <pc:sldMkLst>
-          <pc:docMk/>
-          <pc:sldMk cId="0" sldId="327"/>
-        </pc:sldMkLst>
-      </pc:sldChg>
-      <pc:sldChg chg="add del">
-        <pc:chgData name="Peter Bernhardt" userId="f2333933-0b12-4d6e-972f-f87625423892" providerId="ADAL" clId="{54BAB7D7-C378-4C4A-B0F8-9DF09AB8FC9C}" dt="2026-03-18T17:27:52.949" v="472"/>
-        <pc:sldMkLst>
-          <pc:docMk/>
-          <pc:sldMk cId="0" sldId="328"/>
-        </pc:sldMkLst>
-      </pc:sldChg>
-      <pc:sldChg chg="addSp modSp add del mod chgLayout">
-        <pc:chgData name="Peter Bernhardt" userId="f2333933-0b12-4d6e-972f-f87625423892" providerId="ADAL" clId="{54BAB7D7-C378-4C4A-B0F8-9DF09AB8FC9C}" dt="2026-03-18T17:28:42.087" v="485" actId="700"/>
-        <pc:sldMkLst>
-          <pc:docMk/>
-          <pc:sldMk cId="0" sldId="329"/>
-        </pc:sldMkLst>
-        <pc:spChg chg="mod ord">
-          <ac:chgData name="Peter Bernhardt" userId="f2333933-0b12-4d6e-972f-f87625423892" providerId="ADAL" clId="{54BAB7D7-C378-4C4A-B0F8-9DF09AB8FC9C}" dt="2026-03-18T17:28:42.087" v="485" actId="700"/>
-          <ac:spMkLst>
-            <pc:docMk/>
-            <pc:sldMk cId="0" sldId="329"/>
-            <ac:spMk id="2" creationId="{00000000-0000-0000-0000-000000000000}"/>
-          </ac:spMkLst>
-        </pc:spChg>
-        <pc:spChg chg="add mod ord">
-          <ac:chgData name="Peter Bernhardt" userId="f2333933-0b12-4d6e-972f-f87625423892" providerId="ADAL" clId="{54BAB7D7-C378-4C4A-B0F8-9DF09AB8FC9C}" dt="2026-03-18T17:28:42.087" v="485" actId="700"/>
-          <ac:spMkLst>
-            <pc:docMk/>
-            <pc:sldMk cId="0" sldId="329"/>
-            <ac:spMk id="3" creationId="{5A2A242D-3F5A-09AB-7CD8-B16625515ECD}"/>
-          </ac:spMkLst>
-        </pc:spChg>
-      </pc:sldChg>
-      <pc:sldChg chg="add del">
-        <pc:chgData name="Peter Bernhardt" userId="f2333933-0b12-4d6e-972f-f87625423892" providerId="ADAL" clId="{54BAB7D7-C378-4C4A-B0F8-9DF09AB8FC9C}" dt="2026-03-18T17:27:52.949" v="472"/>
-        <pc:sldMkLst>
-          <pc:docMk/>
-          <pc:sldMk cId="0" sldId="330"/>
-        </pc:sldMkLst>
-      </pc:sldChg>
-      <pc:sldChg chg="modSp add del mod">
-        <pc:chgData name="Peter Bernhardt" userId="f2333933-0b12-4d6e-972f-f87625423892" providerId="ADAL" clId="{54BAB7D7-C378-4C4A-B0F8-9DF09AB8FC9C}" dt="2026-03-18T17:42:29.334" v="743" actId="5793"/>
-        <pc:sldMkLst>
-          <pc:docMk/>
-          <pc:sldMk cId="0" sldId="331"/>
-        </pc:sldMkLst>
-        <pc:spChg chg="mod">
-          <ac:chgData name="Peter Bernhardt" userId="f2333933-0b12-4d6e-972f-f87625423892" providerId="ADAL" clId="{54BAB7D7-C378-4C4A-B0F8-9DF09AB8FC9C}" dt="2026-03-18T17:42:29.334" v="743" actId="5793"/>
-          <ac:spMkLst>
-            <pc:docMk/>
-            <pc:sldMk cId="0" sldId="331"/>
-            <ac:spMk id="3" creationId="{00000000-0000-0000-0000-000000000000}"/>
-          </ac:spMkLst>
-        </pc:spChg>
-      </pc:sldChg>
-      <pc:sldChg chg="add del">
-        <pc:chgData name="Peter Bernhardt" userId="f2333933-0b12-4d6e-972f-f87625423892" providerId="ADAL" clId="{54BAB7D7-C378-4C4A-B0F8-9DF09AB8FC9C}" dt="2026-03-18T17:27:52.949" v="472"/>
-        <pc:sldMkLst>
-          <pc:docMk/>
-          <pc:sldMk cId="0" sldId="332"/>
-        </pc:sldMkLst>
-      </pc:sldChg>
-      <pc:sldChg chg="add del">
-        <pc:chgData name="Peter Bernhardt" userId="f2333933-0b12-4d6e-972f-f87625423892" providerId="ADAL" clId="{54BAB7D7-C378-4C4A-B0F8-9DF09AB8FC9C}" dt="2026-03-18T17:27:52.949" v="472"/>
-        <pc:sldMkLst>
-          <pc:docMk/>
-          <pc:sldMk cId="0" sldId="333"/>
-        </pc:sldMkLst>
-      </pc:sldChg>
-      <pc:sldChg chg="addSp modSp add del mod chgLayout">
-        <pc:chgData name="Peter Bernhardt" userId="f2333933-0b12-4d6e-972f-f87625423892" providerId="ADAL" clId="{54BAB7D7-C378-4C4A-B0F8-9DF09AB8FC9C}" dt="2026-03-18T17:28:45.212" v="486" actId="700"/>
-        <pc:sldMkLst>
-          <pc:docMk/>
-          <pc:sldMk cId="0" sldId="334"/>
-        </pc:sldMkLst>
-        <pc:spChg chg="mod ord">
-          <ac:chgData name="Peter Bernhardt" userId="f2333933-0b12-4d6e-972f-f87625423892" providerId="ADAL" clId="{54BAB7D7-C378-4C4A-B0F8-9DF09AB8FC9C}" dt="2026-03-18T17:28:45.212" v="486" actId="700"/>
-          <ac:spMkLst>
-            <pc:docMk/>
-            <pc:sldMk cId="0" sldId="334"/>
-            <ac:spMk id="2" creationId="{00000000-0000-0000-0000-000000000000}"/>
-          </ac:spMkLst>
-        </pc:spChg>
-        <pc:spChg chg="add mod ord">
-          <ac:chgData name="Peter Bernhardt" userId="f2333933-0b12-4d6e-972f-f87625423892" providerId="ADAL" clId="{54BAB7D7-C378-4C4A-B0F8-9DF09AB8FC9C}" dt="2026-03-18T17:28:45.212" v="486" actId="700"/>
-          <ac:spMkLst>
-            <pc:docMk/>
-            <pc:sldMk cId="0" sldId="334"/>
-            <ac:spMk id="3" creationId="{977E0251-921D-F4CF-B049-C68110E185C4}"/>
-          </ac:spMkLst>
-        </pc:spChg>
-      </pc:sldChg>
-      <pc:sldChg chg="add del">
-        <pc:chgData name="Peter Bernhardt" userId="f2333933-0b12-4d6e-972f-f87625423892" providerId="ADAL" clId="{54BAB7D7-C378-4C4A-B0F8-9DF09AB8FC9C}" dt="2026-03-18T17:27:52.949" v="472"/>
-        <pc:sldMkLst>
-          <pc:docMk/>
-          <pc:sldMk cId="0" sldId="335"/>
-        </pc:sldMkLst>
-      </pc:sldChg>
-      <pc:sldChg chg="add del">
-        <pc:chgData name="Peter Bernhardt" userId="f2333933-0b12-4d6e-972f-f87625423892" providerId="ADAL" clId="{54BAB7D7-C378-4C4A-B0F8-9DF09AB8FC9C}" dt="2026-03-18T17:27:52.949" v="472"/>
-        <pc:sldMkLst>
-          <pc:docMk/>
-          <pc:sldMk cId="0" sldId="336"/>
-        </pc:sldMkLst>
-      </pc:sldChg>
-      <pc:sldChg chg="add del">
-        <pc:chgData name="Peter Bernhardt" userId="f2333933-0b12-4d6e-972f-f87625423892" providerId="ADAL" clId="{54BAB7D7-C378-4C4A-B0F8-9DF09AB8FC9C}" dt="2026-03-18T17:27:52.949" v="472"/>
-        <pc:sldMkLst>
-          <pc:docMk/>
-          <pc:sldMk cId="0" sldId="337"/>
-        </pc:sldMkLst>
-      </pc:sldChg>
-      <pc:sldChg chg="addSp modSp add del mod chgLayout">
-        <pc:chgData name="Peter Bernhardt" userId="f2333933-0b12-4d6e-972f-f87625423892" providerId="ADAL" clId="{54BAB7D7-C378-4C4A-B0F8-9DF09AB8FC9C}" dt="2026-03-18T17:28:48.429" v="487" actId="700"/>
-        <pc:sldMkLst>
-          <pc:docMk/>
-          <pc:sldMk cId="0" sldId="338"/>
-        </pc:sldMkLst>
-        <pc:spChg chg="mod ord">
-          <ac:chgData name="Peter Bernhardt" userId="f2333933-0b12-4d6e-972f-f87625423892" providerId="ADAL" clId="{54BAB7D7-C378-4C4A-B0F8-9DF09AB8FC9C}" dt="2026-03-18T17:28:48.429" v="487" actId="700"/>
-          <ac:spMkLst>
-            <pc:docMk/>
-            <pc:sldMk cId="0" sldId="338"/>
-            <ac:spMk id="2" creationId="{00000000-0000-0000-0000-000000000000}"/>
-          </ac:spMkLst>
-        </pc:spChg>
-        <pc:spChg chg="add mod ord">
-          <ac:chgData name="Peter Bernhardt" userId="f2333933-0b12-4d6e-972f-f87625423892" providerId="ADAL" clId="{54BAB7D7-C378-4C4A-B0F8-9DF09AB8FC9C}" dt="2026-03-18T17:28:48.429" v="487" actId="700"/>
-          <ac:spMkLst>
-            <pc:docMk/>
-            <pc:sldMk cId="0" sldId="338"/>
-            <ac:spMk id="3" creationId="{45C3889D-2894-4931-2791-8ED485936793}"/>
-          </ac:spMkLst>
-        </pc:spChg>
-      </pc:sldChg>
-      <pc:sldChg chg="add del">
-        <pc:chgData name="Peter Bernhardt" userId="f2333933-0b12-4d6e-972f-f87625423892" providerId="ADAL" clId="{54BAB7D7-C378-4C4A-B0F8-9DF09AB8FC9C}" dt="2026-03-18T17:27:52.949" v="472"/>
-        <pc:sldMkLst>
-          <pc:docMk/>
-          <pc:sldMk cId="0" sldId="339"/>
-        </pc:sldMkLst>
-      </pc:sldChg>
-      <pc:sldChg chg="modSp add del mod">
-        <pc:chgData name="Peter Bernhardt" userId="f2333933-0b12-4d6e-972f-f87625423892" providerId="ADAL" clId="{54BAB7D7-C378-4C4A-B0F8-9DF09AB8FC9C}" dt="2026-03-18T17:43:16.789" v="762" actId="20577"/>
-        <pc:sldMkLst>
-          <pc:docMk/>
-          <pc:sldMk cId="0" sldId="340"/>
-        </pc:sldMkLst>
-        <pc:spChg chg="mod">
-          <ac:chgData name="Peter Bernhardt" userId="f2333933-0b12-4d6e-972f-f87625423892" providerId="ADAL" clId="{54BAB7D7-C378-4C4A-B0F8-9DF09AB8FC9C}" dt="2026-03-18T17:43:16.789" v="762" actId="20577"/>
-          <ac:spMkLst>
-            <pc:docMk/>
-            <pc:sldMk cId="0" sldId="340"/>
-            <ac:spMk id="3" creationId="{00000000-0000-0000-0000-000000000000}"/>
-          </ac:spMkLst>
-        </pc:spChg>
-      </pc:sldChg>
-      <pc:sldChg chg="addSp modSp add del mod chgLayout">
-        <pc:chgData name="Peter Bernhardt" userId="f2333933-0b12-4d6e-972f-f87625423892" providerId="ADAL" clId="{54BAB7D7-C378-4C4A-B0F8-9DF09AB8FC9C}" dt="2026-03-18T17:28:51.756" v="488" actId="700"/>
-        <pc:sldMkLst>
-          <pc:docMk/>
-          <pc:sldMk cId="0" sldId="341"/>
-        </pc:sldMkLst>
-        <pc:spChg chg="mod ord">
-          <ac:chgData name="Peter Bernhardt" userId="f2333933-0b12-4d6e-972f-f87625423892" providerId="ADAL" clId="{54BAB7D7-C378-4C4A-B0F8-9DF09AB8FC9C}" dt="2026-03-18T17:28:51.756" v="488" actId="700"/>
-          <ac:spMkLst>
-            <pc:docMk/>
-            <pc:sldMk cId="0" sldId="341"/>
-            <ac:spMk id="2" creationId="{00000000-0000-0000-0000-000000000000}"/>
-          </ac:spMkLst>
-        </pc:spChg>
-        <pc:spChg chg="add mod ord">
-          <ac:chgData name="Peter Bernhardt" userId="f2333933-0b12-4d6e-972f-f87625423892" providerId="ADAL" clId="{54BAB7D7-C378-4C4A-B0F8-9DF09AB8FC9C}" dt="2026-03-18T17:28:51.756" v="488" actId="700"/>
-          <ac:spMkLst>
-            <pc:docMk/>
-            <pc:sldMk cId="0" sldId="341"/>
-            <ac:spMk id="3" creationId="{D20D7610-F3BE-1E9A-1BE8-3B0E9E82CB3E}"/>
-          </ac:spMkLst>
-        </pc:spChg>
-      </pc:sldChg>
-      <pc:sldChg chg="add del">
-        <pc:chgData name="Peter Bernhardt" userId="f2333933-0b12-4d6e-972f-f87625423892" providerId="ADAL" clId="{54BAB7D7-C378-4C4A-B0F8-9DF09AB8FC9C}" dt="2026-03-18T17:27:52.949" v="472"/>
-        <pc:sldMkLst>
-          <pc:docMk/>
-          <pc:sldMk cId="0" sldId="342"/>
-        </pc:sldMkLst>
-      </pc:sldChg>
-      <pc:sldChg chg="add del">
-        <pc:chgData name="Peter Bernhardt" userId="f2333933-0b12-4d6e-972f-f87625423892" providerId="ADAL" clId="{54BAB7D7-C378-4C4A-B0F8-9DF09AB8FC9C}" dt="2026-03-18T17:27:52.949" v="472"/>
-        <pc:sldMkLst>
-          <pc:docMk/>
-          <pc:sldMk cId="0" sldId="343"/>
-        </pc:sldMkLst>
-      </pc:sldChg>
-      <pc:sldChg chg="addSp delSp modSp add del mod chgLayout">
-        <pc:chgData name="Peter Bernhardt" userId="f2333933-0b12-4d6e-972f-f87625423892" providerId="ADAL" clId="{54BAB7D7-C378-4C4A-B0F8-9DF09AB8FC9C}" dt="2026-03-18T17:43:47.150" v="772" actId="20577"/>
-        <pc:sldMkLst>
-          <pc:docMk/>
-          <pc:sldMk cId="0" sldId="344"/>
-        </pc:sldMkLst>
-        <pc:spChg chg="mod ord">
-          <ac:chgData name="Peter Bernhardt" userId="f2333933-0b12-4d6e-972f-f87625423892" providerId="ADAL" clId="{54BAB7D7-C378-4C4A-B0F8-9DF09AB8FC9C}" dt="2026-03-18T17:43:47.150" v="772" actId="20577"/>
-          <ac:spMkLst>
-            <pc:docMk/>
-            <pc:sldMk cId="0" sldId="344"/>
-            <ac:spMk id="2" creationId="{00000000-0000-0000-0000-000000000000}"/>
-          </ac:spMkLst>
-        </pc:spChg>
-        <pc:spChg chg="add mod ord">
-          <ac:chgData name="Peter Bernhardt" userId="f2333933-0b12-4d6e-972f-f87625423892" providerId="ADAL" clId="{54BAB7D7-C378-4C4A-B0F8-9DF09AB8FC9C}" dt="2026-03-18T17:28:55.429" v="489" actId="700"/>
-          <ac:spMkLst>
-            <pc:docMk/>
-            <pc:sldMk cId="0" sldId="344"/>
-            <ac:spMk id="3" creationId="{0D089290-0A3B-CCF9-E37A-56528B78804E}"/>
-          </ac:spMkLst>
-        </pc:spChg>
-        <pc:spChg chg="add del mod ord">
-          <ac:chgData name="Peter Bernhardt" userId="f2333933-0b12-4d6e-972f-f87625423892" providerId="ADAL" clId="{54BAB7D7-C378-4C4A-B0F8-9DF09AB8FC9C}" dt="2026-03-18T17:27:24.435" v="470" actId="700"/>
-          <ac:spMkLst>
-            <pc:docMk/>
-            <pc:sldMk cId="0" sldId="344"/>
-            <ac:spMk id="3" creationId="{C252AFA0-72CD-335E-13B4-7BECFFC61670}"/>
-          </ac:spMkLst>
-        </pc:spChg>
-      </pc:sldChg>
-      <pc:sldChg chg="modSp add del mod chgLayout">
-        <pc:chgData name="Peter Bernhardt" userId="f2333933-0b12-4d6e-972f-f87625423892" providerId="ADAL" clId="{54BAB7D7-C378-4C4A-B0F8-9DF09AB8FC9C}" dt="2026-03-18T17:29:15.071" v="492" actId="700"/>
-        <pc:sldMkLst>
-          <pc:docMk/>
-          <pc:sldMk cId="0" sldId="345"/>
-        </pc:sldMkLst>
-        <pc:spChg chg="mod ord">
-          <ac:chgData name="Peter Bernhardt" userId="f2333933-0b12-4d6e-972f-f87625423892" providerId="ADAL" clId="{54BAB7D7-C378-4C4A-B0F8-9DF09AB8FC9C}" dt="2026-03-18T17:29:15.071" v="492" actId="700"/>
-          <ac:spMkLst>
-            <pc:docMk/>
-            <pc:sldMk cId="0" sldId="345"/>
-            <ac:spMk id="2" creationId="{00000000-0000-0000-0000-000000000000}"/>
-          </ac:spMkLst>
-        </pc:spChg>
-        <pc:spChg chg="mod ord">
-          <ac:chgData name="Peter Bernhardt" userId="f2333933-0b12-4d6e-972f-f87625423892" providerId="ADAL" clId="{54BAB7D7-C378-4C4A-B0F8-9DF09AB8FC9C}" dt="2026-03-18T17:29:15.071" v="492" actId="700"/>
-          <ac:spMkLst>
-            <pc:docMk/>
-            <pc:sldMk cId="0" sldId="345"/>
-            <ac:spMk id="3" creationId="{00000000-0000-0000-0000-000000000000}"/>
-          </ac:spMkLst>
-        </pc:spChg>
-      </pc:sldChg>
-      <pc:sldChg chg="add del">
-        <pc:chgData name="Peter Bernhardt" userId="f2333933-0b12-4d6e-972f-f87625423892" providerId="ADAL" clId="{54BAB7D7-C378-4C4A-B0F8-9DF09AB8FC9C}" dt="2026-03-18T17:29:10.056" v="491" actId="47"/>
-        <pc:sldMkLst>
-          <pc:docMk/>
-          <pc:sldMk cId="0" sldId="346"/>
-        </pc:sldMkLst>
-      </pc:sldChg>
-      <pc:sldChg chg="add del">
-        <pc:chgData name="Peter Bernhardt" userId="f2333933-0b12-4d6e-972f-f87625423892" providerId="ADAL" clId="{54BAB7D7-C378-4C4A-B0F8-9DF09AB8FC9C}" dt="2026-03-18T17:29:00.195" v="490" actId="47"/>
-        <pc:sldMkLst>
-          <pc:docMk/>
-          <pc:sldMk cId="0" sldId="347"/>
-        </pc:sldMkLst>
-      </pc:sldChg>
-      <pc:sldMasterChg chg="modSp modSldLayout">
-        <pc:chgData name="Peter Bernhardt" userId="f2333933-0b12-4d6e-972f-f87625423892" providerId="ADAL" clId="{54BAB7D7-C378-4C4A-B0F8-9DF09AB8FC9C}" dt="2026-03-18T16:35:30.591" v="0"/>
-        <pc:sldMasterMkLst>
-          <pc:docMk/>
-          <pc:sldMasterMk cId="3676200875" sldId="2147483648"/>
-        </pc:sldMasterMkLst>
-        <pc:spChg chg="mod">
-          <ac:chgData name="Peter Bernhardt" userId="f2333933-0b12-4d6e-972f-f87625423892" providerId="ADAL" clId="{54BAB7D7-C378-4C4A-B0F8-9DF09AB8FC9C}" dt="2026-03-18T16:35:30.591" v="0"/>
-          <ac:spMkLst>
-            <pc:docMk/>
-            <pc:sldMasterMk cId="3676200875" sldId="2147483648"/>
-            <ac:spMk id="2" creationId="{00000000-0000-0000-0000-000000000000}"/>
-          </ac:spMkLst>
-        </pc:spChg>
-        <pc:spChg chg="mod">
-          <ac:chgData name="Peter Bernhardt" userId="f2333933-0b12-4d6e-972f-f87625423892" providerId="ADAL" clId="{54BAB7D7-C378-4C4A-B0F8-9DF09AB8FC9C}" dt="2026-03-18T16:35:30.591" v="0"/>
-          <ac:spMkLst>
-            <pc:docMk/>
-            <pc:sldMasterMk cId="3676200875" sldId="2147483648"/>
-            <ac:spMk id="3" creationId="{00000000-0000-0000-0000-000000000000}"/>
-          </ac:spMkLst>
-        </pc:spChg>
-        <pc:spChg chg="mod">
-          <ac:chgData name="Peter Bernhardt" userId="f2333933-0b12-4d6e-972f-f87625423892" providerId="ADAL" clId="{54BAB7D7-C378-4C4A-B0F8-9DF09AB8FC9C}" dt="2026-03-18T16:35:30.591" v="0"/>
-          <ac:spMkLst>
-            <pc:docMk/>
-            <pc:sldMasterMk cId="3676200875" sldId="2147483648"/>
-            <ac:spMk id="4" creationId="{00000000-0000-0000-0000-000000000000}"/>
-          </ac:spMkLst>
-        </pc:spChg>
-        <pc:spChg chg="mod">
-          <ac:chgData name="Peter Bernhardt" userId="f2333933-0b12-4d6e-972f-f87625423892" providerId="ADAL" clId="{54BAB7D7-C378-4C4A-B0F8-9DF09AB8FC9C}" dt="2026-03-18T16:35:30.591" v="0"/>
-          <ac:spMkLst>
-            <pc:docMk/>
-            <pc:sldMasterMk cId="3676200875" sldId="2147483648"/>
-            <ac:spMk id="5" creationId="{00000000-0000-0000-0000-000000000000}"/>
-          </ac:spMkLst>
-        </pc:spChg>
-        <pc:spChg chg="mod">
-          <ac:chgData name="Peter Bernhardt" userId="f2333933-0b12-4d6e-972f-f87625423892" providerId="ADAL" clId="{54BAB7D7-C378-4C4A-B0F8-9DF09AB8FC9C}" dt="2026-03-18T16:35:30.591" v="0"/>
-          <ac:spMkLst>
-            <pc:docMk/>
-            <pc:sldMasterMk cId="3676200875" sldId="2147483648"/>
-            <ac:spMk id="6" creationId="{00000000-0000-0000-0000-000000000000}"/>
-          </ac:spMkLst>
-        </pc:spChg>
-        <pc:sldLayoutChg chg="modSp">
-          <pc:chgData name="Peter Bernhardt" userId="f2333933-0b12-4d6e-972f-f87625423892" providerId="ADAL" clId="{54BAB7D7-C378-4C4A-B0F8-9DF09AB8FC9C}" dt="2026-03-18T16:35:30.591" v="0"/>
-          <pc:sldLayoutMkLst>
-            <pc:docMk/>
-            <pc:sldMasterMk cId="3676200875" sldId="2147483648"/>
-            <pc:sldLayoutMk cId="1444357513" sldId="2147483649"/>
-          </pc:sldLayoutMkLst>
-          <pc:spChg chg="mod">
-            <ac:chgData name="Peter Bernhardt" userId="f2333933-0b12-4d6e-972f-f87625423892" providerId="ADAL" clId="{54BAB7D7-C378-4C4A-B0F8-9DF09AB8FC9C}" dt="2026-03-18T16:35:30.591" v="0"/>
-            <ac:spMkLst>
-              <pc:docMk/>
-              <pc:sldMasterMk cId="3676200875" sldId="2147483648"/>
-              <pc:sldLayoutMk cId="1444357513" sldId="2147483649"/>
-              <ac:spMk id="2" creationId="{00000000-0000-0000-0000-000000000000}"/>
-            </ac:spMkLst>
-          </pc:spChg>
-          <pc:spChg chg="mod">
-            <ac:chgData name="Peter Bernhardt" userId="f2333933-0b12-4d6e-972f-f87625423892" providerId="ADAL" clId="{54BAB7D7-C378-4C4A-B0F8-9DF09AB8FC9C}" dt="2026-03-18T16:35:30.591" v="0"/>
-            <ac:spMkLst>
-              <pc:docMk/>
-              <pc:sldMasterMk cId="3676200875" sldId="2147483648"/>
-              <pc:sldLayoutMk cId="1444357513" sldId="2147483649"/>
-              <ac:spMk id="3" creationId="{00000000-0000-0000-0000-000000000000}"/>
-            </ac:spMkLst>
-          </pc:spChg>
-        </pc:sldLayoutChg>
-        <pc:sldLayoutChg chg="modSp">
-          <pc:chgData name="Peter Bernhardt" userId="f2333933-0b12-4d6e-972f-f87625423892" providerId="ADAL" clId="{54BAB7D7-C378-4C4A-B0F8-9DF09AB8FC9C}" dt="2026-03-18T16:35:30.591" v="0"/>
-          <pc:sldLayoutMkLst>
-            <pc:docMk/>
-            <pc:sldMasterMk cId="3676200875" sldId="2147483648"/>
-            <pc:sldLayoutMk cId="1073069076" sldId="2147483651"/>
-          </pc:sldLayoutMkLst>
-          <pc:spChg chg="mod">
-            <ac:chgData name="Peter Bernhardt" userId="f2333933-0b12-4d6e-972f-f87625423892" providerId="ADAL" clId="{54BAB7D7-C378-4C4A-B0F8-9DF09AB8FC9C}" dt="2026-03-18T16:35:30.591" v="0"/>
-            <ac:spMkLst>
-              <pc:docMk/>
-              <pc:sldMasterMk cId="3676200875" sldId="2147483648"/>
-              <pc:sldLayoutMk cId="1073069076" sldId="2147483651"/>
-              <ac:spMk id="2" creationId="{00000000-0000-0000-0000-000000000000}"/>
-            </ac:spMkLst>
-          </pc:spChg>
-          <pc:spChg chg="mod">
-            <ac:chgData name="Peter Bernhardt" userId="f2333933-0b12-4d6e-972f-f87625423892" providerId="ADAL" clId="{54BAB7D7-C378-4C4A-B0F8-9DF09AB8FC9C}" dt="2026-03-18T16:35:30.591" v="0"/>
-            <ac:spMkLst>
-              <pc:docMk/>
-              <pc:sldMasterMk cId="3676200875" sldId="2147483648"/>
-              <pc:sldLayoutMk cId="1073069076" sldId="2147483651"/>
-              <ac:spMk id="3" creationId="{00000000-0000-0000-0000-000000000000}"/>
-            </ac:spMkLst>
-          </pc:spChg>
-        </pc:sldLayoutChg>
-        <pc:sldLayoutChg chg="modSp">
-          <pc:chgData name="Peter Bernhardt" userId="f2333933-0b12-4d6e-972f-f87625423892" providerId="ADAL" clId="{54BAB7D7-C378-4C4A-B0F8-9DF09AB8FC9C}" dt="2026-03-18T16:35:30.591" v="0"/>
-          <pc:sldLayoutMkLst>
-            <pc:docMk/>
-            <pc:sldMasterMk cId="3676200875" sldId="2147483648"/>
-            <pc:sldLayoutMk cId="2619886245" sldId="2147483652"/>
-          </pc:sldLayoutMkLst>
-          <pc:spChg chg="mod">
-            <ac:chgData name="Peter Bernhardt" userId="f2333933-0b12-4d6e-972f-f87625423892" providerId="ADAL" clId="{54BAB7D7-C378-4C4A-B0F8-9DF09AB8FC9C}" dt="2026-03-18T16:35:30.591" v="0"/>
-            <ac:spMkLst>
-              <pc:docMk/>
-              <pc:sldMasterMk cId="3676200875" sldId="2147483648"/>
-              <pc:sldLayoutMk cId="2619886245" sldId="2147483652"/>
-              <ac:spMk id="3" creationId="{00000000-0000-0000-0000-000000000000}"/>
-            </ac:spMkLst>
-          </pc:spChg>
-          <pc:spChg chg="mod">
-            <ac:chgData name="Peter Bernhardt" userId="f2333933-0b12-4d6e-972f-f87625423892" providerId="ADAL" clId="{54BAB7D7-C378-4C4A-B0F8-9DF09AB8FC9C}" dt="2026-03-18T16:35:30.591" v="0"/>
-            <ac:spMkLst>
-              <pc:docMk/>
-              <pc:sldMasterMk cId="3676200875" sldId="2147483648"/>
-              <pc:sldLayoutMk cId="2619886245" sldId="2147483652"/>
-              <ac:spMk id="4" creationId="{00000000-0000-0000-0000-000000000000}"/>
-            </ac:spMkLst>
-          </pc:spChg>
-        </pc:sldLayoutChg>
-        <pc:sldLayoutChg chg="modSp">
-          <pc:chgData name="Peter Bernhardt" userId="f2333933-0b12-4d6e-972f-f87625423892" providerId="ADAL" clId="{54BAB7D7-C378-4C4A-B0F8-9DF09AB8FC9C}" dt="2026-03-18T16:35:30.591" v="0"/>
-          <pc:sldLayoutMkLst>
-            <pc:docMk/>
-            <pc:sldMasterMk cId="3676200875" sldId="2147483648"/>
-            <pc:sldLayoutMk cId="2535793967" sldId="2147483653"/>
-          </pc:sldLayoutMkLst>
-          <pc:spChg chg="mod">
-            <ac:chgData name="Peter Bernhardt" userId="f2333933-0b12-4d6e-972f-f87625423892" providerId="ADAL" clId="{54BAB7D7-C378-4C4A-B0F8-9DF09AB8FC9C}" dt="2026-03-18T16:35:30.591" v="0"/>
-            <ac:spMkLst>
-              <pc:docMk/>
-              <pc:sldMasterMk cId="3676200875" sldId="2147483648"/>
-              <pc:sldLayoutMk cId="2535793967" sldId="2147483653"/>
-              <ac:spMk id="3" creationId="{00000000-0000-0000-0000-000000000000}"/>
-            </ac:spMkLst>
-          </pc:spChg>
-          <pc:spChg chg="mod">
-            <ac:chgData name="Peter Bernhardt" userId="f2333933-0b12-4d6e-972f-f87625423892" providerId="ADAL" clId="{54BAB7D7-C378-4C4A-B0F8-9DF09AB8FC9C}" dt="2026-03-18T16:35:30.591" v="0"/>
-            <ac:spMkLst>
-              <pc:docMk/>
-              <pc:sldMasterMk cId="3676200875" sldId="2147483648"/>
-              <pc:sldLayoutMk cId="2535793967" sldId="2147483653"/>
-              <ac:spMk id="4" creationId="{00000000-0000-0000-0000-000000000000}"/>
-            </ac:spMkLst>
-          </pc:spChg>
-          <pc:spChg chg="mod">
-            <ac:chgData name="Peter Bernhardt" userId="f2333933-0b12-4d6e-972f-f87625423892" providerId="ADAL" clId="{54BAB7D7-C378-4C4A-B0F8-9DF09AB8FC9C}" dt="2026-03-18T16:35:30.591" v="0"/>
-            <ac:spMkLst>
-              <pc:docMk/>
-              <pc:sldMasterMk cId="3676200875" sldId="2147483648"/>
-              <pc:sldLayoutMk cId="2535793967" sldId="2147483653"/>
-              <ac:spMk id="5" creationId="{00000000-0000-0000-0000-000000000000}"/>
-            </ac:spMkLst>
-          </pc:spChg>
-          <pc:spChg chg="mod">
-            <ac:chgData name="Peter Bernhardt" userId="f2333933-0b12-4d6e-972f-f87625423892" providerId="ADAL" clId="{54BAB7D7-C378-4C4A-B0F8-9DF09AB8FC9C}" dt="2026-03-18T16:35:30.591" v="0"/>
-            <ac:spMkLst>
-              <pc:docMk/>
-              <pc:sldMasterMk cId="3676200875" sldId="2147483648"/>
-              <pc:sldLayoutMk cId="2535793967" sldId="2147483653"/>
-              <ac:spMk id="6" creationId="{00000000-0000-0000-0000-000000000000}"/>
-            </ac:spMkLst>
-          </pc:spChg>
-        </pc:sldLayoutChg>
-        <pc:sldLayoutChg chg="modSp">
-          <pc:chgData name="Peter Bernhardt" userId="f2333933-0b12-4d6e-972f-f87625423892" providerId="ADAL" clId="{54BAB7D7-C378-4C4A-B0F8-9DF09AB8FC9C}" dt="2026-03-18T16:35:30.591" v="0"/>
-          <pc:sldLayoutMkLst>
-            <pc:docMk/>
-            <pc:sldMasterMk cId="3676200875" sldId="2147483648"/>
-            <pc:sldLayoutMk cId="3540895647" sldId="2147483656"/>
-          </pc:sldLayoutMkLst>
-          <pc:spChg chg="mod">
-            <ac:chgData name="Peter Bernhardt" userId="f2333933-0b12-4d6e-972f-f87625423892" providerId="ADAL" clId="{54BAB7D7-C378-4C4A-B0F8-9DF09AB8FC9C}" dt="2026-03-18T16:35:30.591" v="0"/>
-            <ac:spMkLst>
-              <pc:docMk/>
-              <pc:sldMasterMk cId="3676200875" sldId="2147483648"/>
-              <pc:sldLayoutMk cId="3540895647" sldId="2147483656"/>
-              <ac:spMk id="2" creationId="{00000000-0000-0000-0000-000000000000}"/>
-            </ac:spMkLst>
-          </pc:spChg>
-          <pc:spChg chg="mod">
-            <ac:chgData name="Peter Bernhardt" userId="f2333933-0b12-4d6e-972f-f87625423892" providerId="ADAL" clId="{54BAB7D7-C378-4C4A-B0F8-9DF09AB8FC9C}" dt="2026-03-18T16:35:30.591" v="0"/>
-            <ac:spMkLst>
-              <pc:docMk/>
-              <pc:sldMasterMk cId="3676200875" sldId="2147483648"/>
-              <pc:sldLayoutMk cId="3540895647" sldId="2147483656"/>
-              <ac:spMk id="3" creationId="{00000000-0000-0000-0000-000000000000}"/>
-            </ac:spMkLst>
-          </pc:spChg>
-          <pc:spChg chg="mod">
-            <ac:chgData name="Peter Bernhardt" userId="f2333933-0b12-4d6e-972f-f87625423892" providerId="ADAL" clId="{54BAB7D7-C378-4C4A-B0F8-9DF09AB8FC9C}" dt="2026-03-18T16:35:30.591" v="0"/>
-            <ac:spMkLst>
-              <pc:docMk/>
-              <pc:sldMasterMk cId="3676200875" sldId="2147483648"/>
-              <pc:sldLayoutMk cId="3540895647" sldId="2147483656"/>
-              <ac:spMk id="4" creationId="{00000000-0000-0000-0000-000000000000}"/>
-            </ac:spMkLst>
-          </pc:spChg>
-        </pc:sldLayoutChg>
-        <pc:sldLayoutChg chg="modSp">
-          <pc:chgData name="Peter Bernhardt" userId="f2333933-0b12-4d6e-972f-f87625423892" providerId="ADAL" clId="{54BAB7D7-C378-4C4A-B0F8-9DF09AB8FC9C}" dt="2026-03-18T16:35:30.591" v="0"/>
-          <pc:sldLayoutMkLst>
-            <pc:docMk/>
-            <pc:sldMasterMk cId="3676200875" sldId="2147483648"/>
-            <pc:sldLayoutMk cId="3566899855" sldId="2147483657"/>
-          </pc:sldLayoutMkLst>
-          <pc:spChg chg="mod">
-            <ac:chgData name="Peter Bernhardt" userId="f2333933-0b12-4d6e-972f-f87625423892" providerId="ADAL" clId="{54BAB7D7-C378-4C4A-B0F8-9DF09AB8FC9C}" dt="2026-03-18T16:35:30.591" v="0"/>
-            <ac:spMkLst>
-              <pc:docMk/>
-              <pc:sldMasterMk cId="3676200875" sldId="2147483648"/>
-              <pc:sldLayoutMk cId="3566899855" sldId="2147483657"/>
-              <ac:spMk id="2" creationId="{00000000-0000-0000-0000-000000000000}"/>
-            </ac:spMkLst>
-          </pc:spChg>
-          <pc:spChg chg="mod">
-            <ac:chgData name="Peter Bernhardt" userId="f2333933-0b12-4d6e-972f-f87625423892" providerId="ADAL" clId="{54BAB7D7-C378-4C4A-B0F8-9DF09AB8FC9C}" dt="2026-03-18T16:35:30.591" v="0"/>
-            <ac:spMkLst>
-              <pc:docMk/>
-              <pc:sldMasterMk cId="3676200875" sldId="2147483648"/>
-              <pc:sldLayoutMk cId="3566899855" sldId="2147483657"/>
-              <ac:spMk id="3" creationId="{00000000-0000-0000-0000-000000000000}"/>
-            </ac:spMkLst>
-          </pc:spChg>
-          <pc:spChg chg="mod">
-            <ac:chgData name="Peter Bernhardt" userId="f2333933-0b12-4d6e-972f-f87625423892" providerId="ADAL" clId="{54BAB7D7-C378-4C4A-B0F8-9DF09AB8FC9C}" dt="2026-03-18T16:35:30.591" v="0"/>
-            <ac:spMkLst>
-              <pc:docMk/>
-              <pc:sldMasterMk cId="3676200875" sldId="2147483648"/>
-              <pc:sldLayoutMk cId="3566899855" sldId="2147483657"/>
-              <ac:spMk id="4" creationId="{00000000-0000-0000-0000-000000000000}"/>
-            </ac:spMkLst>
-          </pc:spChg>
-        </pc:sldLayoutChg>
-        <pc:sldLayoutChg chg="modSp">
-          <pc:chgData name="Peter Bernhardt" userId="f2333933-0b12-4d6e-972f-f87625423892" providerId="ADAL" clId="{54BAB7D7-C378-4C4A-B0F8-9DF09AB8FC9C}" dt="2026-03-18T16:35:30.591" v="0"/>
-          <pc:sldLayoutMkLst>
-            <pc:docMk/>
-            <pc:sldMasterMk cId="3676200875" sldId="2147483648"/>
-            <pc:sldLayoutMk cId="2581529045" sldId="2147483659"/>
-          </pc:sldLayoutMkLst>
-          <pc:spChg chg="mod">
-            <ac:chgData name="Peter Bernhardt" userId="f2333933-0b12-4d6e-972f-f87625423892" providerId="ADAL" clId="{54BAB7D7-C378-4C4A-B0F8-9DF09AB8FC9C}" dt="2026-03-18T16:35:30.591" v="0"/>
-            <ac:spMkLst>
-              <pc:docMk/>
-              <pc:sldMasterMk cId="3676200875" sldId="2147483648"/>
-              <pc:sldLayoutMk cId="2581529045" sldId="2147483659"/>
-              <ac:spMk id="2" creationId="{00000000-0000-0000-0000-000000000000}"/>
-            </ac:spMkLst>
-          </pc:spChg>
-          <pc:spChg chg="mod">
-            <ac:chgData name="Peter Bernhardt" userId="f2333933-0b12-4d6e-972f-f87625423892" providerId="ADAL" clId="{54BAB7D7-C378-4C4A-B0F8-9DF09AB8FC9C}" dt="2026-03-18T16:35:30.591" v="0"/>
-            <ac:spMkLst>
-              <pc:docMk/>
-              <pc:sldMasterMk cId="3676200875" sldId="2147483648"/>
-              <pc:sldLayoutMk cId="2581529045" sldId="2147483659"/>
-              <ac:spMk id="3" creationId="{00000000-0000-0000-0000-000000000000}"/>
-            </ac:spMkLst>
-          </pc:spChg>
-        </pc:sldLayoutChg>
-      </pc:sldMasterChg>
-      <pc:sldMasterChg chg="modSp mod modSldLayout">
-        <pc:chgData name="Peter Bernhardt" userId="f2333933-0b12-4d6e-972f-f87625423892" providerId="ADAL" clId="{54BAB7D7-C378-4C4A-B0F8-9DF09AB8FC9C}" dt="2026-03-18T17:16:09.783" v="436" actId="403"/>
-        <pc:sldMasterMkLst>
-          <pc:docMk/>
-          <pc:sldMasterMk cId="3715007525" sldId="2147483750"/>
-        </pc:sldMasterMkLst>
-        <pc:spChg chg="mod">
-          <ac:chgData name="Peter Bernhardt" userId="f2333933-0b12-4d6e-972f-f87625423892" providerId="ADAL" clId="{54BAB7D7-C378-4C4A-B0F8-9DF09AB8FC9C}" dt="2026-03-18T16:41:48.305" v="241" actId="20577"/>
-          <ac:spMkLst>
-            <pc:docMk/>
-            <pc:sldMasterMk cId="3715007525" sldId="2147483750"/>
-            <ac:spMk id="2" creationId="{00000000-0000-0000-0000-000000000000}"/>
-          </ac:spMkLst>
-        </pc:spChg>
-        <pc:spChg chg="mod">
-          <ac:chgData name="Peter Bernhardt" userId="f2333933-0b12-4d6e-972f-f87625423892" providerId="ADAL" clId="{54BAB7D7-C378-4C4A-B0F8-9DF09AB8FC9C}" dt="2026-03-18T16:42:03.580" v="272" actId="14100"/>
-          <ac:spMkLst>
-            <pc:docMk/>
-            <pc:sldMasterMk cId="3715007525" sldId="2147483750"/>
-            <ac:spMk id="3" creationId="{00000000-0000-0000-0000-000000000000}"/>
-          </ac:spMkLst>
-        </pc:spChg>
-        <pc:cxnChg chg="mod">
-          <ac:chgData name="Peter Bernhardt" userId="f2333933-0b12-4d6e-972f-f87625423892" providerId="ADAL" clId="{54BAB7D7-C378-4C4A-B0F8-9DF09AB8FC9C}" dt="2026-03-18T16:41:55.705" v="265" actId="1035"/>
-          <ac:cxnSpMkLst>
-            <pc:docMk/>
-            <pc:sldMasterMk cId="3715007525" sldId="2147483750"/>
-            <ac:cxnSpMk id="10" creationId="{00000000-0000-0000-0000-000000000000}"/>
-          </ac:cxnSpMkLst>
-        </pc:cxnChg>
-        <pc:sldLayoutChg chg="modSp mod">
-          <pc:chgData name="Peter Bernhardt" userId="f2333933-0b12-4d6e-972f-f87625423892" providerId="ADAL" clId="{54BAB7D7-C378-4C4A-B0F8-9DF09AB8FC9C}" dt="2026-03-18T16:42:12.756" v="279" actId="404"/>
-          <pc:sldLayoutMkLst>
-            <pc:docMk/>
-            <pc:sldMasterMk cId="3715007525" sldId="2147483750"/>
-            <pc:sldLayoutMk cId="1222138658" sldId="2147483751"/>
-          </pc:sldLayoutMkLst>
-          <pc:spChg chg="mod">
-            <ac:chgData name="Peter Bernhardt" userId="f2333933-0b12-4d6e-972f-f87625423892" providerId="ADAL" clId="{54BAB7D7-C378-4C4A-B0F8-9DF09AB8FC9C}" dt="2026-03-18T16:42:12.756" v="279" actId="404"/>
-            <ac:spMkLst>
-              <pc:docMk/>
-              <pc:sldMasterMk cId="3715007525" sldId="2147483750"/>
-              <pc:sldLayoutMk cId="1222138658" sldId="2147483751"/>
-              <ac:spMk id="2" creationId="{00000000-0000-0000-0000-000000000000}"/>
-            </ac:spMkLst>
-          </pc:spChg>
-        </pc:sldLayoutChg>
-        <pc:sldLayoutChg chg="modSp mod">
-          <pc:chgData name="Peter Bernhardt" userId="f2333933-0b12-4d6e-972f-f87625423892" providerId="ADAL" clId="{54BAB7D7-C378-4C4A-B0F8-9DF09AB8FC9C}" dt="2026-03-18T17:16:09.783" v="436" actId="403"/>
-          <pc:sldLayoutMkLst>
-            <pc:docMk/>
-            <pc:sldMasterMk cId="3715007525" sldId="2147483750"/>
-            <pc:sldLayoutMk cId="2723228330" sldId="2147483752"/>
-          </pc:sldLayoutMkLst>
-          <pc:spChg chg="mod">
-            <ac:chgData name="Peter Bernhardt" userId="f2333933-0b12-4d6e-972f-f87625423892" providerId="ADAL" clId="{54BAB7D7-C378-4C4A-B0F8-9DF09AB8FC9C}" dt="2026-03-18T16:41:24.217" v="210" actId="255"/>
-            <ac:spMkLst>
-              <pc:docMk/>
-              <pc:sldMasterMk cId="3715007525" sldId="2147483750"/>
-              <pc:sldLayoutMk cId="2723228330" sldId="2147483752"/>
-              <ac:spMk id="2" creationId="{00000000-0000-0000-0000-000000000000}"/>
-            </ac:spMkLst>
-          </pc:spChg>
-          <pc:spChg chg="mod">
-            <ac:chgData name="Peter Bernhardt" userId="f2333933-0b12-4d6e-972f-f87625423892" providerId="ADAL" clId="{54BAB7D7-C378-4C4A-B0F8-9DF09AB8FC9C}" dt="2026-03-18T17:16:09.783" v="436" actId="403"/>
-            <ac:spMkLst>
-              <pc:docMk/>
-              <pc:sldMasterMk cId="3715007525" sldId="2147483750"/>
-              <pc:sldLayoutMk cId="2723228330" sldId="2147483752"/>
-              <ac:spMk id="3" creationId="{00000000-0000-0000-0000-000000000000}"/>
-            </ac:spMkLst>
-          </pc:spChg>
-        </pc:sldLayoutChg>
-        <pc:sldLayoutChg chg="modSp mod">
-          <pc:chgData name="Peter Bernhardt" userId="f2333933-0b12-4d6e-972f-f87625423892" providerId="ADAL" clId="{54BAB7D7-C378-4C4A-B0F8-9DF09AB8FC9C}" dt="2026-03-18T16:46:14.357" v="293" actId="113"/>
-          <pc:sldLayoutMkLst>
-            <pc:docMk/>
-            <pc:sldMasterMk cId="3715007525" sldId="2147483750"/>
-            <pc:sldLayoutMk cId="1145065635" sldId="2147483753"/>
-          </pc:sldLayoutMkLst>
-          <pc:spChg chg="mod">
-            <ac:chgData name="Peter Bernhardt" userId="f2333933-0b12-4d6e-972f-f87625423892" providerId="ADAL" clId="{54BAB7D7-C378-4C4A-B0F8-9DF09AB8FC9C}" dt="2026-03-18T16:46:14.357" v="293" actId="113"/>
-            <ac:spMkLst>
-              <pc:docMk/>
-              <pc:sldMasterMk cId="3715007525" sldId="2147483750"/>
-              <pc:sldLayoutMk cId="1145065635" sldId="2147483753"/>
-              <ac:spMk id="2" creationId="{00000000-0000-0000-0000-000000000000}"/>
-            </ac:spMkLst>
-          </pc:spChg>
-        </pc:sldLayoutChg>
-      </pc:sldMasterChg>
     </pc:docChg>
   </pc:docChgLst>
 </pc:chgInfo>
+</file>
+
+<file path=ppt/handoutMasters/handoutMaster1.xml><?xml version="1.0" encoding="utf-8"?>
+<p:handoutMaster xmlns:a="http://schemas.openxmlformats.org/drawingml/2006/main" xmlns:r="http://schemas.openxmlformats.org/officeDocument/2006/relationships" xmlns:p="http://schemas.openxmlformats.org/presentationml/2006/main">
+  <p:cSld>
+    <p:bg>
+      <p:bgRef idx="1001">
+        <a:schemeClr val="bg1"/>
+      </p:bgRef>
+    </p:bg>
+    <p:spTree>
+      <p:nvGrpSpPr>
+        <p:cNvPr id="1" name=""/>
+        <p:cNvGrpSpPr/>
+        <p:nvPr/>
+      </p:nvGrpSpPr>
+      <p:grpSpPr>
+        <a:xfrm>
+          <a:off x="0" y="0"/>
+          <a:ext cx="0" cy="0"/>
+          <a:chOff x="0" y="0"/>
+          <a:chExt cx="0" cy="0"/>
+        </a:xfrm>
+      </p:grpSpPr>
+      <p:sp>
+        <p:nvSpPr>
+          <p:cNvPr id="2" name="Kopfzeilenplatzhalter 1">
+            <a:extLst>
+              <a:ext uri="{FF2B5EF4-FFF2-40B4-BE49-F238E27FC236}">
+                <a16:creationId xmlns:a16="http://schemas.microsoft.com/office/drawing/2014/main" id="{F327EB1D-86E4-5FFD-9DEE-FE4D388C49C5}"/>
+              </a:ext>
+            </a:extLst>
+          </p:cNvPr>
+          <p:cNvSpPr>
+            <a:spLocks noGrp="1"/>
+          </p:cNvSpPr>
+          <p:nvPr>
+            <p:ph type="hdr" sz="quarter"/>
+          </p:nvPr>
+        </p:nvSpPr>
+        <p:spPr>
+          <a:xfrm>
+            <a:off x="0" y="0"/>
+            <a:ext cx="2971800" cy="458788"/>
+          </a:xfrm>
+          <a:prstGeom prst="rect">
+            <a:avLst/>
+          </a:prstGeom>
+        </p:spPr>
+        <p:txBody>
+          <a:bodyPr vert="horz" lIns="91440" tIns="45720" rIns="91440" bIns="45720" rtlCol="0"/>
+          <a:lstStyle>
+            <a:lvl1pPr algn="l">
+              <a:defRPr sz="1200"/>
+            </a:lvl1pPr>
+          </a:lstStyle>
+          <a:p>
+            <a:endParaRPr lang="de-DE"/>
+          </a:p>
+        </p:txBody>
+      </p:sp>
+      <p:sp>
+        <p:nvSpPr>
+          <p:cNvPr id="4" name="Fußzeilenplatzhalter 3">
+            <a:extLst>
+              <a:ext uri="{FF2B5EF4-FFF2-40B4-BE49-F238E27FC236}">
+                <a16:creationId xmlns:a16="http://schemas.microsoft.com/office/drawing/2014/main" id="{4D7D95B1-466A-708F-F5DF-0CE22EFD9201}"/>
+              </a:ext>
+            </a:extLst>
+          </p:cNvPr>
+          <p:cNvSpPr>
+            <a:spLocks noGrp="1"/>
+          </p:cNvSpPr>
+          <p:nvPr>
+            <p:ph type="ftr" sz="quarter" idx="2"/>
+          </p:nvPr>
+        </p:nvSpPr>
+        <p:spPr>
+          <a:xfrm>
+            <a:off x="0" y="8685213"/>
+            <a:ext cx="2971800" cy="458787"/>
+          </a:xfrm>
+          <a:prstGeom prst="rect">
+            <a:avLst/>
+          </a:prstGeom>
+        </p:spPr>
+        <p:txBody>
+          <a:bodyPr vert="horz" lIns="91440" tIns="45720" rIns="91440" bIns="45720" rtlCol="0" anchor="b"/>
+          <a:lstStyle>
+            <a:lvl1pPr algn="l">
+              <a:defRPr sz="1200"/>
+            </a:lvl1pPr>
+          </a:lstStyle>
+          <a:p>
+            <a:endParaRPr lang="de-DE"/>
+          </a:p>
+        </p:txBody>
+      </p:sp>
+      <p:sp>
+        <p:nvSpPr>
+          <p:cNvPr id="5" name="Foliennummernplatzhalter 4">
+            <a:extLst>
+              <a:ext uri="{FF2B5EF4-FFF2-40B4-BE49-F238E27FC236}">
+                <a16:creationId xmlns:a16="http://schemas.microsoft.com/office/drawing/2014/main" id="{E92A8533-649C-179E-2C79-939BDAB6D87A}"/>
+              </a:ext>
+            </a:extLst>
+          </p:cNvPr>
+          <p:cNvSpPr>
+            <a:spLocks noGrp="1"/>
+          </p:cNvSpPr>
+          <p:nvPr>
+            <p:ph type="sldNum" sz="quarter" idx="3"/>
+          </p:nvPr>
+        </p:nvSpPr>
+        <p:spPr>
+          <a:xfrm>
+            <a:off x="3884613" y="8685213"/>
+            <a:ext cx="2971800" cy="458787"/>
+          </a:xfrm>
+          <a:prstGeom prst="rect">
+            <a:avLst/>
+          </a:prstGeom>
+        </p:spPr>
+        <p:txBody>
+          <a:bodyPr vert="horz" lIns="91440" tIns="45720" rIns="91440" bIns="45720" rtlCol="0" anchor="b"/>
+          <a:lstStyle>
+            <a:lvl1pPr algn="r">
+              <a:defRPr sz="1200"/>
+            </a:lvl1pPr>
+          </a:lstStyle>
+          <a:p>
+            <a:fld id="{6C5E6BA0-B6F9-4E1B-B2C3-CF57F34F74FE}" type="slidenum">
+              <a:rPr lang="de-DE" smtClean="0"/>
+              <a:t>‹Nr.›</a:t>
+            </a:fld>
+            <a:endParaRPr lang="de-DE"/>
+          </a:p>
+        </p:txBody>
+      </p:sp>
+    </p:spTree>
+    <p:extLst>
+      <p:ext uri="{BB962C8B-B14F-4D97-AF65-F5344CB8AC3E}">
+        <p14:creationId xmlns:p14="http://schemas.microsoft.com/office/powerpoint/2010/main" val="3889744366"/>
+      </p:ext>
+    </p:extLst>
+  </p:cSld>
+  <p:clrMap bg1="lt1" tx1="dk1" bg2="lt2" tx2="dk2" accent1="accent1" accent2="accent2" accent3="accent3" accent4="accent4" accent5="accent5" accent6="accent6" hlink="hlink" folHlink="folHlink"/>
+</p:handoutMaster>
 </file>
 
 <file path=ppt/slideLayouts/slideLayout1.xml><?xml version="1.0" encoding="utf-8"?>
@@ -2932,7 +561,7 @@
           <a:p>
             <a:fld id="{241EB5C9-1307-BA42-ABA2-0BC069CD8E7F}" type="datetimeFigureOut">
               <a:rPr lang="en-US" smtClean="0"/>
-              <a:t>3/18/2026</a:t>
+              <a:t>4/21/2026</a:t>
             </a:fld>
             <a:endParaRPr lang="en-US"/>
           </a:p>
@@ -3140,7 +769,7 @@
           <a:p>
             <a:fld id="{241EB5C9-1307-BA42-ABA2-0BC069CD8E7F}" type="datetimeFigureOut">
               <a:rPr lang="en-US" smtClean="0"/>
-              <a:t>3/18/2026</a:t>
+              <a:t>4/21/2026</a:t>
             </a:fld>
             <a:endParaRPr lang="en-US"/>
           </a:p>
@@ -3396,7 +1025,7 @@
           <a:p>
             <a:fld id="{241EB5C9-1307-BA42-ABA2-0BC069CD8E7F}" type="datetimeFigureOut">
               <a:rPr lang="en-US" smtClean="0"/>
-              <a:t>3/18/2026</a:t>
+              <a:t>4/21/2026</a:t>
             </a:fld>
             <a:endParaRPr lang="en-US"/>
           </a:p>
@@ -3584,7 +1213,7 @@
           <a:p>
             <a:fld id="{241EB5C9-1307-BA42-ABA2-0BC069CD8E7F}" type="datetimeFigureOut">
               <a:rPr lang="en-US" smtClean="0"/>
-              <a:t>3/18/2026</a:t>
+              <a:t>4/21/2026</a:t>
             </a:fld>
             <a:endParaRPr lang="en-US"/>
           </a:p>
@@ -3941,7 +1570,7 @@
           <a:p>
             <a:fld id="{241EB5C9-1307-BA42-ABA2-0BC069CD8E7F}" type="datetimeFigureOut">
               <a:rPr lang="en-US" smtClean="0"/>
-              <a:t>3/18/2026</a:t>
+              <a:t>4/21/2026</a:t>
             </a:fld>
             <a:endParaRPr lang="en-US"/>
           </a:p>
@@ -4216,7 +1845,7 @@
           <a:p>
             <a:fld id="{241EB5C9-1307-BA42-ABA2-0BC069CD8E7F}" type="datetimeFigureOut">
               <a:rPr lang="en-US" smtClean="0"/>
-              <a:t>3/18/2026</a:t>
+              <a:t>4/21/2026</a:t>
             </a:fld>
             <a:endParaRPr lang="en-US"/>
           </a:p>
@@ -4595,7 +2224,7 @@
           <a:p>
             <a:fld id="{241EB5C9-1307-BA42-ABA2-0BC069CD8E7F}" type="datetimeFigureOut">
               <a:rPr lang="en-US" smtClean="0"/>
-              <a:t>3/18/2026</a:t>
+              <a:t>4/21/2026</a:t>
             </a:fld>
             <a:endParaRPr lang="en-US"/>
           </a:p>
@@ -4713,7 +2342,7 @@
           <a:p>
             <a:fld id="{241EB5C9-1307-BA42-ABA2-0BC069CD8E7F}" type="datetimeFigureOut">
               <a:rPr lang="en-US" smtClean="0"/>
-              <a:t>3/18/2026</a:t>
+              <a:t>4/21/2026</a:t>
             </a:fld>
             <a:endParaRPr lang="en-US"/>
           </a:p>
@@ -4884,7 +2513,7 @@
           <a:p>
             <a:fld id="{241EB5C9-1307-BA42-ABA2-0BC069CD8E7F}" type="datetimeFigureOut">
               <a:rPr lang="en-US" smtClean="0"/>
-              <a:t>3/18/2026</a:t>
+              <a:t>4/21/2026</a:t>
             </a:fld>
             <a:endParaRPr lang="en-US"/>
           </a:p>
@@ -5252,7 +2881,7 @@
           <a:p>
             <a:fld id="{241EB5C9-1307-BA42-ABA2-0BC069CD8E7F}" type="datetimeFigureOut">
               <a:rPr lang="en-US" smtClean="0"/>
-              <a:t>3/18/2026</a:t>
+              <a:t>4/21/2026</a:t>
             </a:fld>
             <a:endParaRPr lang="en-US"/>
           </a:p>
@@ -5629,7 +3258,7 @@
           <a:p>
             <a:fld id="{241EB5C9-1307-BA42-ABA2-0BC069CD8E7F}" type="datetimeFigureOut">
               <a:rPr lang="en-US" smtClean="0"/>
-              <a:t>3/18/2026</a:t>
+              <a:t>4/21/2026</a:t>
             </a:fld>
             <a:endParaRPr lang="en-US"/>
           </a:p>
@@ -5930,7 +3559,7 @@
           <a:p>
             <a:fld id="{241EB5C9-1307-BA42-ABA2-0BC069CD8E7F}" type="datetimeFigureOut">
               <a:rPr lang="en-US" smtClean="0"/>
-              <a:t>3/18/2026</a:t>
+              <a:t>4/21/2026</a:t>
             </a:fld>
             <a:endParaRPr lang="en-US"/>
           </a:p>
@@ -15218,4 +12847,319 @@
     </a:ext>
   </a:extLst>
 </a:theme>
+</file>
+
+<file path=ppt/theme/theme2.xml><?xml version="1.0" encoding="utf-8"?>
+<a:theme xmlns:a="http://schemas.openxmlformats.org/drawingml/2006/main" name="Office">
+  <a:themeElements>
+    <a:clrScheme name="Office">
+      <a:dk1>
+        <a:sysClr val="windowText" lastClr="000000"/>
+      </a:dk1>
+      <a:lt1>
+        <a:sysClr val="window" lastClr="FFFFFF"/>
+      </a:lt1>
+      <a:dk2>
+        <a:srgbClr val="0E2841"/>
+      </a:dk2>
+      <a:lt2>
+        <a:srgbClr val="E8E8E8"/>
+      </a:lt2>
+      <a:accent1>
+        <a:srgbClr val="156082"/>
+      </a:accent1>
+      <a:accent2>
+        <a:srgbClr val="E97132"/>
+      </a:accent2>
+      <a:accent3>
+        <a:srgbClr val="196B24"/>
+      </a:accent3>
+      <a:accent4>
+        <a:srgbClr val="0F9ED5"/>
+      </a:accent4>
+      <a:accent5>
+        <a:srgbClr val="A02B93"/>
+      </a:accent5>
+      <a:accent6>
+        <a:srgbClr val="4EA72E"/>
+      </a:accent6>
+      <a:hlink>
+        <a:srgbClr val="467886"/>
+      </a:hlink>
+      <a:folHlink>
+        <a:srgbClr val="96607D"/>
+      </a:folHlink>
+    </a:clrScheme>
+    <a:fontScheme name="Office">
+      <a:majorFont>
+        <a:latin typeface="Aptos Display" panose="02110004020202020204"/>
+        <a:ea typeface=""/>
+        <a:cs typeface=""/>
+        <a:font script="Jpan" typeface="游ゴシック Light"/>
+        <a:font script="Hang" typeface="맑은 고딕"/>
+        <a:font script="Hans" typeface="等线 Light"/>
+        <a:font script="Hant" typeface="新細明體"/>
+        <a:font script="Arab" typeface="Times New Roman"/>
+        <a:font script="Hebr" typeface="Times New Roman"/>
+        <a:font script="Thai" typeface="Angsana New"/>
+        <a:font script="Ethi" typeface="Nyala"/>
+        <a:font script="Beng" typeface="Vrinda"/>
+        <a:font script="Gujr" typeface="Shruti"/>
+        <a:font script="Khmr" typeface="MoolBoran"/>
+        <a:font script="Knda" typeface="Tunga"/>
+        <a:font script="Guru" typeface="Raavi"/>
+        <a:font script="Cans" typeface="Euphemia"/>
+        <a:font script="Cher" typeface="Plantagenet Cherokee"/>
+        <a:font script="Yiii" typeface="Microsoft Yi Baiti"/>
+        <a:font script="Tibt" typeface="Microsoft Himalaya"/>
+        <a:font script="Thaa" typeface="MV Boli"/>
+        <a:font script="Deva" typeface="Mangal"/>
+        <a:font script="Telu" typeface="Gautami"/>
+        <a:font script="Taml" typeface="Latha"/>
+        <a:font script="Syrc" typeface="Estrangelo Edessa"/>
+        <a:font script="Orya" typeface="Kalinga"/>
+        <a:font script="Mlym" typeface="Kartika"/>
+        <a:font script="Laoo" typeface="DokChampa"/>
+        <a:font script="Sinh" typeface="Iskoola Pota"/>
+        <a:font script="Mong" typeface="Mongolian Baiti"/>
+        <a:font script="Viet" typeface="Times New Roman"/>
+        <a:font script="Uigh" typeface="Microsoft Uighur"/>
+        <a:font script="Geor" typeface="Sylfaen"/>
+        <a:font script="Armn" typeface="Arial"/>
+        <a:font script="Bugi" typeface="Leelawadee UI"/>
+        <a:font script="Bopo" typeface="Microsoft JhengHei"/>
+        <a:font script="Java" typeface="Javanese Text"/>
+        <a:font script="Lisu" typeface="Segoe UI"/>
+        <a:font script="Mymr" typeface="Myanmar Text"/>
+        <a:font script="Nkoo" typeface="Ebrima"/>
+        <a:font script="Olck" typeface="Nirmala UI"/>
+        <a:font script="Osma" typeface="Ebrima"/>
+        <a:font script="Phag" typeface="Phagspa"/>
+        <a:font script="Syrn" typeface="Estrangelo Edessa"/>
+        <a:font script="Syrj" typeface="Estrangelo Edessa"/>
+        <a:font script="Syre" typeface="Estrangelo Edessa"/>
+        <a:font script="Sora" typeface="Nirmala UI"/>
+        <a:font script="Tale" typeface="Microsoft Tai Le"/>
+        <a:font script="Talu" typeface="Microsoft New Tai Lue"/>
+        <a:font script="Tfng" typeface="Ebrima"/>
+      </a:majorFont>
+      <a:minorFont>
+        <a:latin typeface="Aptos" panose="02110004020202020204"/>
+        <a:ea typeface=""/>
+        <a:cs typeface=""/>
+        <a:font script="Jpan" typeface="游ゴシック"/>
+        <a:font script="Hang" typeface="맑은 고딕"/>
+        <a:font script="Hans" typeface="等线"/>
+        <a:font script="Hant" typeface="新細明體"/>
+        <a:font script="Arab" typeface="Arial"/>
+        <a:font script="Hebr" typeface="Arial"/>
+        <a:font script="Thai" typeface="Cordia New"/>
+        <a:font script="Ethi" typeface="Nyala"/>
+        <a:font script="Beng" typeface="Vrinda"/>
+        <a:font script="Gujr" typeface="Shruti"/>
+        <a:font script="Khmr" typeface="DaunPenh"/>
+        <a:font script="Knda" typeface="Tunga"/>
+        <a:font script="Guru" typeface="Raavi"/>
+        <a:font script="Cans" typeface="Euphemia"/>
+        <a:font script="Cher" typeface="Plantagenet Cherokee"/>
+        <a:font script="Yiii" typeface="Microsoft Yi Baiti"/>
+        <a:font script="Tibt" typeface="Microsoft Himalaya"/>
+        <a:font script="Thaa" typeface="MV Boli"/>
+        <a:font script="Deva" typeface="Mangal"/>
+        <a:font script="Telu" typeface="Gautami"/>
+        <a:font script="Taml" typeface="Latha"/>
+        <a:font script="Syrc" typeface="Estrangelo Edessa"/>
+        <a:font script="Orya" typeface="Kalinga"/>
+        <a:font script="Mlym" typeface="Kartika"/>
+        <a:font script="Laoo" typeface="DokChampa"/>
+        <a:font script="Sinh" typeface="Iskoola Pota"/>
+        <a:font script="Mong" typeface="Mongolian Baiti"/>
+        <a:font script="Viet" typeface="Arial"/>
+        <a:font script="Uigh" typeface="Microsoft Uighur"/>
+        <a:font script="Geor" typeface="Sylfaen"/>
+        <a:font script="Armn" typeface="Arial"/>
+        <a:font script="Bugi" typeface="Leelawadee UI"/>
+        <a:font script="Bopo" typeface="Microsoft JhengHei"/>
+        <a:font script="Java" typeface="Javanese Text"/>
+        <a:font script="Lisu" typeface="Segoe UI"/>
+        <a:font script="Mymr" typeface="Myanmar Text"/>
+        <a:font script="Nkoo" typeface="Ebrima"/>
+        <a:font script="Olck" typeface="Nirmala UI"/>
+        <a:font script="Osma" typeface="Ebrima"/>
+        <a:font script="Phag" typeface="Phagspa"/>
+        <a:font script="Syrn" typeface="Estrangelo Edessa"/>
+        <a:font script="Syrj" typeface="Estrangelo Edessa"/>
+        <a:font script="Syre" typeface="Estrangelo Edessa"/>
+        <a:font script="Sora" typeface="Nirmala UI"/>
+        <a:font script="Tale" typeface="Microsoft Tai Le"/>
+        <a:font script="Talu" typeface="Microsoft New Tai Lue"/>
+        <a:font script="Tfng" typeface="Ebrima"/>
+      </a:minorFont>
+    </a:fontScheme>
+    <a:fmtScheme name="Office">
+      <a:fillStyleLst>
+        <a:solidFill>
+          <a:schemeClr val="phClr"/>
+        </a:solidFill>
+        <a:gradFill rotWithShape="1">
+          <a:gsLst>
+            <a:gs pos="0">
+              <a:schemeClr val="phClr">
+                <a:lumMod val="110000"/>
+                <a:satMod val="105000"/>
+                <a:tint val="67000"/>
+              </a:schemeClr>
+            </a:gs>
+            <a:gs pos="50000">
+              <a:schemeClr val="phClr">
+                <a:lumMod val="105000"/>
+                <a:satMod val="103000"/>
+                <a:tint val="73000"/>
+              </a:schemeClr>
+            </a:gs>
+            <a:gs pos="100000">
+              <a:schemeClr val="phClr">
+                <a:lumMod val="105000"/>
+                <a:satMod val="109000"/>
+                <a:tint val="81000"/>
+              </a:schemeClr>
+            </a:gs>
+          </a:gsLst>
+          <a:lin ang="5400000" scaled="0"/>
+        </a:gradFill>
+        <a:gradFill rotWithShape="1">
+          <a:gsLst>
+            <a:gs pos="0">
+              <a:schemeClr val="phClr">
+                <a:satMod val="103000"/>
+                <a:lumMod val="102000"/>
+                <a:tint val="94000"/>
+              </a:schemeClr>
+            </a:gs>
+            <a:gs pos="50000">
+              <a:schemeClr val="phClr">
+                <a:satMod val="110000"/>
+                <a:lumMod val="100000"/>
+                <a:shade val="100000"/>
+              </a:schemeClr>
+            </a:gs>
+            <a:gs pos="100000">
+              <a:schemeClr val="phClr">
+                <a:lumMod val="99000"/>
+                <a:satMod val="120000"/>
+                <a:shade val="78000"/>
+              </a:schemeClr>
+            </a:gs>
+          </a:gsLst>
+          <a:lin ang="5400000" scaled="0"/>
+        </a:gradFill>
+      </a:fillStyleLst>
+      <a:lnStyleLst>
+        <a:ln w="12700" cap="flat" cmpd="sng" algn="ctr">
+          <a:solidFill>
+            <a:schemeClr val="phClr"/>
+          </a:solidFill>
+          <a:prstDash val="solid"/>
+          <a:miter lim="800000"/>
+        </a:ln>
+        <a:ln w="19050" cap="flat" cmpd="sng" algn="ctr">
+          <a:solidFill>
+            <a:schemeClr val="phClr"/>
+          </a:solidFill>
+          <a:prstDash val="solid"/>
+          <a:miter lim="800000"/>
+        </a:ln>
+        <a:ln w="25400" cap="flat" cmpd="sng" algn="ctr">
+          <a:solidFill>
+            <a:schemeClr val="phClr"/>
+          </a:solidFill>
+          <a:prstDash val="solid"/>
+          <a:miter lim="800000"/>
+        </a:ln>
+      </a:lnStyleLst>
+      <a:effectStyleLst>
+        <a:effectStyle>
+          <a:effectLst/>
+        </a:effectStyle>
+        <a:effectStyle>
+          <a:effectLst/>
+        </a:effectStyle>
+        <a:effectStyle>
+          <a:effectLst>
+            <a:outerShdw blurRad="57150" dist="19050" dir="5400000" algn="ctr" rotWithShape="0">
+              <a:srgbClr val="000000">
+                <a:alpha val="63000"/>
+              </a:srgbClr>
+            </a:outerShdw>
+          </a:effectLst>
+        </a:effectStyle>
+      </a:effectStyleLst>
+      <a:bgFillStyleLst>
+        <a:solidFill>
+          <a:schemeClr val="phClr"/>
+        </a:solidFill>
+        <a:solidFill>
+          <a:schemeClr val="phClr">
+            <a:tint val="95000"/>
+            <a:satMod val="170000"/>
+          </a:schemeClr>
+        </a:solidFill>
+        <a:gradFill rotWithShape="1">
+          <a:gsLst>
+            <a:gs pos="0">
+              <a:schemeClr val="phClr">
+                <a:tint val="93000"/>
+                <a:satMod val="150000"/>
+                <a:shade val="98000"/>
+                <a:lumMod val="102000"/>
+              </a:schemeClr>
+            </a:gs>
+            <a:gs pos="50000">
+              <a:schemeClr val="phClr">
+                <a:tint val="98000"/>
+                <a:satMod val="130000"/>
+                <a:shade val="90000"/>
+                <a:lumMod val="103000"/>
+              </a:schemeClr>
+            </a:gs>
+            <a:gs pos="100000">
+              <a:schemeClr val="phClr">
+                <a:shade val="63000"/>
+                <a:satMod val="120000"/>
+              </a:schemeClr>
+            </a:gs>
+          </a:gsLst>
+          <a:lin ang="5400000" scaled="0"/>
+        </a:gradFill>
+      </a:bgFillStyleLst>
+    </a:fmtScheme>
+  </a:themeElements>
+  <a:objectDefaults>
+    <a:lnDef>
+      <a:spPr/>
+      <a:bodyPr/>
+      <a:lstStyle/>
+      <a:style>
+        <a:lnRef idx="2">
+          <a:schemeClr val="accent1"/>
+        </a:lnRef>
+        <a:fillRef idx="0">
+          <a:schemeClr val="accent1"/>
+        </a:fillRef>
+        <a:effectRef idx="1">
+          <a:schemeClr val="accent1"/>
+        </a:effectRef>
+        <a:fontRef idx="minor">
+          <a:schemeClr val="tx1"/>
+        </a:fontRef>
+      </a:style>
+    </a:lnDef>
+  </a:objectDefaults>
+  <a:extraClrSchemeLst/>
+  <a:extLst>
+    <a:ext uri="{05A4C25C-085E-4340-85A3-A5531E510DB2}">
+      <thm15:themeFamily xmlns:thm15="http://schemas.microsoft.com/office/thememl/2012/main" name="Office Theme" id="{2E142A2C-CD16-42D6-873A-C26D2A0506FA}" vid="{1BDDFF52-6CD6-40A5-AB3C-68EB2F1E4D0A}"/>
+    </a:ext>
+  </a:extLst>
+</a:theme>
 </file>
</xml_diff>